<commit_message>
feat: automate insertion of project architecture and classifier diagrams into presentation slides
</commit_message>
<xml_diff>
--- a/Medical_Specialty_Classification_Presentation.pptx
+++ b/Medical_Specialty_Classification_Presentation.pptx
@@ -7488,8 +7488,8 @@
         </p:nvSpPr>
         <p:spPr>
           <a:xfrm>
-            <a:off x="457200" y="1371600"/>
-            <a:ext cx="5440680" cy="4983480"/>
+            <a:off x="457200" y="1325880"/>
+            <a:ext cx="5440680" cy="5074920"/>
           </a:xfrm>
           <a:prstGeom prst="roundRect">
             <a:avLst/>
@@ -7533,8 +7533,8 @@
         </p:nvSpPr>
         <p:spPr>
           <a:xfrm>
-            <a:off x="594360" y="1508760"/>
-            <a:ext cx="5166360" cy="502920"/>
+            <a:off x="594360" y="1417320"/>
+            <a:ext cx="5166360" cy="384048"/>
           </a:xfrm>
           <a:prstGeom prst="roundRect">
             <a:avLst/>
@@ -7565,7 +7565,7 @@
           <a:lstStyle/>
           <a:p>
             <a:pPr algn="ctr">
-              <a:defRPr sz="1150" b="1">
+              <a:defRPr sz="1100" b="1">
                 <a:solidFill>
                   <a:srgbClr val="FFFFFF"/>
                 </a:solidFill>
@@ -7573,31 +7573,55 @@
               </a:defRPr>
             </a:pPr>
             <a:r>
-              <a:t>SVM (SUPPORT VECTOR MACHINE) ACTIVITY FLOW</a:t>
-            </a:r>
-          </a:p>
-        </p:txBody>
-      </p:sp>
-      <p:sp>
-        <p:nvSpPr>
-          <p:cNvPr id="9" name="Rounded Rectangle 8"/>
+              <a:t>SUPPORT VECTOR MACHINE (SVM) — ACTIVITY DIAGRAM</a:t>
+            </a:r>
+          </a:p>
+        </p:txBody>
+      </p:sp>
+      <p:pic>
+        <p:nvPicPr>
+          <p:cNvPr id="9" name="Picture 8" descr="svm.png"/>
+          <p:cNvPicPr>
+            <a:picLocks noChangeAspect="1"/>
+          </p:cNvPicPr>
+          <p:nvPr/>
+        </p:nvPicPr>
+        <p:blipFill>
+          <a:blip r:embed="rId3"/>
+          <a:stretch>
+            <a:fillRect/>
+          </a:stretch>
+        </p:blipFill>
+        <p:spPr>
+          <a:xfrm>
+            <a:off x="1892807" y="1874519"/>
+            <a:ext cx="2560320" cy="4437888"/>
+          </a:xfrm>
+          <a:prstGeom prst="rect">
+            <a:avLst/>
+          </a:prstGeom>
+        </p:spPr>
+      </p:pic>
+      <p:sp>
+        <p:nvSpPr>
+          <p:cNvPr id="10" name="Rounded Rectangle 9"/>
           <p:cNvSpPr/>
           <p:nvPr/>
         </p:nvSpPr>
         <p:spPr>
           <a:xfrm>
-            <a:off x="594360" y="2148840"/>
-            <a:ext cx="5166360" cy="594360"/>
+            <a:off x="6217920" y="1325880"/>
+            <a:ext cx="5486400" cy="5074920"/>
           </a:xfrm>
           <a:prstGeom prst="roundRect">
             <a:avLst/>
           </a:prstGeom>
           <a:solidFill>
-            <a:srgbClr val="F0FDFA"/>
+            <a:srgbClr val="FFFFFF"/>
           </a:solidFill>
-          <a:ln w="12700">
+          <a:ln w="19050">
             <a:solidFill>
-              <a:srgbClr val="99F6E4"/>
+              <a:srgbClr val="2563EB"/>
             </a:solidFill>
           </a:ln>
         </p:spPr>
@@ -7616,57 +7640,32 @@
           </a:fontRef>
         </p:style>
         <p:txBody>
-          <a:bodyPr rtlCol="0" anchor="ctr" wrap="square" lIns="109728" tIns="54864"/>
-          <a:lstStyle/>
-          <a:p>
-            <a:pPr algn="ctr">
-              <a:defRPr sz="1000" b="1">
-                <a:solidFill>
-                  <a:srgbClr val="0F766E"/>
-                </a:solidFill>
-                <a:latin typeface="Calibri"/>
-              </a:defRPr>
-            </a:pPr>
-            <a:r>
-              <a:t>1. High-Dimensional Input</a:t>
-            </a:r>
-          </a:p>
-          <a:p>
-            <a:pPr>
-              <a:defRPr sz="850" b="0">
-                <a:solidFill>
-                  <a:srgbClr val="334155"/>
-                </a:solidFill>
-                <a:latin typeface="Calibri"/>
-              </a:defRPr>
-            </a:pPr>
-            <a:r>
-              <a:t>Sparse TF-IDF feature vector x ∈ R^V representing clinical narrative vocabulary.</a:t>
-            </a:r>
-          </a:p>
-        </p:txBody>
-      </p:sp>
-      <p:sp>
-        <p:nvSpPr>
-          <p:cNvPr id="10" name="Rounded Rectangle 9"/>
+          <a:bodyPr rtlCol="0" anchor="ctr"/>
+          <a:lstStyle/>
+          <a:p>
+            <a:pPr algn="ctr"/>
+          </a:p>
+        </p:txBody>
+      </p:sp>
+      <p:sp>
+        <p:nvSpPr>
+          <p:cNvPr id="11" name="Rounded Rectangle 10"/>
           <p:cNvSpPr/>
           <p:nvPr/>
         </p:nvSpPr>
         <p:spPr>
           <a:xfrm>
-            <a:off x="594360" y="2852928"/>
-            <a:ext cx="5166360" cy="594360"/>
+            <a:off x="6355080" y="1417320"/>
+            <a:ext cx="5212080" cy="384048"/>
           </a:xfrm>
           <a:prstGeom prst="roundRect">
             <a:avLst/>
           </a:prstGeom>
           <a:solidFill>
-            <a:srgbClr val="F0FDFA"/>
+            <a:srgbClr val="2563EB"/>
           </a:solidFill>
-          <a:ln w="12700">
-            <a:solidFill>
-              <a:srgbClr val="99F6E4"/>
-            </a:solidFill>
+          <a:ln>
+            <a:noFill/>
           </a:ln>
         </p:spPr>
         <p:style>
@@ -7684,814 +7683,47 @@
           </a:fontRef>
         </p:style>
         <p:txBody>
-          <a:bodyPr rtlCol="0" anchor="ctr" wrap="square" lIns="109728" tIns="54864"/>
+          <a:bodyPr rtlCol="0" anchor="ctr"/>
           <a:lstStyle/>
           <a:p>
             <a:pPr algn="ctr">
-              <a:defRPr sz="1000" b="1">
-                <a:solidFill>
-                  <a:srgbClr val="0F766E"/>
+              <a:defRPr sz="1100" b="1">
+                <a:solidFill>
+                  <a:srgbClr val="FFFFFF"/>
                 </a:solidFill>
                 <a:latin typeface="Calibri"/>
               </a:defRPr>
             </a:pPr>
             <a:r>
-              <a:t>2. Linear Decision Mapping</a:t>
-            </a:r>
-          </a:p>
-          <a:p>
-            <a:pPr>
-              <a:defRPr sz="850" b="0">
-                <a:solidFill>
-                  <a:srgbClr val="334155"/>
-                </a:solidFill>
-                <a:latin typeface="Calibri"/>
-              </a:defRPr>
-            </a:pPr>
-            <a:r>
-              <a:t>Constructs decision hyperplane w·x + b = 0 in sparse high-dimensional term space.</a:t>
-            </a:r>
-          </a:p>
-        </p:txBody>
-      </p:sp>
-      <p:sp>
-        <p:nvSpPr>
-          <p:cNvPr id="11" name="Rounded Rectangle 10"/>
-          <p:cNvSpPr/>
-          <p:nvPr/>
-        </p:nvSpPr>
-        <p:spPr>
-          <a:xfrm>
-            <a:off x="594360" y="3557016"/>
-            <a:ext cx="5166360" cy="594360"/>
-          </a:xfrm>
-          <a:prstGeom prst="roundRect">
-            <a:avLst/>
-          </a:prstGeom>
-          <a:solidFill>
-            <a:srgbClr val="F0FDFA"/>
-          </a:solidFill>
-          <a:ln w="12700">
-            <a:solidFill>
-              <a:srgbClr val="99F6E4"/>
-            </a:solidFill>
-          </a:ln>
-        </p:spPr>
-        <p:style>
-          <a:lnRef idx="1">
-            <a:schemeClr val="accent1"/>
-          </a:lnRef>
-          <a:fillRef idx="3">
-            <a:schemeClr val="accent1"/>
-          </a:fillRef>
-          <a:effectRef idx="2">
-            <a:schemeClr val="accent1"/>
-          </a:effectRef>
-          <a:fontRef idx="minor">
-            <a:schemeClr val="lt1"/>
-          </a:fontRef>
-        </p:style>
-        <p:txBody>
-          <a:bodyPr rtlCol="0" anchor="ctr" wrap="square" lIns="109728" tIns="54864"/>
-          <a:lstStyle/>
-          <a:p>
-            <a:pPr algn="ctr">
-              <a:defRPr sz="1000" b="1">
-                <a:solidFill>
-                  <a:srgbClr val="0F766E"/>
-                </a:solidFill>
-                <a:latin typeface="Calibri"/>
-              </a:defRPr>
-            </a:pPr>
-            <a:r>
-              <a:t>3. Maximum Margin Optimization</a:t>
-            </a:r>
-          </a:p>
-          <a:p>
-            <a:pPr>
-              <a:defRPr sz="850" b="0">
-                <a:solidFill>
-                  <a:srgbClr val="334155"/>
-                </a:solidFill>
-                <a:latin typeface="Calibri"/>
-              </a:defRPr>
-            </a:pPr>
-            <a:r>
-              <a:t>Solves quadratic program: min 1/2 ||w||² subject to y_i(w·x_i + b) ≥ 1 - ξ_i.</a:t>
-            </a:r>
-          </a:p>
-        </p:txBody>
-      </p:sp>
-      <p:sp>
-        <p:nvSpPr>
-          <p:cNvPr id="12" name="Rounded Rectangle 11"/>
-          <p:cNvSpPr/>
-          <p:nvPr/>
-        </p:nvSpPr>
-        <p:spPr>
-          <a:xfrm>
-            <a:off x="594360" y="4261104"/>
-            <a:ext cx="5166360" cy="594360"/>
-          </a:xfrm>
-          <a:prstGeom prst="roundRect">
-            <a:avLst/>
-          </a:prstGeom>
-          <a:solidFill>
-            <a:srgbClr val="F0FDFA"/>
-          </a:solidFill>
-          <a:ln w="12700">
-            <a:solidFill>
-              <a:srgbClr val="99F6E4"/>
-            </a:solidFill>
-          </a:ln>
-        </p:spPr>
-        <p:style>
-          <a:lnRef idx="1">
-            <a:schemeClr val="accent1"/>
-          </a:lnRef>
-          <a:fillRef idx="3">
-            <a:schemeClr val="accent1"/>
-          </a:fillRef>
-          <a:effectRef idx="2">
-            <a:schemeClr val="accent1"/>
-          </a:effectRef>
-          <a:fontRef idx="minor">
-            <a:schemeClr val="lt1"/>
-          </a:fontRef>
-        </p:style>
-        <p:txBody>
-          <a:bodyPr rtlCol="0" anchor="ctr" wrap="square" lIns="109728" tIns="54864"/>
-          <a:lstStyle/>
-          <a:p>
-            <a:pPr algn="ctr">
-              <a:defRPr sz="1000" b="1">
-                <a:solidFill>
-                  <a:srgbClr val="0F766E"/>
-                </a:solidFill>
-                <a:latin typeface="Calibri"/>
-              </a:defRPr>
-            </a:pPr>
-            <a:r>
-              <a:t>4. Support Vector Identification</a:t>
-            </a:r>
-          </a:p>
-          <a:p>
-            <a:pPr>
-              <a:defRPr sz="850" b="0">
-                <a:solidFill>
-                  <a:srgbClr val="334155"/>
-                </a:solidFill>
-                <a:latin typeface="Calibri"/>
-              </a:defRPr>
-            </a:pPr>
-            <a:r>
-              <a:t>Identifies critical borderline transcripts that define category separation margins.</a:t>
-            </a:r>
-          </a:p>
-        </p:txBody>
-      </p:sp>
-      <p:sp>
-        <p:nvSpPr>
-          <p:cNvPr id="13" name="Rounded Rectangle 12"/>
-          <p:cNvSpPr/>
-          <p:nvPr/>
-        </p:nvSpPr>
-        <p:spPr>
-          <a:xfrm>
-            <a:off x="594360" y="4965192"/>
-            <a:ext cx="5166360" cy="594360"/>
-          </a:xfrm>
-          <a:prstGeom prst="roundRect">
-            <a:avLst/>
-          </a:prstGeom>
-          <a:solidFill>
-            <a:srgbClr val="F0FDFA"/>
-          </a:solidFill>
-          <a:ln w="12700">
-            <a:solidFill>
-              <a:srgbClr val="99F6E4"/>
-            </a:solidFill>
-          </a:ln>
-        </p:spPr>
-        <p:style>
-          <a:lnRef idx="1">
-            <a:schemeClr val="accent1"/>
-          </a:lnRef>
-          <a:fillRef idx="3">
-            <a:schemeClr val="accent1"/>
-          </a:fillRef>
-          <a:effectRef idx="2">
-            <a:schemeClr val="accent1"/>
-          </a:effectRef>
-          <a:fontRef idx="minor">
-            <a:schemeClr val="lt1"/>
-          </a:fontRef>
-        </p:style>
-        <p:txBody>
-          <a:bodyPr rtlCol="0" anchor="ctr" wrap="square" lIns="109728" tIns="54864"/>
-          <a:lstStyle/>
-          <a:p>
-            <a:pPr algn="ctr">
-              <a:defRPr sz="1000" b="1">
-                <a:solidFill>
-                  <a:srgbClr val="0F766E"/>
-                </a:solidFill>
-                <a:latin typeface="Calibri"/>
-              </a:defRPr>
-            </a:pPr>
-            <a:r>
-              <a:t>5. Platt Probability Scaling</a:t>
-            </a:r>
-          </a:p>
-          <a:p>
-            <a:pPr>
-              <a:defRPr sz="850" b="0">
-                <a:solidFill>
-                  <a:srgbClr val="334155"/>
-                </a:solidFill>
-                <a:latin typeface="Calibri"/>
-              </a:defRPr>
-            </a:pPr>
-            <a:r>
-              <a:t>Calibrates decision distances via sigmoid fitting: P(c|x) = 1 / (1 + exp(A·f(x) + B)).</a:t>
-            </a:r>
-          </a:p>
-        </p:txBody>
-      </p:sp>
-      <p:sp>
-        <p:nvSpPr>
-          <p:cNvPr id="14" name="Rounded Rectangle 13"/>
-          <p:cNvSpPr/>
-          <p:nvPr/>
-        </p:nvSpPr>
-        <p:spPr>
-          <a:xfrm>
-            <a:off x="594360" y="5669280"/>
-            <a:ext cx="5166360" cy="594360"/>
-          </a:xfrm>
-          <a:prstGeom prst="roundRect">
-            <a:avLst/>
-          </a:prstGeom>
-          <a:solidFill>
-            <a:srgbClr val="F0FDFA"/>
-          </a:solidFill>
-          <a:ln w="12700">
-            <a:solidFill>
-              <a:srgbClr val="99F6E4"/>
-            </a:solidFill>
-          </a:ln>
-        </p:spPr>
-        <p:style>
-          <a:lnRef idx="1">
-            <a:schemeClr val="accent1"/>
-          </a:lnRef>
-          <a:fillRef idx="3">
-            <a:schemeClr val="accent1"/>
-          </a:fillRef>
-          <a:effectRef idx="2">
-            <a:schemeClr val="accent1"/>
-          </a:effectRef>
-          <a:fontRef idx="minor">
-            <a:schemeClr val="lt1"/>
-          </a:fontRef>
-        </p:style>
-        <p:txBody>
-          <a:bodyPr rtlCol="0" anchor="ctr" wrap="square" lIns="109728" tIns="54864"/>
-          <a:lstStyle/>
-          <a:p>
-            <a:pPr algn="ctr">
-              <a:defRPr sz="1000" b="1">
-                <a:solidFill>
-                  <a:srgbClr val="0F766E"/>
-                </a:solidFill>
-                <a:latin typeface="Calibri"/>
-              </a:defRPr>
-            </a:pPr>
-            <a:r>
-              <a:t>6. Class Probability Output</a:t>
-            </a:r>
-          </a:p>
-          <a:p>
-            <a:pPr>
-              <a:defRPr sz="850" b="0">
-                <a:solidFill>
-                  <a:srgbClr val="334155"/>
-                </a:solidFill>
-                <a:latin typeface="Calibri"/>
-              </a:defRPr>
-            </a:pPr>
-            <a:r>
-              <a:t>Outputs calibrated probability distribution across all 40 medical specialty categories.</a:t>
-            </a:r>
-          </a:p>
-        </p:txBody>
-      </p:sp>
-      <p:sp>
-        <p:nvSpPr>
-          <p:cNvPr id="15" name="Rounded Rectangle 14"/>
-          <p:cNvSpPr/>
-          <p:nvPr/>
-        </p:nvSpPr>
-        <p:spPr>
-          <a:xfrm>
-            <a:off x="6217920" y="1371600"/>
-            <a:ext cx="5486400" cy="4983480"/>
-          </a:xfrm>
-          <a:prstGeom prst="roundRect">
-            <a:avLst/>
-          </a:prstGeom>
-          <a:solidFill>
-            <a:srgbClr val="FFFFFF"/>
-          </a:solidFill>
-          <a:ln w="19050">
-            <a:solidFill>
-              <a:srgbClr val="2563EB"/>
-            </a:solidFill>
-          </a:ln>
-        </p:spPr>
-        <p:style>
-          <a:lnRef idx="1">
-            <a:schemeClr val="accent1"/>
-          </a:lnRef>
-          <a:fillRef idx="3">
-            <a:schemeClr val="accent1"/>
-          </a:fillRef>
-          <a:effectRef idx="2">
-            <a:schemeClr val="accent1"/>
-          </a:effectRef>
-          <a:fontRef idx="minor">
-            <a:schemeClr val="lt1"/>
-          </a:fontRef>
-        </p:style>
-        <p:txBody>
-          <a:bodyPr rtlCol="0" anchor="ctr"/>
-          <a:lstStyle/>
-          <a:p>
-            <a:pPr algn="ctr"/>
-          </a:p>
-        </p:txBody>
-      </p:sp>
-      <p:sp>
-        <p:nvSpPr>
-          <p:cNvPr id="16" name="Rounded Rectangle 15"/>
-          <p:cNvSpPr/>
-          <p:nvPr/>
-        </p:nvSpPr>
-        <p:spPr>
-          <a:xfrm>
-            <a:off x="6355080" y="1508760"/>
-            <a:ext cx="5212080" cy="502920"/>
-          </a:xfrm>
-          <a:prstGeom prst="roundRect">
-            <a:avLst/>
-          </a:prstGeom>
-          <a:solidFill>
-            <a:srgbClr val="2563EB"/>
-          </a:solidFill>
-          <a:ln>
-            <a:noFill/>
-          </a:ln>
-        </p:spPr>
-        <p:style>
-          <a:lnRef idx="1">
-            <a:schemeClr val="accent1"/>
-          </a:lnRef>
-          <a:fillRef idx="3">
-            <a:schemeClr val="accent1"/>
-          </a:fillRef>
-          <a:effectRef idx="2">
-            <a:schemeClr val="accent1"/>
-          </a:effectRef>
-          <a:fontRef idx="minor">
-            <a:schemeClr val="lt1"/>
-          </a:fontRef>
-        </p:style>
-        <p:txBody>
-          <a:bodyPr rtlCol="0" anchor="ctr"/>
-          <a:lstStyle/>
-          <a:p>
-            <a:pPr algn="ctr">
-              <a:defRPr sz="1150" b="1">
-                <a:solidFill>
-                  <a:srgbClr val="FFFFFF"/>
-                </a:solidFill>
-                <a:latin typeface="Calibri"/>
-              </a:defRPr>
-            </a:pPr>
-            <a:r>
-              <a:t>MULTINOMIAL NAIVE BAYES ACTIVITY FLOW</a:t>
-            </a:r>
-          </a:p>
-        </p:txBody>
-      </p:sp>
-      <p:sp>
-        <p:nvSpPr>
-          <p:cNvPr id="17" name="Rounded Rectangle 16"/>
-          <p:cNvSpPr/>
-          <p:nvPr/>
-        </p:nvSpPr>
-        <p:spPr>
-          <a:xfrm>
-            <a:off x="6355080" y="2148840"/>
-            <a:ext cx="5212080" cy="594360"/>
-          </a:xfrm>
-          <a:prstGeom prst="roundRect">
-            <a:avLst/>
-          </a:prstGeom>
-          <a:solidFill>
-            <a:srgbClr val="EFF6FF"/>
-          </a:solidFill>
-          <a:ln w="12700">
-            <a:solidFill>
-              <a:srgbClr val="BFDBFE"/>
-            </a:solidFill>
-          </a:ln>
-        </p:spPr>
-        <p:style>
-          <a:lnRef idx="1">
-            <a:schemeClr val="accent1"/>
-          </a:lnRef>
-          <a:fillRef idx="3">
-            <a:schemeClr val="accent1"/>
-          </a:fillRef>
-          <a:effectRef idx="2">
-            <a:schemeClr val="accent1"/>
-          </a:effectRef>
-          <a:fontRef idx="minor">
-            <a:schemeClr val="lt1"/>
-          </a:fontRef>
-        </p:style>
-        <p:txBody>
-          <a:bodyPr rtlCol="0" anchor="ctr" wrap="square" lIns="109728" tIns="54864"/>
-          <a:lstStyle/>
-          <a:p>
-            <a:pPr algn="ctr">
-              <a:defRPr sz="1000" b="1">
-                <a:solidFill>
-                  <a:srgbClr val="1E40AF"/>
-                </a:solidFill>
-                <a:latin typeface="Calibri"/>
-              </a:defRPr>
-            </a:pPr>
-            <a:r>
-              <a:t>1. Term Frequency Vector Input</a:t>
-            </a:r>
-          </a:p>
-          <a:p>
-            <a:pPr>
-              <a:defRPr sz="850" b="0">
-                <a:solidFill>
-                  <a:srgbClr val="334155"/>
-                </a:solidFill>
-                <a:latin typeface="Calibri"/>
-              </a:defRPr>
-            </a:pPr>
-            <a:r>
-              <a:t>Vector of clinical token counts and TF-IDF weights for each vocabulary term t_k.</a:t>
-            </a:r>
-          </a:p>
-        </p:txBody>
-      </p:sp>
-      <p:sp>
-        <p:nvSpPr>
-          <p:cNvPr id="18" name="Rounded Rectangle 17"/>
-          <p:cNvSpPr/>
-          <p:nvPr/>
-        </p:nvSpPr>
-        <p:spPr>
-          <a:xfrm>
-            <a:off x="6355080" y="2852928"/>
-            <a:ext cx="5212080" cy="594360"/>
-          </a:xfrm>
-          <a:prstGeom prst="roundRect">
-            <a:avLst/>
-          </a:prstGeom>
-          <a:solidFill>
-            <a:srgbClr val="EFF6FF"/>
-          </a:solidFill>
-          <a:ln w="12700">
-            <a:solidFill>
-              <a:srgbClr val="BFDBFE"/>
-            </a:solidFill>
-          </a:ln>
-        </p:spPr>
-        <p:style>
-          <a:lnRef idx="1">
-            <a:schemeClr val="accent1"/>
-          </a:lnRef>
-          <a:fillRef idx="3">
-            <a:schemeClr val="accent1"/>
-          </a:fillRef>
-          <a:effectRef idx="2">
-            <a:schemeClr val="accent1"/>
-          </a:effectRef>
-          <a:fontRef idx="minor">
-            <a:schemeClr val="lt1"/>
-          </a:fontRef>
-        </p:style>
-        <p:txBody>
-          <a:bodyPr rtlCol="0" anchor="ctr" wrap="square" lIns="109728" tIns="54864"/>
-          <a:lstStyle/>
-          <a:p>
-            <a:pPr algn="ctr">
-              <a:defRPr sz="1000" b="1">
-                <a:solidFill>
-                  <a:srgbClr val="1E40AF"/>
-                </a:solidFill>
-                <a:latin typeface="Calibri"/>
-              </a:defRPr>
-            </a:pPr>
-            <a:r>
-              <a:t>2. Prior Class Probability P(c)</a:t>
-            </a:r>
-          </a:p>
-          <a:p>
-            <a:pPr>
-              <a:defRPr sz="850" b="0">
-                <a:solidFill>
-                  <a:srgbClr val="334155"/>
-                </a:solidFill>
-                <a:latin typeface="Calibri"/>
-              </a:defRPr>
-            </a:pPr>
-            <a:r>
-              <a:t>Estimates empirical prior for each specialty: P(c) = N_c / N_total from training data.</a:t>
-            </a:r>
-          </a:p>
-        </p:txBody>
-      </p:sp>
-      <p:sp>
-        <p:nvSpPr>
-          <p:cNvPr id="19" name="Rounded Rectangle 18"/>
-          <p:cNvSpPr/>
-          <p:nvPr/>
-        </p:nvSpPr>
-        <p:spPr>
-          <a:xfrm>
-            <a:off x="6355080" y="3557016"/>
-            <a:ext cx="5212080" cy="594360"/>
-          </a:xfrm>
-          <a:prstGeom prst="roundRect">
-            <a:avLst/>
-          </a:prstGeom>
-          <a:solidFill>
-            <a:srgbClr val="EFF6FF"/>
-          </a:solidFill>
-          <a:ln w="12700">
-            <a:solidFill>
-              <a:srgbClr val="BFDBFE"/>
-            </a:solidFill>
-          </a:ln>
-        </p:spPr>
-        <p:style>
-          <a:lnRef idx="1">
-            <a:schemeClr val="accent1"/>
-          </a:lnRef>
-          <a:fillRef idx="3">
-            <a:schemeClr val="accent1"/>
-          </a:fillRef>
-          <a:effectRef idx="2">
-            <a:schemeClr val="accent1"/>
-          </a:effectRef>
-          <a:fontRef idx="minor">
-            <a:schemeClr val="lt1"/>
-          </a:fontRef>
-        </p:style>
-        <p:txBody>
-          <a:bodyPr rtlCol="0" anchor="ctr" wrap="square" lIns="109728" tIns="54864"/>
-          <a:lstStyle/>
-          <a:p>
-            <a:pPr algn="ctr">
-              <a:defRPr sz="1000" b="1">
-                <a:solidFill>
-                  <a:srgbClr val="1E40AF"/>
-                </a:solidFill>
-                <a:latin typeface="Calibri"/>
-              </a:defRPr>
-            </a:pPr>
-            <a:r>
-              <a:t>3. Feature Likelihood with Smoothing</a:t>
-            </a:r>
-          </a:p>
-          <a:p>
-            <a:pPr>
-              <a:defRPr sz="850" b="0">
-                <a:solidFill>
-                  <a:srgbClr val="334155"/>
-                </a:solidFill>
-                <a:latin typeface="Calibri"/>
-              </a:defRPr>
-            </a:pPr>
-            <a:r>
-              <a:t>Calculates P(t|c) = (count(t,c) + α) / (Σ count(w,c) + α·|V|) using Laplace smoothing (α=1).</a:t>
-            </a:r>
-          </a:p>
-        </p:txBody>
-      </p:sp>
-      <p:sp>
-        <p:nvSpPr>
-          <p:cNvPr id="20" name="Rounded Rectangle 19"/>
-          <p:cNvSpPr/>
-          <p:nvPr/>
-        </p:nvSpPr>
-        <p:spPr>
-          <a:xfrm>
-            <a:off x="6355080" y="4261104"/>
-            <a:ext cx="5212080" cy="594360"/>
-          </a:xfrm>
-          <a:prstGeom prst="roundRect">
-            <a:avLst/>
-          </a:prstGeom>
-          <a:solidFill>
-            <a:srgbClr val="EFF6FF"/>
-          </a:solidFill>
-          <a:ln w="12700">
-            <a:solidFill>
-              <a:srgbClr val="BFDBFE"/>
-            </a:solidFill>
-          </a:ln>
-        </p:spPr>
-        <p:style>
-          <a:lnRef idx="1">
-            <a:schemeClr val="accent1"/>
-          </a:lnRef>
-          <a:fillRef idx="3">
-            <a:schemeClr val="accent1"/>
-          </a:fillRef>
-          <a:effectRef idx="2">
-            <a:schemeClr val="accent1"/>
-          </a:effectRef>
-          <a:fontRef idx="minor">
-            <a:schemeClr val="lt1"/>
-          </a:fontRef>
-        </p:style>
-        <p:txBody>
-          <a:bodyPr rtlCol="0" anchor="ctr" wrap="square" lIns="109728" tIns="54864"/>
-          <a:lstStyle/>
-          <a:p>
-            <a:pPr algn="ctr">
-              <a:defRPr sz="1000" b="1">
-                <a:solidFill>
-                  <a:srgbClr val="1E40AF"/>
-                </a:solidFill>
-                <a:latin typeface="Calibri"/>
-              </a:defRPr>
-            </a:pPr>
-            <a:r>
-              <a:t>4. Log Posterior Accumulation</a:t>
-            </a:r>
-          </a:p>
-          <a:p>
-            <a:pPr>
-              <a:defRPr sz="850" b="0">
-                <a:solidFill>
-                  <a:srgbClr val="334155"/>
-                </a:solidFill>
-                <a:latin typeface="Calibri"/>
-              </a:defRPr>
-            </a:pPr>
-            <a:r>
-              <a:t>Computes log P(c|d) = log P(c) + Σ f_t · log P(t|c) to prevent floating-point underflow.</a:t>
-            </a:r>
-          </a:p>
-        </p:txBody>
-      </p:sp>
-      <p:sp>
-        <p:nvSpPr>
-          <p:cNvPr id="21" name="Rounded Rectangle 20"/>
-          <p:cNvSpPr/>
-          <p:nvPr/>
-        </p:nvSpPr>
-        <p:spPr>
-          <a:xfrm>
-            <a:off x="6355080" y="4965192"/>
-            <a:ext cx="5212080" cy="594360"/>
-          </a:xfrm>
-          <a:prstGeom prst="roundRect">
-            <a:avLst/>
-          </a:prstGeom>
-          <a:solidFill>
-            <a:srgbClr val="EFF6FF"/>
-          </a:solidFill>
-          <a:ln w="12700">
-            <a:solidFill>
-              <a:srgbClr val="BFDBFE"/>
-            </a:solidFill>
-          </a:ln>
-        </p:spPr>
-        <p:style>
-          <a:lnRef idx="1">
-            <a:schemeClr val="accent1"/>
-          </a:lnRef>
-          <a:fillRef idx="3">
-            <a:schemeClr val="accent1"/>
-          </a:fillRef>
-          <a:effectRef idx="2">
-            <a:schemeClr val="accent1"/>
-          </a:effectRef>
-          <a:fontRef idx="minor">
-            <a:schemeClr val="lt1"/>
-          </a:fontRef>
-        </p:style>
-        <p:txBody>
-          <a:bodyPr rtlCol="0" anchor="ctr" wrap="square" lIns="109728" tIns="54864"/>
-          <a:lstStyle/>
-          <a:p>
-            <a:pPr algn="ctr">
-              <a:defRPr sz="1000" b="1">
-                <a:solidFill>
-                  <a:srgbClr val="1E40AF"/>
-                </a:solidFill>
-                <a:latin typeface="Calibri"/>
-              </a:defRPr>
-            </a:pPr>
-            <a:r>
-              <a:t>5. Softmax Normalization</a:t>
-            </a:r>
-          </a:p>
-          <a:p>
-            <a:pPr>
-              <a:defRPr sz="850" b="0">
-                <a:solidFill>
-                  <a:srgbClr val="334155"/>
-                </a:solidFill>
-                <a:latin typeface="Calibri"/>
-              </a:defRPr>
-            </a:pPr>
-            <a:r>
-              <a:t>Converts log-likelihoods into normalized probability distribution: P(c|d) = exp(s_c)/Σ exp(s_k).</a:t>
-            </a:r>
-          </a:p>
-        </p:txBody>
-      </p:sp>
-      <p:sp>
-        <p:nvSpPr>
-          <p:cNvPr id="22" name="Rounded Rectangle 21"/>
-          <p:cNvSpPr/>
-          <p:nvPr/>
-        </p:nvSpPr>
-        <p:spPr>
-          <a:xfrm>
-            <a:off x="6355080" y="5669280"/>
-            <a:ext cx="5212080" cy="594360"/>
-          </a:xfrm>
-          <a:prstGeom prst="roundRect">
-            <a:avLst/>
-          </a:prstGeom>
-          <a:solidFill>
-            <a:srgbClr val="EFF6FF"/>
-          </a:solidFill>
-          <a:ln w="12700">
-            <a:solidFill>
-              <a:srgbClr val="BFDBFE"/>
-            </a:solidFill>
-          </a:ln>
-        </p:spPr>
-        <p:style>
-          <a:lnRef idx="1">
-            <a:schemeClr val="accent1"/>
-          </a:lnRef>
-          <a:fillRef idx="3">
-            <a:schemeClr val="accent1"/>
-          </a:fillRef>
-          <a:effectRef idx="2">
-            <a:schemeClr val="accent1"/>
-          </a:effectRef>
-          <a:fontRef idx="minor">
-            <a:schemeClr val="lt1"/>
-          </a:fontRef>
-        </p:style>
-        <p:txBody>
-          <a:bodyPr rtlCol="0" anchor="ctr" wrap="square" lIns="109728" tIns="54864"/>
-          <a:lstStyle/>
-          <a:p>
-            <a:pPr algn="ctr">
-              <a:defRPr sz="1000" b="1">
-                <a:solidFill>
-                  <a:srgbClr val="1E40AF"/>
-                </a:solidFill>
-                <a:latin typeface="Calibri"/>
-              </a:defRPr>
-            </a:pPr>
-            <a:r>
-              <a:t>6. Class Probability Output</a:t>
-            </a:r>
-          </a:p>
-          <a:p>
-            <a:pPr>
-              <a:defRPr sz="850" b="0">
-                <a:solidFill>
-                  <a:srgbClr val="334155"/>
-                </a:solidFill>
-                <a:latin typeface="Calibri"/>
-              </a:defRPr>
-            </a:pPr>
-            <a:r>
-              <a:t>Generates probabilistic score distribution over 40 categories for ensemble soft voting.</a:t>
-            </a:r>
-          </a:p>
-        </p:txBody>
-      </p:sp>
+              <a:t>MULTINOMIAL NAIVE BAYES (MNB) — ACTIVITY DIAGRAM</a:t>
+            </a:r>
+          </a:p>
+        </p:txBody>
+      </p:sp>
+      <p:pic>
+        <p:nvPicPr>
+          <p:cNvPr id="12" name="Picture 11" descr="mnb.png"/>
+          <p:cNvPicPr>
+            <a:picLocks noChangeAspect="1"/>
+          </p:cNvPicPr>
+          <p:nvPr/>
+        </p:nvPicPr>
+        <p:blipFill>
+          <a:blip r:embed="rId4"/>
+          <a:stretch>
+            <a:fillRect/>
+          </a:stretch>
+        </p:blipFill>
+        <p:spPr>
+          <a:xfrm>
+            <a:off x="7379208" y="1920240"/>
+            <a:ext cx="3154680" cy="4339609"/>
+          </a:xfrm>
+          <a:prstGeom prst="rect">
+            <a:avLst/>
+          </a:prstGeom>
+        </p:spPr>
+      </p:pic>
     </p:spTree>
   </p:cSld>
   <p:clrMapOvr>
@@ -8729,8 +7961,8 @@
         </p:nvSpPr>
         <p:spPr>
           <a:xfrm>
-            <a:off x="457200" y="1371600"/>
-            <a:ext cx="5440680" cy="4983480"/>
+            <a:off x="457200" y="1325880"/>
+            <a:ext cx="5440680" cy="5074920"/>
           </a:xfrm>
           <a:prstGeom prst="roundRect">
             <a:avLst/>
@@ -8774,8 +8006,8 @@
         </p:nvSpPr>
         <p:spPr>
           <a:xfrm>
-            <a:off x="594360" y="1508760"/>
-            <a:ext cx="5166360" cy="502920"/>
+            <a:off x="594360" y="1417320"/>
+            <a:ext cx="5166360" cy="384048"/>
           </a:xfrm>
           <a:prstGeom prst="roundRect">
             <a:avLst/>
@@ -8806,7 +8038,7 @@
           <a:lstStyle/>
           <a:p>
             <a:pPr algn="ctr">
-              <a:defRPr sz="1150" b="1">
+              <a:defRPr sz="1100" b="1">
                 <a:solidFill>
                   <a:srgbClr val="FFFFFF"/>
                 </a:solidFill>
@@ -8814,31 +8046,55 @@
               </a:defRPr>
             </a:pPr>
             <a:r>
-              <a:t>RANDOM FOREST (RF) ACTIVITY FLOW</a:t>
-            </a:r>
-          </a:p>
-        </p:txBody>
-      </p:sp>
-      <p:sp>
-        <p:nvSpPr>
-          <p:cNvPr id="9" name="Rounded Rectangle 8"/>
+              <a:t>RANDOM FOREST (RF) — ACTIVITY DIAGRAM</a:t>
+            </a:r>
+          </a:p>
+        </p:txBody>
+      </p:sp>
+      <p:pic>
+        <p:nvPicPr>
+          <p:cNvPr id="9" name="Picture 8" descr="rf.png"/>
+          <p:cNvPicPr>
+            <a:picLocks noChangeAspect="1"/>
+          </p:cNvPicPr>
+          <p:nvPr/>
+        </p:nvPicPr>
+        <p:blipFill>
+          <a:blip r:embed="rId3"/>
+          <a:stretch>
+            <a:fillRect/>
+          </a:stretch>
+        </p:blipFill>
+        <p:spPr>
+          <a:xfrm>
+            <a:off x="1828800" y="1874519"/>
+            <a:ext cx="2697480" cy="4339946"/>
+          </a:xfrm>
+          <a:prstGeom prst="rect">
+            <a:avLst/>
+          </a:prstGeom>
+        </p:spPr>
+      </p:pic>
+      <p:sp>
+        <p:nvSpPr>
+          <p:cNvPr id="10" name="Rounded Rectangle 9"/>
           <p:cNvSpPr/>
           <p:nvPr/>
         </p:nvSpPr>
         <p:spPr>
           <a:xfrm>
-            <a:off x="594360" y="2148840"/>
-            <a:ext cx="5166360" cy="594360"/>
+            <a:off x="6217920" y="1325880"/>
+            <a:ext cx="5486400" cy="5074920"/>
           </a:xfrm>
           <a:prstGeom prst="roundRect">
             <a:avLst/>
           </a:prstGeom>
           <a:solidFill>
-            <a:srgbClr val="F0FDF4"/>
+            <a:srgbClr val="FFFFFF"/>
           </a:solidFill>
-          <a:ln w="12700">
+          <a:ln w="19050">
             <a:solidFill>
-              <a:srgbClr val="BBF7D0"/>
+              <a:srgbClr val="9333EA"/>
             </a:solidFill>
           </a:ln>
         </p:spPr>
@@ -8857,57 +8113,32 @@
           </a:fontRef>
         </p:style>
         <p:txBody>
-          <a:bodyPr rtlCol="0" anchor="ctr" wrap="square" lIns="109728" tIns="54864"/>
-          <a:lstStyle/>
-          <a:p>
-            <a:pPr algn="ctr">
-              <a:defRPr sz="1000" b="1">
-                <a:solidFill>
-                  <a:srgbClr val="15803D"/>
-                </a:solidFill>
-                <a:latin typeface="Calibri"/>
-              </a:defRPr>
-            </a:pPr>
-            <a:r>
-              <a:t>1. Dataset &amp; Feature Matrix Input</a:t>
-            </a:r>
-          </a:p>
-          <a:p>
-            <a:pPr>
-              <a:defRPr sz="850" b="0">
-                <a:solidFill>
-                  <a:srgbClr val="334155"/>
-                </a:solidFill>
-                <a:latin typeface="Calibri"/>
-              </a:defRPr>
-            </a:pPr>
-            <a:r>
-              <a:t>Receives training matrix X (TF-IDF features) and multi-class labels Y (40 classes).</a:t>
-            </a:r>
-          </a:p>
-        </p:txBody>
-      </p:sp>
-      <p:sp>
-        <p:nvSpPr>
-          <p:cNvPr id="10" name="Rounded Rectangle 9"/>
+          <a:bodyPr rtlCol="0" anchor="ctr"/>
+          <a:lstStyle/>
+          <a:p>
+            <a:pPr algn="ctr"/>
+          </a:p>
+        </p:txBody>
+      </p:sp>
+      <p:sp>
+        <p:nvSpPr>
+          <p:cNvPr id="11" name="Rounded Rectangle 10"/>
           <p:cNvSpPr/>
           <p:nvPr/>
         </p:nvSpPr>
         <p:spPr>
           <a:xfrm>
-            <a:off x="594360" y="2852928"/>
-            <a:ext cx="5166360" cy="594360"/>
+            <a:off x="6355080" y="1417320"/>
+            <a:ext cx="5212080" cy="384048"/>
           </a:xfrm>
           <a:prstGeom prst="roundRect">
             <a:avLst/>
           </a:prstGeom>
           <a:solidFill>
-            <a:srgbClr val="F0FDF4"/>
+            <a:srgbClr val="9333EA"/>
           </a:solidFill>
-          <a:ln w="12700">
-            <a:solidFill>
-              <a:srgbClr val="BBF7D0"/>
-            </a:solidFill>
+          <a:ln>
+            <a:noFill/>
           </a:ln>
         </p:spPr>
         <p:style>
@@ -8925,814 +8156,47 @@
           </a:fontRef>
         </p:style>
         <p:txBody>
-          <a:bodyPr rtlCol="0" anchor="ctr" wrap="square" lIns="109728" tIns="54864"/>
+          <a:bodyPr rtlCol="0" anchor="ctr"/>
           <a:lstStyle/>
           <a:p>
             <a:pPr algn="ctr">
-              <a:defRPr sz="1000" b="1">
-                <a:solidFill>
-                  <a:srgbClr val="15803D"/>
+              <a:defRPr sz="1100" b="1">
+                <a:solidFill>
+                  <a:srgbClr val="FFFFFF"/>
                 </a:solidFill>
                 <a:latin typeface="Calibri"/>
               </a:defRPr>
             </a:pPr>
             <a:r>
-              <a:t>2. Bootstrap Sampling (Bagging)</a:t>
-            </a:r>
-          </a:p>
-          <a:p>
-            <a:pPr>
-              <a:defRPr sz="850" b="0">
-                <a:solidFill>
-                  <a:srgbClr val="334155"/>
-                </a:solidFill>
-                <a:latin typeface="Calibri"/>
-              </a:defRPr>
-            </a:pPr>
-            <a:r>
-              <a:t>Generates B bootstrap sample sets by sampling rows with replacement to induce diversity.</a:t>
-            </a:r>
-          </a:p>
-        </p:txBody>
-      </p:sp>
-      <p:sp>
-        <p:nvSpPr>
-          <p:cNvPr id="11" name="Rounded Rectangle 10"/>
-          <p:cNvSpPr/>
-          <p:nvPr/>
-        </p:nvSpPr>
-        <p:spPr>
-          <a:xfrm>
-            <a:off x="594360" y="3557016"/>
-            <a:ext cx="5166360" cy="594360"/>
-          </a:xfrm>
-          <a:prstGeom prst="roundRect">
-            <a:avLst/>
-          </a:prstGeom>
-          <a:solidFill>
-            <a:srgbClr val="F0FDF4"/>
-          </a:solidFill>
-          <a:ln w="12700">
-            <a:solidFill>
-              <a:srgbClr val="BBF7D0"/>
-            </a:solidFill>
-          </a:ln>
-        </p:spPr>
-        <p:style>
-          <a:lnRef idx="1">
-            <a:schemeClr val="accent1"/>
-          </a:lnRef>
-          <a:fillRef idx="3">
-            <a:schemeClr val="accent1"/>
-          </a:fillRef>
-          <a:effectRef idx="2">
-            <a:schemeClr val="accent1"/>
-          </a:effectRef>
-          <a:fontRef idx="minor">
-            <a:schemeClr val="lt1"/>
-          </a:fontRef>
-        </p:style>
-        <p:txBody>
-          <a:bodyPr rtlCol="0" anchor="ctr" wrap="square" lIns="109728" tIns="54864"/>
-          <a:lstStyle/>
-          <a:p>
-            <a:pPr algn="ctr">
-              <a:defRPr sz="1000" b="1">
-                <a:solidFill>
-                  <a:srgbClr val="15803D"/>
-                </a:solidFill>
-                <a:latin typeface="Calibri"/>
-              </a:defRPr>
-            </a:pPr>
-            <a:r>
-              <a:t>3. Random Feature Subspace Split</a:t>
-            </a:r>
-          </a:p>
-          <a:p>
-            <a:pPr>
-              <a:defRPr sz="850" b="0">
-                <a:solidFill>
-                  <a:srgbClr val="334155"/>
-                </a:solidFill>
-                <a:latin typeface="Calibri"/>
-              </a:defRPr>
-            </a:pPr>
-            <a:r>
-              <a:t>At each decision node, randomly selects m = √|V| features and finds optimal split.</a:t>
-            </a:r>
-          </a:p>
-        </p:txBody>
-      </p:sp>
-      <p:sp>
-        <p:nvSpPr>
-          <p:cNvPr id="12" name="Rounded Rectangle 11"/>
-          <p:cNvSpPr/>
-          <p:nvPr/>
-        </p:nvSpPr>
-        <p:spPr>
-          <a:xfrm>
-            <a:off x="594360" y="4261104"/>
-            <a:ext cx="5166360" cy="594360"/>
-          </a:xfrm>
-          <a:prstGeom prst="roundRect">
-            <a:avLst/>
-          </a:prstGeom>
-          <a:solidFill>
-            <a:srgbClr val="F0FDF4"/>
-          </a:solidFill>
-          <a:ln w="12700">
-            <a:solidFill>
-              <a:srgbClr val="BBF7D0"/>
-            </a:solidFill>
-          </a:ln>
-        </p:spPr>
-        <p:style>
-          <a:lnRef idx="1">
-            <a:schemeClr val="accent1"/>
-          </a:lnRef>
-          <a:fillRef idx="3">
-            <a:schemeClr val="accent1"/>
-          </a:fillRef>
-          <a:effectRef idx="2">
-            <a:schemeClr val="accent1"/>
-          </a:effectRef>
-          <a:fontRef idx="minor">
-            <a:schemeClr val="lt1"/>
-          </a:fontRef>
-        </p:style>
-        <p:txBody>
-          <a:bodyPr rtlCol="0" anchor="ctr" wrap="square" lIns="109728" tIns="54864"/>
-          <a:lstStyle/>
-          <a:p>
-            <a:pPr algn="ctr">
-              <a:defRPr sz="1000" b="1">
-                <a:solidFill>
-                  <a:srgbClr val="15803D"/>
-                </a:solidFill>
-                <a:latin typeface="Calibri"/>
-              </a:defRPr>
-            </a:pPr>
-            <a:r>
-              <a:t>4. Decision Tree Induction</a:t>
-            </a:r>
-          </a:p>
-          <a:p>
-            <a:pPr>
-              <a:defRPr sz="850" b="0">
-                <a:solidFill>
-                  <a:srgbClr val="334155"/>
-                </a:solidFill>
-                <a:latin typeface="Calibri"/>
-              </a:defRPr>
-            </a:pPr>
-            <a:r>
-              <a:t>Recursively splits nodes using Gini Impurity: Gini = 1 - Σ p_i² until stopping criterion.</a:t>
-            </a:r>
-          </a:p>
-        </p:txBody>
-      </p:sp>
-      <p:sp>
-        <p:nvSpPr>
-          <p:cNvPr id="13" name="Rounded Rectangle 12"/>
-          <p:cNvSpPr/>
-          <p:nvPr/>
-        </p:nvSpPr>
-        <p:spPr>
-          <a:xfrm>
-            <a:off x="594360" y="4965192"/>
-            <a:ext cx="5166360" cy="594360"/>
-          </a:xfrm>
-          <a:prstGeom prst="roundRect">
-            <a:avLst/>
-          </a:prstGeom>
-          <a:solidFill>
-            <a:srgbClr val="F0FDF4"/>
-          </a:solidFill>
-          <a:ln w="12700">
-            <a:solidFill>
-              <a:srgbClr val="BBF7D0"/>
-            </a:solidFill>
-          </a:ln>
-        </p:spPr>
-        <p:style>
-          <a:lnRef idx="1">
-            <a:schemeClr val="accent1"/>
-          </a:lnRef>
-          <a:fillRef idx="3">
-            <a:schemeClr val="accent1"/>
-          </a:fillRef>
-          <a:effectRef idx="2">
-            <a:schemeClr val="accent1"/>
-          </a:effectRef>
-          <a:fontRef idx="minor">
-            <a:schemeClr val="lt1"/>
-          </a:fontRef>
-        </p:style>
-        <p:txBody>
-          <a:bodyPr rtlCol="0" anchor="ctr" wrap="square" lIns="109728" tIns="54864"/>
-          <a:lstStyle/>
-          <a:p>
-            <a:pPr algn="ctr">
-              <a:defRPr sz="1000" b="1">
-                <a:solidFill>
-                  <a:srgbClr val="15803D"/>
-                </a:solidFill>
-                <a:latin typeface="Calibri"/>
-              </a:defRPr>
-            </a:pPr>
-            <a:r>
-              <a:t>5. Forest Ensemble Assembly</a:t>
-            </a:r>
-          </a:p>
-          <a:p>
-            <a:pPr>
-              <a:defRPr sz="850" b="0">
-                <a:solidFill>
-                  <a:srgbClr val="334155"/>
-                </a:solidFill>
-                <a:latin typeface="Calibri"/>
-              </a:defRPr>
-            </a:pPr>
-            <a:r>
-              <a:t>Combines B independently trained decision trees into an uncorrelated forest ensemble.</a:t>
-            </a:r>
-          </a:p>
-        </p:txBody>
-      </p:sp>
-      <p:sp>
-        <p:nvSpPr>
-          <p:cNvPr id="14" name="Rounded Rectangle 13"/>
-          <p:cNvSpPr/>
-          <p:nvPr/>
-        </p:nvSpPr>
-        <p:spPr>
-          <a:xfrm>
-            <a:off x="594360" y="5669280"/>
-            <a:ext cx="5166360" cy="594360"/>
-          </a:xfrm>
-          <a:prstGeom prst="roundRect">
-            <a:avLst/>
-          </a:prstGeom>
-          <a:solidFill>
-            <a:srgbClr val="F0FDF4"/>
-          </a:solidFill>
-          <a:ln w="12700">
-            <a:solidFill>
-              <a:srgbClr val="BBF7D0"/>
-            </a:solidFill>
-          </a:ln>
-        </p:spPr>
-        <p:style>
-          <a:lnRef idx="1">
-            <a:schemeClr val="accent1"/>
-          </a:lnRef>
-          <a:fillRef idx="3">
-            <a:schemeClr val="accent1"/>
-          </a:fillRef>
-          <a:effectRef idx="2">
-            <a:schemeClr val="accent1"/>
-          </a:effectRef>
-          <a:fontRef idx="minor">
-            <a:schemeClr val="lt1"/>
-          </a:fontRef>
-        </p:style>
-        <p:txBody>
-          <a:bodyPr rtlCol="0" anchor="ctr" wrap="square" lIns="109728" tIns="54864"/>
-          <a:lstStyle/>
-          <a:p>
-            <a:pPr algn="ctr">
-              <a:defRPr sz="1000" b="1">
-                <a:solidFill>
-                  <a:srgbClr val="15803D"/>
-                </a:solidFill>
-                <a:latin typeface="Calibri"/>
-              </a:defRPr>
-            </a:pPr>
-            <a:r>
-              <a:t>6. Ensemble Averaged Probability</a:t>
-            </a:r>
-          </a:p>
-          <a:p>
-            <a:pPr>
-              <a:defRPr sz="850" b="0">
-                <a:solidFill>
-                  <a:srgbClr val="334155"/>
-                </a:solidFill>
-                <a:latin typeface="Calibri"/>
-              </a:defRPr>
-            </a:pPr>
-            <a:r>
-              <a:t>Calculates consensus class probabilities: P_RF(c) = (1/B) Σ P_tree_b(c) across all B trees.</a:t>
-            </a:r>
-          </a:p>
-        </p:txBody>
-      </p:sp>
-      <p:sp>
-        <p:nvSpPr>
-          <p:cNvPr id="15" name="Rounded Rectangle 14"/>
-          <p:cNvSpPr/>
-          <p:nvPr/>
-        </p:nvSpPr>
-        <p:spPr>
-          <a:xfrm>
-            <a:off x="6217920" y="1371600"/>
-            <a:ext cx="5486400" cy="4983480"/>
-          </a:xfrm>
-          <a:prstGeom prst="roundRect">
-            <a:avLst/>
-          </a:prstGeom>
-          <a:solidFill>
-            <a:srgbClr val="FFFFFF"/>
-          </a:solidFill>
-          <a:ln w="19050">
-            <a:solidFill>
-              <a:srgbClr val="9333EA"/>
-            </a:solidFill>
-          </a:ln>
-        </p:spPr>
-        <p:style>
-          <a:lnRef idx="1">
-            <a:schemeClr val="accent1"/>
-          </a:lnRef>
-          <a:fillRef idx="3">
-            <a:schemeClr val="accent1"/>
-          </a:fillRef>
-          <a:effectRef idx="2">
-            <a:schemeClr val="accent1"/>
-          </a:effectRef>
-          <a:fontRef idx="minor">
-            <a:schemeClr val="lt1"/>
-          </a:fontRef>
-        </p:style>
-        <p:txBody>
-          <a:bodyPr rtlCol="0" anchor="ctr"/>
-          <a:lstStyle/>
-          <a:p>
-            <a:pPr algn="ctr"/>
-          </a:p>
-        </p:txBody>
-      </p:sp>
-      <p:sp>
-        <p:nvSpPr>
-          <p:cNvPr id="16" name="Rounded Rectangle 15"/>
-          <p:cNvSpPr/>
-          <p:nvPr/>
-        </p:nvSpPr>
-        <p:spPr>
-          <a:xfrm>
-            <a:off x="6355080" y="1508760"/>
-            <a:ext cx="5212080" cy="502920"/>
-          </a:xfrm>
-          <a:prstGeom prst="roundRect">
-            <a:avLst/>
-          </a:prstGeom>
-          <a:solidFill>
-            <a:srgbClr val="9333EA"/>
-          </a:solidFill>
-          <a:ln>
-            <a:noFill/>
-          </a:ln>
-        </p:spPr>
-        <p:style>
-          <a:lnRef idx="1">
-            <a:schemeClr val="accent1"/>
-          </a:lnRef>
-          <a:fillRef idx="3">
-            <a:schemeClr val="accent1"/>
-          </a:fillRef>
-          <a:effectRef idx="2">
-            <a:schemeClr val="accent1"/>
-          </a:effectRef>
-          <a:fontRef idx="minor">
-            <a:schemeClr val="lt1"/>
-          </a:fontRef>
-        </p:style>
-        <p:txBody>
-          <a:bodyPr rtlCol="0" anchor="ctr"/>
-          <a:lstStyle/>
-          <a:p>
-            <a:pPr algn="ctr">
-              <a:defRPr sz="1150" b="1">
-                <a:solidFill>
-                  <a:srgbClr val="FFFFFF"/>
-                </a:solidFill>
-                <a:latin typeface="Calibri"/>
-              </a:defRPr>
-            </a:pPr>
-            <a:r>
-              <a:t>LOGISTIC REGRESSION (LR) ACTIVITY FLOW</a:t>
-            </a:r>
-          </a:p>
-        </p:txBody>
-      </p:sp>
-      <p:sp>
-        <p:nvSpPr>
-          <p:cNvPr id="17" name="Rounded Rectangle 16"/>
-          <p:cNvSpPr/>
-          <p:nvPr/>
-        </p:nvSpPr>
-        <p:spPr>
-          <a:xfrm>
-            <a:off x="6355080" y="2148840"/>
-            <a:ext cx="5212080" cy="594360"/>
-          </a:xfrm>
-          <a:prstGeom prst="roundRect">
-            <a:avLst/>
-          </a:prstGeom>
-          <a:solidFill>
-            <a:srgbClr val="FAF5FF"/>
-          </a:solidFill>
-          <a:ln w="12700">
-            <a:solidFill>
-              <a:srgbClr val="E9D5FF"/>
-            </a:solidFill>
-          </a:ln>
-        </p:spPr>
-        <p:style>
-          <a:lnRef idx="1">
-            <a:schemeClr val="accent1"/>
-          </a:lnRef>
-          <a:fillRef idx="3">
-            <a:schemeClr val="accent1"/>
-          </a:fillRef>
-          <a:effectRef idx="2">
-            <a:schemeClr val="accent1"/>
-          </a:effectRef>
-          <a:fontRef idx="minor">
-            <a:schemeClr val="lt1"/>
-          </a:fontRef>
-        </p:style>
-        <p:txBody>
-          <a:bodyPr rtlCol="0" anchor="ctr" wrap="square" lIns="109728" tIns="54864"/>
-          <a:lstStyle/>
-          <a:p>
-            <a:pPr algn="ctr">
-              <a:defRPr sz="1000" b="1">
-                <a:solidFill>
-                  <a:srgbClr val="7E22CE"/>
-                </a:solidFill>
-                <a:latin typeface="Calibri"/>
-              </a:defRPr>
-            </a:pPr>
-            <a:r>
-              <a:t>1. Standardized Vector Input</a:t>
-            </a:r>
-          </a:p>
-          <a:p>
-            <a:pPr>
-              <a:defRPr sz="850" b="0">
-                <a:solidFill>
-                  <a:srgbClr val="334155"/>
-                </a:solidFill>
-                <a:latin typeface="Calibri"/>
-              </a:defRPr>
-            </a:pPr>
-            <a:r>
-              <a:t>Sparse TF-IDF vector x with L2 Euclidean normalization representing clinical narrative.</a:t>
-            </a:r>
-          </a:p>
-        </p:txBody>
-      </p:sp>
-      <p:sp>
-        <p:nvSpPr>
-          <p:cNvPr id="18" name="Rounded Rectangle 17"/>
-          <p:cNvSpPr/>
-          <p:nvPr/>
-        </p:nvSpPr>
-        <p:spPr>
-          <a:xfrm>
-            <a:off x="6355080" y="2852928"/>
-            <a:ext cx="5212080" cy="594360"/>
-          </a:xfrm>
-          <a:prstGeom prst="roundRect">
-            <a:avLst/>
-          </a:prstGeom>
-          <a:solidFill>
-            <a:srgbClr val="FAF5FF"/>
-          </a:solidFill>
-          <a:ln w="12700">
-            <a:solidFill>
-              <a:srgbClr val="E9D5FF"/>
-            </a:solidFill>
-          </a:ln>
-        </p:spPr>
-        <p:style>
-          <a:lnRef idx="1">
-            <a:schemeClr val="accent1"/>
-          </a:lnRef>
-          <a:fillRef idx="3">
-            <a:schemeClr val="accent1"/>
-          </a:fillRef>
-          <a:effectRef idx="2">
-            <a:schemeClr val="accent1"/>
-          </a:effectRef>
-          <a:fontRef idx="minor">
-            <a:schemeClr val="lt1"/>
-          </a:fontRef>
-        </p:style>
-        <p:txBody>
-          <a:bodyPr rtlCol="0" anchor="ctr" wrap="square" lIns="109728" tIns="54864"/>
-          <a:lstStyle/>
-          <a:p>
-            <a:pPr algn="ctr">
-              <a:defRPr sz="1000" b="1">
-                <a:solidFill>
-                  <a:srgbClr val="7E22CE"/>
-                </a:solidFill>
-                <a:latin typeface="Calibri"/>
-              </a:defRPr>
-            </a:pPr>
-            <a:r>
-              <a:t>2. Linear Logit Computation</a:t>
-            </a:r>
-          </a:p>
-          <a:p>
-            <a:pPr>
-              <a:defRPr sz="850" b="0">
-                <a:solidFill>
-                  <a:srgbClr val="334155"/>
-                </a:solidFill>
-                <a:latin typeface="Calibri"/>
-              </a:defRPr>
-            </a:pPr>
-            <a:r>
-              <a:t>Computes linear combination z_c = w_c · x + b_c for each medical specialty class c ∈ {1..40}.</a:t>
-            </a:r>
-          </a:p>
-        </p:txBody>
-      </p:sp>
-      <p:sp>
-        <p:nvSpPr>
-          <p:cNvPr id="19" name="Rounded Rectangle 18"/>
-          <p:cNvSpPr/>
-          <p:nvPr/>
-        </p:nvSpPr>
-        <p:spPr>
-          <a:xfrm>
-            <a:off x="6355080" y="3557016"/>
-            <a:ext cx="5212080" cy="594360"/>
-          </a:xfrm>
-          <a:prstGeom prst="roundRect">
-            <a:avLst/>
-          </a:prstGeom>
-          <a:solidFill>
-            <a:srgbClr val="FAF5FF"/>
-          </a:solidFill>
-          <a:ln w="12700">
-            <a:solidFill>
-              <a:srgbClr val="E9D5FF"/>
-            </a:solidFill>
-          </a:ln>
-        </p:spPr>
-        <p:style>
-          <a:lnRef idx="1">
-            <a:schemeClr val="accent1"/>
-          </a:lnRef>
-          <a:fillRef idx="3">
-            <a:schemeClr val="accent1"/>
-          </a:fillRef>
-          <a:effectRef idx="2">
-            <a:schemeClr val="accent1"/>
-          </a:effectRef>
-          <a:fontRef idx="minor">
-            <a:schemeClr val="lt1"/>
-          </a:fontRef>
-        </p:style>
-        <p:txBody>
-          <a:bodyPr rtlCol="0" anchor="ctr" wrap="square" lIns="109728" tIns="54864"/>
-          <a:lstStyle/>
-          <a:p>
-            <a:pPr algn="ctr">
-              <a:defRPr sz="1000" b="1">
-                <a:solidFill>
-                  <a:srgbClr val="7E22CE"/>
-                </a:solidFill>
-                <a:latin typeface="Calibri"/>
-              </a:defRPr>
-            </a:pPr>
-            <a:r>
-              <a:t>3. L2 Ridge Regularization</a:t>
-            </a:r>
-          </a:p>
-          <a:p>
-            <a:pPr>
-              <a:defRPr sz="850" b="0">
-                <a:solidFill>
-                  <a:srgbClr val="334155"/>
-                </a:solidFill>
-                <a:latin typeface="Calibri"/>
-              </a:defRPr>
-            </a:pPr>
-            <a:r>
-              <a:t>Applies L2 penalty λ/2 ||w||² in objective function to shrink weights &amp; prevent overfitting.</a:t>
-            </a:r>
-          </a:p>
-        </p:txBody>
-      </p:sp>
-      <p:sp>
-        <p:nvSpPr>
-          <p:cNvPr id="20" name="Rounded Rectangle 19"/>
-          <p:cNvSpPr/>
-          <p:nvPr/>
-        </p:nvSpPr>
-        <p:spPr>
-          <a:xfrm>
-            <a:off x="6355080" y="4261104"/>
-            <a:ext cx="5212080" cy="594360"/>
-          </a:xfrm>
-          <a:prstGeom prst="roundRect">
-            <a:avLst/>
-          </a:prstGeom>
-          <a:solidFill>
-            <a:srgbClr val="FAF5FF"/>
-          </a:solidFill>
-          <a:ln w="12700">
-            <a:solidFill>
-              <a:srgbClr val="E9D5FF"/>
-            </a:solidFill>
-          </a:ln>
-        </p:spPr>
-        <p:style>
-          <a:lnRef idx="1">
-            <a:schemeClr val="accent1"/>
-          </a:lnRef>
-          <a:fillRef idx="3">
-            <a:schemeClr val="accent1"/>
-          </a:fillRef>
-          <a:effectRef idx="2">
-            <a:schemeClr val="accent1"/>
-          </a:effectRef>
-          <a:fontRef idx="minor">
-            <a:schemeClr val="lt1"/>
-          </a:fontRef>
-        </p:style>
-        <p:txBody>
-          <a:bodyPr rtlCol="0" anchor="ctr" wrap="square" lIns="109728" tIns="54864"/>
-          <a:lstStyle/>
-          <a:p>
-            <a:pPr algn="ctr">
-              <a:defRPr sz="1000" b="1">
-                <a:solidFill>
-                  <a:srgbClr val="7E22CE"/>
-                </a:solidFill>
-                <a:latin typeface="Calibri"/>
-              </a:defRPr>
-            </a:pPr>
-            <a:r>
-              <a:t>4. Softmax Probability Mapping</a:t>
-            </a:r>
-          </a:p>
-          <a:p>
-            <a:pPr>
-              <a:defRPr sz="850" b="0">
-                <a:solidFill>
-                  <a:srgbClr val="334155"/>
-                </a:solidFill>
-                <a:latin typeface="Calibri"/>
-              </a:defRPr>
-            </a:pPr>
-            <a:r>
-              <a:t>Transforms logits to calibrated probabilities via Softmax: P(y=c|x) = exp(z_c) / Σ exp(z_k).</a:t>
-            </a:r>
-          </a:p>
-        </p:txBody>
-      </p:sp>
-      <p:sp>
-        <p:nvSpPr>
-          <p:cNvPr id="21" name="Rounded Rectangle 20"/>
-          <p:cNvSpPr/>
-          <p:nvPr/>
-        </p:nvSpPr>
-        <p:spPr>
-          <a:xfrm>
-            <a:off x="6355080" y="4965192"/>
-            <a:ext cx="5212080" cy="594360"/>
-          </a:xfrm>
-          <a:prstGeom prst="roundRect">
-            <a:avLst/>
-          </a:prstGeom>
-          <a:solidFill>
-            <a:srgbClr val="FAF5FF"/>
-          </a:solidFill>
-          <a:ln w="12700">
-            <a:solidFill>
-              <a:srgbClr val="E9D5FF"/>
-            </a:solidFill>
-          </a:ln>
-        </p:spPr>
-        <p:style>
-          <a:lnRef idx="1">
-            <a:schemeClr val="accent1"/>
-          </a:lnRef>
-          <a:fillRef idx="3">
-            <a:schemeClr val="accent1"/>
-          </a:fillRef>
-          <a:effectRef idx="2">
-            <a:schemeClr val="accent1"/>
-          </a:effectRef>
-          <a:fontRef idx="minor">
-            <a:schemeClr val="lt1"/>
-          </a:fontRef>
-        </p:style>
-        <p:txBody>
-          <a:bodyPr rtlCol="0" anchor="ctr" wrap="square" lIns="109728" tIns="54864"/>
-          <a:lstStyle/>
-          <a:p>
-            <a:pPr algn="ctr">
-              <a:defRPr sz="1000" b="1">
-                <a:solidFill>
-                  <a:srgbClr val="7E22CE"/>
-                </a:solidFill>
-                <a:latin typeface="Calibri"/>
-              </a:defRPr>
-            </a:pPr>
-            <a:r>
-              <a:t>5. Cross-Entropy Loss Optimization</a:t>
-            </a:r>
-          </a:p>
-          <a:p>
-            <a:pPr>
-              <a:defRPr sz="850" b="0">
-                <a:solidFill>
-                  <a:srgbClr val="334155"/>
-                </a:solidFill>
-                <a:latin typeface="Calibri"/>
-              </a:defRPr>
-            </a:pPr>
-            <a:r>
-              <a:t>Optimizes parameter weights using L-BFGS quasi-Newton gradient ascent solver.</a:t>
-            </a:r>
-          </a:p>
-        </p:txBody>
-      </p:sp>
-      <p:sp>
-        <p:nvSpPr>
-          <p:cNvPr id="22" name="Rounded Rectangle 21"/>
-          <p:cNvSpPr/>
-          <p:nvPr/>
-        </p:nvSpPr>
-        <p:spPr>
-          <a:xfrm>
-            <a:off x="6355080" y="5669280"/>
-            <a:ext cx="5212080" cy="594360"/>
-          </a:xfrm>
-          <a:prstGeom prst="roundRect">
-            <a:avLst/>
-          </a:prstGeom>
-          <a:solidFill>
-            <a:srgbClr val="FAF5FF"/>
-          </a:solidFill>
-          <a:ln w="12700">
-            <a:solidFill>
-              <a:srgbClr val="E9D5FF"/>
-            </a:solidFill>
-          </a:ln>
-        </p:spPr>
-        <p:style>
-          <a:lnRef idx="1">
-            <a:schemeClr val="accent1"/>
-          </a:lnRef>
-          <a:fillRef idx="3">
-            <a:schemeClr val="accent1"/>
-          </a:fillRef>
-          <a:effectRef idx="2">
-            <a:schemeClr val="accent1"/>
-          </a:effectRef>
-          <a:fontRef idx="minor">
-            <a:schemeClr val="lt1"/>
-          </a:fontRef>
-        </p:style>
-        <p:txBody>
-          <a:bodyPr rtlCol="0" anchor="ctr" wrap="square" lIns="109728" tIns="54864"/>
-          <a:lstStyle/>
-          <a:p>
-            <a:pPr algn="ctr">
-              <a:defRPr sz="1000" b="1">
-                <a:solidFill>
-                  <a:srgbClr val="7E22CE"/>
-                </a:solidFill>
-                <a:latin typeface="Calibri"/>
-              </a:defRPr>
-            </a:pPr>
-            <a:r>
-              <a:t>6. Multi-Class Probability Output</a:t>
-            </a:r>
-          </a:p>
-          <a:p>
-            <a:pPr>
-              <a:defRPr sz="850" b="0">
-                <a:solidFill>
-                  <a:srgbClr val="334155"/>
-                </a:solidFill>
-                <a:latin typeface="Calibri"/>
-              </a:defRPr>
-            </a:pPr>
-            <a:r>
-              <a:t>Generates calibrated posterior probability distribution vector across all 40 categories.</a:t>
-            </a:r>
-          </a:p>
-        </p:txBody>
-      </p:sp>
+              <a:t>LOGISTIC REGRESSION (LR) — ACTIVITY DIAGRAM</a:t>
+            </a:r>
+          </a:p>
+        </p:txBody>
+      </p:sp>
+      <p:pic>
+        <p:nvPicPr>
+          <p:cNvPr id="12" name="Picture 11" descr="lr.png"/>
+          <p:cNvPicPr>
+            <a:picLocks noChangeAspect="1"/>
+          </p:cNvPicPr>
+          <p:nvPr/>
+        </p:nvPicPr>
+        <p:blipFill>
+          <a:blip r:embed="rId4"/>
+          <a:stretch>
+            <a:fillRect/>
+          </a:stretch>
+        </p:blipFill>
+        <p:spPr>
+          <a:xfrm>
+            <a:off x="7744968" y="1874519"/>
+            <a:ext cx="2423160" cy="4447845"/>
+          </a:xfrm>
+          <a:prstGeom prst="rect">
+            <a:avLst/>
+          </a:prstGeom>
+        </p:spPr>
+      </p:pic>
     </p:spTree>
   </p:cSld>
   <p:clrMapOvr>
@@ -9970,14 +8434,14 @@
         </p:nvSpPr>
         <p:spPr>
           <a:xfrm>
-            <a:off x="457200" y="1371600"/>
-            <a:ext cx="11247120" cy="731520"/>
+            <a:off x="457200" y="1325880"/>
+            <a:ext cx="6858000" cy="5074920"/>
           </a:xfrm>
           <a:prstGeom prst="roundRect">
             <a:avLst/>
           </a:prstGeom>
           <a:solidFill>
-            <a:srgbClr val="EEF6F6"/>
+            <a:srgbClr val="FFFFFF"/>
           </a:solidFill>
           <a:ln w="19050">
             <a:solidFill>
@@ -10000,33 +8464,10 @@
           </a:fontRef>
         </p:style>
         <p:txBody>
-          <a:bodyPr rtlCol="0" anchor="ctr" wrap="square"/>
-          <a:lstStyle/>
-          <a:p>
-            <a:pPr algn="ctr">
-              <a:defRPr sz="1100" b="1">
-                <a:solidFill>
-                  <a:srgbClr val="0E7C86"/>
-                </a:solidFill>
-                <a:latin typeface="Calibri"/>
-              </a:defRPr>
-            </a:pPr>
-            <a:r>
-              <a:t>STAGE 1: INPUT NARRATIVE &amp; VECTORIZATION INFERENCE</a:t>
-            </a:r>
-          </a:p>
-          <a:p>
-            <a:pPr>
-              <a:defRPr sz="1000">
-                <a:solidFill>
-                  <a:srgbClr val="0F172A"/>
-                </a:solidFill>
-                <a:latin typeface="Calibri"/>
-              </a:defRPr>
-            </a:pPr>
-            <a:r>
-              <a:t>Unseen Clinical Transcription Text  →  8-Step Preprocessing Pipeline  →  TF-IDF Transformation (V vocabulary features)  →  Normalized Sparse Vector x</a:t>
-            </a:r>
+          <a:bodyPr rtlCol="0" anchor="ctr"/>
+          <a:lstStyle/>
+          <a:p>
+            <a:pPr algn="ctr"/>
           </a:p>
         </p:txBody>
       </p:sp>
@@ -10038,19 +8479,17 @@
         </p:nvSpPr>
         <p:spPr>
           <a:xfrm>
-            <a:off x="457200" y="2240280"/>
-            <a:ext cx="2651760" cy="1508760"/>
+            <a:off x="594360" y="1417320"/>
+            <a:ext cx="6583680" cy="384048"/>
           </a:xfrm>
           <a:prstGeom prst="roundRect">
             <a:avLst/>
           </a:prstGeom>
           <a:solidFill>
-            <a:srgbClr val="F0FDFA"/>
+            <a:srgbClr val="0E7C86"/>
           </a:solidFill>
-          <a:ln w="19050">
-            <a:solidFill>
-              <a:srgbClr val="0E7C86"/>
-            </a:solidFill>
+          <a:ln>
+            <a:noFill/>
           </a:ln>
         </p:spPr>
         <p:style>
@@ -10068,88 +8507,67 @@
           </a:fontRef>
         </p:style>
         <p:txBody>
-          <a:bodyPr rtlCol="0" anchor="ctr" wrap="square" lIns="109728" tIns="91440"/>
+          <a:bodyPr rtlCol="0" anchor="ctr"/>
           <a:lstStyle/>
           <a:p>
             <a:pPr algn="ctr">
-              <a:spcAft>
-                <a:spcPts val="200"/>
-              </a:spcAft>
               <a:defRPr sz="1100" b="1">
                 <a:solidFill>
-                  <a:srgbClr val="0E7C86"/>
+                  <a:srgbClr val="FFFFFF"/>
                 </a:solidFill>
                 <a:latin typeface="Calibri"/>
               </a:defRPr>
             </a:pPr>
             <a:r>
-              <a:t>MODEL 1: SVM Classifier</a:t>
-            </a:r>
-          </a:p>
-          <a:p>
-            <a:pPr>
-              <a:defRPr sz="950">
-                <a:solidFill>
-                  <a:srgbClr val="334155"/>
-                </a:solidFill>
-                <a:latin typeface="Calibri"/>
-              </a:defRPr>
-            </a:pPr>
-            <a:r>
-              <a:t>Support Vector Machine</a:t>
-            </a:r>
-          </a:p>
-          <a:p>
-            <a:pPr>
-              <a:spcAft>
-                <a:spcPts val="400"/>
-              </a:spcAft>
-              <a:defRPr sz="900">
-                <a:solidFill>
-                  <a:srgbClr val="94A3B8"/>
-                </a:solidFill>
-                <a:latin typeface="Calibri"/>
-              </a:defRPr>
-            </a:pPr>
-            <a:r>
-              <a:t>Platt Calibrated Scaling</a:t>
-            </a:r>
-          </a:p>
-          <a:p>
-            <a:pPr>
-              <a:defRPr sz="950" b="1">
-                <a:solidFill>
-                  <a:srgbClr val="0E7C86"/>
-                </a:solidFill>
-                <a:latin typeface="Calibri"/>
-              </a:defRPr>
-            </a:pPr>
-            <a:r>
-              <a:t>Output: P_SVM(c|x) ∈ R^40</a:t>
-            </a:r>
-          </a:p>
-        </p:txBody>
-      </p:sp>
-      <p:sp>
-        <p:nvSpPr>
-          <p:cNvPr id="9" name="Rounded Rectangle 8"/>
+              <a:t>VOTING ENSEMBLE CLASSIFIER — ACTIVITY DIAGRAM</a:t>
+            </a:r>
+          </a:p>
+        </p:txBody>
+      </p:sp>
+      <p:pic>
+        <p:nvPicPr>
+          <p:cNvPr id="9" name="Picture 8" descr="ensemble.png"/>
+          <p:cNvPicPr>
+            <a:picLocks noChangeAspect="1"/>
+          </p:cNvPicPr>
+          <p:nvPr/>
+        </p:nvPicPr>
+        <p:blipFill>
+          <a:blip r:embed="rId3"/>
+          <a:stretch>
+            <a:fillRect/>
+          </a:stretch>
+        </p:blipFill>
+        <p:spPr>
+          <a:xfrm>
+            <a:off x="640080" y="1874519"/>
+            <a:ext cx="6492240" cy="4440372"/>
+          </a:xfrm>
+          <a:prstGeom prst="rect">
+            <a:avLst/>
+          </a:prstGeom>
+        </p:spPr>
+      </p:pic>
+      <p:sp>
+        <p:nvSpPr>
+          <p:cNvPr id="10" name="Rounded Rectangle 9"/>
           <p:cNvSpPr/>
           <p:nvPr/>
         </p:nvSpPr>
         <p:spPr>
           <a:xfrm>
-            <a:off x="3319272" y="2240280"/>
-            <a:ext cx="2651760" cy="1508760"/>
+            <a:off x="7543800" y="1325880"/>
+            <a:ext cx="4160520" cy="5074920"/>
           </a:xfrm>
           <a:prstGeom prst="roundRect">
             <a:avLst/>
           </a:prstGeom>
           <a:solidFill>
-            <a:srgbClr val="F0FDF4"/>
+            <a:srgbClr val="FAFAFC"/>
           </a:solidFill>
           <a:ln w="19050">
             <a:solidFill>
-              <a:srgbClr val="16A34A"/>
+              <a:srgbClr val="CBD5E1"/>
             </a:solidFill>
           </a:ln>
         </p:spPr>
@@ -10168,35 +8586,22 @@
           </a:fontRef>
         </p:style>
         <p:txBody>
-          <a:bodyPr rtlCol="0" anchor="ctr" wrap="square" lIns="109728" tIns="91440"/>
+          <a:bodyPr rtlCol="0" anchor="ctr" wrap="square" lIns="201168" rIns="201168" tIns="182880"/>
           <a:lstStyle/>
           <a:p>
             <a:pPr algn="ctr">
               <a:spcAft>
-                <a:spcPts val="200"/>
+                <a:spcPts val="600"/>
               </a:spcAft>
-              <a:defRPr sz="1100" b="1">
-                <a:solidFill>
-                  <a:srgbClr val="16A34A"/>
+              <a:defRPr sz="1150" b="1">
+                <a:solidFill>
+                  <a:srgbClr val="0E7C86"/>
                 </a:solidFill>
                 <a:latin typeface="Calibri"/>
               </a:defRPr>
             </a:pPr>
             <a:r>
-              <a:t>MODEL 2: Random Forest</a:t>
-            </a:r>
-          </a:p>
-          <a:p>
-            <a:pPr>
-              <a:defRPr sz="950">
-                <a:solidFill>
-                  <a:srgbClr val="334155"/>
-                </a:solidFill>
-                <a:latin typeface="Calibri"/>
-              </a:defRPr>
-            </a:pPr>
-            <a:r>
-              <a:t>Ensemble Decision Trees</a:t>
+              <a:t>ENSEMBLE ARCHITECTURE</a:t>
             </a:r>
           </a:p>
           <a:p>
@@ -10204,99 +8609,24 @@
               <a:spcAft>
                 <a:spcPts val="400"/>
               </a:spcAft>
-              <a:defRPr sz="900">
-                <a:solidFill>
-                  <a:srgbClr val="94A3B8"/>
+            </a:pPr>
+            <a:r>
+              <a:rPr sz="950" b="1">
+                <a:solidFill>
+                  <a:srgbClr val="0B1F3A"/>
                 </a:solidFill>
                 <a:latin typeface="Calibri"/>
-              </a:defRPr>
-            </a:pPr>
-            <a:r>
-              <a:t>Tree Mean Voting</a:t>
-            </a:r>
-          </a:p>
-          <a:p>
-            <a:pPr>
-              <a:defRPr sz="950" b="1">
-                <a:solidFill>
-                  <a:srgbClr val="16A34A"/>
+              </a:rPr>
+              <a:t>• Parallel Execution: </a:t>
+            </a:r>
+            <a:r>
+              <a:rPr sz="900">
+                <a:solidFill>
+                  <a:srgbClr val="334155"/>
                 </a:solidFill>
                 <a:latin typeface="Calibri"/>
-              </a:defRPr>
-            </a:pPr>
-            <a:r>
-              <a:t>Output: P_RF(c|x) ∈ R^40</a:t>
-            </a:r>
-          </a:p>
-        </p:txBody>
-      </p:sp>
-      <p:sp>
-        <p:nvSpPr>
-          <p:cNvPr id="10" name="Rounded Rectangle 9"/>
-          <p:cNvSpPr/>
-          <p:nvPr/>
-        </p:nvSpPr>
-        <p:spPr>
-          <a:xfrm>
-            <a:off x="6181344" y="2240280"/>
-            <a:ext cx="2651760" cy="1508760"/>
-          </a:xfrm>
-          <a:prstGeom prst="roundRect">
-            <a:avLst/>
-          </a:prstGeom>
-          <a:solidFill>
-            <a:srgbClr val="FAF5FF"/>
-          </a:solidFill>
-          <a:ln w="19050">
-            <a:solidFill>
-              <a:srgbClr val="9333EA"/>
-            </a:solidFill>
-          </a:ln>
-        </p:spPr>
-        <p:style>
-          <a:lnRef idx="1">
-            <a:schemeClr val="accent1"/>
-          </a:lnRef>
-          <a:fillRef idx="3">
-            <a:schemeClr val="accent1"/>
-          </a:fillRef>
-          <a:effectRef idx="2">
-            <a:schemeClr val="accent1"/>
-          </a:effectRef>
-          <a:fontRef idx="minor">
-            <a:schemeClr val="lt1"/>
-          </a:fontRef>
-        </p:style>
-        <p:txBody>
-          <a:bodyPr rtlCol="0" anchor="ctr" wrap="square" lIns="109728" tIns="91440"/>
-          <a:lstStyle/>
-          <a:p>
-            <a:pPr algn="ctr">
-              <a:spcAft>
-                <a:spcPts val="200"/>
-              </a:spcAft>
-              <a:defRPr sz="1100" b="1">
-                <a:solidFill>
-                  <a:srgbClr val="9333EA"/>
-                </a:solidFill>
-                <a:latin typeface="Calibri"/>
-              </a:defRPr>
-            </a:pPr>
-            <a:r>
-              <a:t>MODEL 3: Logistic Regression</a:t>
-            </a:r>
-          </a:p>
-          <a:p>
-            <a:pPr>
-              <a:defRPr sz="950">
-                <a:solidFill>
-                  <a:srgbClr val="334155"/>
-                </a:solidFill>
-                <a:latin typeface="Calibri"/>
-              </a:defRPr>
-            </a:pPr>
-            <a:r>
-              <a:t>Multinomial Softmax</a:t>
+              </a:rPr>
+              <a:t>All 4 base classifiers (LR, SVM, RF, MNB) ingest identical TF-IDF vectors simultaneously.</a:t>
             </a:r>
           </a:p>
           <a:p>
@@ -10304,99 +8634,24 @@
               <a:spcAft>
                 <a:spcPts val="400"/>
               </a:spcAft>
-              <a:defRPr sz="900">
-                <a:solidFill>
-                  <a:srgbClr val="94A3B8"/>
+            </a:pPr>
+            <a:r>
+              <a:rPr sz="950" b="1">
+                <a:solidFill>
+                  <a:srgbClr val="0B1F3A"/>
                 </a:solidFill>
                 <a:latin typeface="Calibri"/>
-              </a:defRPr>
-            </a:pPr>
-            <a:r>
-              <a:t>L2 Regularized Logits</a:t>
-            </a:r>
-          </a:p>
-          <a:p>
-            <a:pPr>
-              <a:defRPr sz="950" b="1">
-                <a:solidFill>
-                  <a:srgbClr val="9333EA"/>
+              </a:rPr>
+              <a:t>• Probability Calibration: </a:t>
+            </a:r>
+            <a:r>
+              <a:rPr sz="900">
+                <a:solidFill>
+                  <a:srgbClr val="334155"/>
                 </a:solidFill>
                 <a:latin typeface="Calibri"/>
-              </a:defRPr>
-            </a:pPr>
-            <a:r>
-              <a:t>Output: P_LR(c|x) ∈ R^40</a:t>
-            </a:r>
-          </a:p>
-        </p:txBody>
-      </p:sp>
-      <p:sp>
-        <p:nvSpPr>
-          <p:cNvPr id="11" name="Rounded Rectangle 10"/>
-          <p:cNvSpPr/>
-          <p:nvPr/>
-        </p:nvSpPr>
-        <p:spPr>
-          <a:xfrm>
-            <a:off x="9043416" y="2240280"/>
-            <a:ext cx="2651760" cy="1508760"/>
-          </a:xfrm>
-          <a:prstGeom prst="roundRect">
-            <a:avLst/>
-          </a:prstGeom>
-          <a:solidFill>
-            <a:srgbClr val="EFF6FF"/>
-          </a:solidFill>
-          <a:ln w="19050">
-            <a:solidFill>
-              <a:srgbClr val="2563EB"/>
-            </a:solidFill>
-          </a:ln>
-        </p:spPr>
-        <p:style>
-          <a:lnRef idx="1">
-            <a:schemeClr val="accent1"/>
-          </a:lnRef>
-          <a:fillRef idx="3">
-            <a:schemeClr val="accent1"/>
-          </a:fillRef>
-          <a:effectRef idx="2">
-            <a:schemeClr val="accent1"/>
-          </a:effectRef>
-          <a:fontRef idx="minor">
-            <a:schemeClr val="lt1"/>
-          </a:fontRef>
-        </p:style>
-        <p:txBody>
-          <a:bodyPr rtlCol="0" anchor="ctr" wrap="square" lIns="109728" tIns="91440"/>
-          <a:lstStyle/>
-          <a:p>
-            <a:pPr algn="ctr">
-              <a:spcAft>
-                <a:spcPts val="200"/>
-              </a:spcAft>
-              <a:defRPr sz="1100" b="1">
-                <a:solidFill>
-                  <a:srgbClr val="2563EB"/>
-                </a:solidFill>
-                <a:latin typeface="Calibri"/>
-              </a:defRPr>
-            </a:pPr>
-            <a:r>
-              <a:t>MODEL 4: Multinomial NB</a:t>
-            </a:r>
-          </a:p>
-          <a:p>
-            <a:pPr>
-              <a:defRPr sz="950">
-                <a:solidFill>
-                  <a:srgbClr val="334155"/>
-                </a:solidFill>
-                <a:latin typeface="Calibri"/>
-              </a:defRPr>
-            </a:pPr>
-            <a:r>
-              <a:t>Naïve Bayes Estimator</a:t>
+              </a:rPr>
+              <a:t>Logistic Regression, RF, and MNB output natural probabilities; SVM decision scores are calibrated to produce true probability distributions.</a:t>
             </a:r>
           </a:p>
           <a:p>
@@ -10404,203 +8659,74 @@
               <a:spcAft>
                 <a:spcPts val="400"/>
               </a:spcAft>
-              <a:defRPr sz="900">
-                <a:solidFill>
-                  <a:srgbClr val="94A3B8"/>
+            </a:pPr>
+            <a:r>
+              <a:rPr sz="950" b="1">
+                <a:solidFill>
+                  <a:srgbClr val="0B1F3A"/>
                 </a:solidFill>
                 <a:latin typeface="Calibri"/>
-              </a:defRPr>
-            </a:pPr>
-            <a:r>
-              <a:t>Laplace Smoothed Prior</a:t>
-            </a:r>
-          </a:p>
-          <a:p>
-            <a:pPr>
-              <a:defRPr sz="950" b="1">
-                <a:solidFill>
-                  <a:srgbClr val="2563EB"/>
+              </a:rPr>
+              <a:t>• Soft Voting Consensus: </a:t>
+            </a:r>
+            <a:r>
+              <a:rPr sz="900">
+                <a:solidFill>
+                  <a:srgbClr val="334155"/>
                 </a:solidFill>
                 <a:latin typeface="Calibri"/>
-              </a:defRPr>
-            </a:pPr>
-            <a:r>
-              <a:t>Output: P_MNB(c|x) ∈ R^40</a:t>
-            </a:r>
-          </a:p>
-        </p:txBody>
-      </p:sp>
-      <p:sp>
-        <p:nvSpPr>
-          <p:cNvPr id="12" name="Rounded Rectangle 11"/>
-          <p:cNvSpPr/>
-          <p:nvPr/>
-        </p:nvSpPr>
-        <p:spPr>
-          <a:xfrm>
-            <a:off x="457200" y="3931920"/>
-            <a:ext cx="11247120" cy="1371600"/>
-          </a:xfrm>
-          <a:prstGeom prst="roundRect">
-            <a:avLst/>
-          </a:prstGeom>
-          <a:solidFill>
-            <a:srgbClr val="FFFFFF"/>
-          </a:solidFill>
-          <a:ln w="19050">
-            <a:solidFill>
-              <a:srgbClr val="D97706"/>
-            </a:solidFill>
-          </a:ln>
-        </p:spPr>
-        <p:style>
-          <a:lnRef idx="1">
-            <a:schemeClr val="accent1"/>
-          </a:lnRef>
-          <a:fillRef idx="3">
-            <a:schemeClr val="accent1"/>
-          </a:fillRef>
-          <a:effectRef idx="2">
-            <a:schemeClr val="accent1"/>
-          </a:effectRef>
-          <a:fontRef idx="minor">
-            <a:schemeClr val="lt1"/>
-          </a:fontRef>
-        </p:style>
-        <p:txBody>
-          <a:bodyPr rtlCol="0" anchor="ctr" wrap="square" lIns="182880" tIns="109728"/>
-          <a:lstStyle/>
-          <a:p>
-            <a:pPr algn="ctr">
-              <a:spcAft>
-                <a:spcPts val="300"/>
-              </a:spcAft>
-              <a:defRPr sz="1100" b="1">
-                <a:solidFill>
-                  <a:srgbClr val="D97706"/>
-                </a:solidFill>
-                <a:latin typeface="Calibri"/>
-              </a:defRPr>
-            </a:pPr>
-            <a:r>
-              <a:t>STAGE 2: SOFT VOTING CONSENSUS &amp; PROBABILITY AGGREGATION</a:t>
+              </a:rPr>
+              <a:t>P_ensemble(c | x) = 1/4 Σ P_m(c | x) averages predicted probabilities across all 40 categories.</a:t>
             </a:r>
           </a:p>
           <a:p>
             <a:pPr>
               <a:spcAft>
-                <a:spcPts val="300"/>
+                <a:spcPts val="400"/>
               </a:spcAft>
-              <a:defRPr sz="1100" b="1">
-                <a:solidFill>
-                  <a:srgbClr val="0F172A"/>
-                </a:solidFill>
-                <a:latin typeface="Cambria"/>
-              </a:defRPr>
-            </a:pPr>
-            <a:r>
-              <a:t>Formula: P_Ensemble(c | x) = 1/4 · [ P_SVM(c | x) + P_RF(c | x) + P_LR(c | x) + P_MNB(c | x) ]   for all 40 categories c ∈ {1..40}</a:t>
+            </a:pPr>
+            <a:r>
+              <a:rPr sz="950" b="1">
+                <a:solidFill>
+                  <a:srgbClr val="0B1F3A"/>
+                </a:solidFill>
+                <a:latin typeface="Calibri"/>
+              </a:rPr>
+              <a:t>• Argmax Decision Rule: </a:t>
+            </a:r>
+            <a:r>
+              <a:rPr sz="900">
+                <a:solidFill>
+                  <a:srgbClr val="334155"/>
+                </a:solidFill>
+                <a:latin typeface="Calibri"/>
+              </a:rPr>
+              <a:t>The final medical specialty is selected as the class that maximizes the aggregated ensemble probability: ŷ = argmax P_ensemble(c | x).</a:t>
             </a:r>
           </a:p>
           <a:p>
             <a:pPr>
               <a:spcAft>
-                <a:spcPts val="300"/>
+                <a:spcPts val="400"/>
               </a:spcAft>
-              <a:defRPr sz="1100" b="1">
-                <a:solidFill>
-                  <a:srgbClr val="0E7C86"/>
-                </a:solidFill>
-                <a:latin typeface="Cambria"/>
-              </a:defRPr>
-            </a:pPr>
-            <a:r>
-              <a:t>Decision Rule: Predicted Medical Specialty c* = argmax_c P_Ensemble(c | x)   with Confidence Score = max_c P_Ensemble(c | x) · 100%</a:t>
-            </a:r>
-          </a:p>
-          <a:p>
-            <a:pPr>
-              <a:defRPr sz="950">
+            </a:pPr>
+            <a:r>
+              <a:rPr sz="950" b="1">
+                <a:solidFill>
+                  <a:srgbClr val="0B1F3A"/>
+                </a:solidFill>
+                <a:latin typeface="Calibri"/>
+              </a:rPr>
+              <a:t>• Variance Reduction: </a:t>
+            </a:r>
+            <a:r>
+              <a:rPr sz="900">
                 <a:solidFill>
                   <a:srgbClr val="334155"/>
                 </a:solidFill>
                 <a:latin typeface="Calibri"/>
-              </a:defRPr>
-            </a:pPr>
-            <a:r>
-              <a:t>Why Soft Voting? Averages confident probability outputs rather than simple discrete votes; mitigates individual estimator errors and smooths noise.</a:t>
-            </a:r>
-          </a:p>
-        </p:txBody>
-      </p:sp>
-      <p:sp>
-        <p:nvSpPr>
-          <p:cNvPr id="13" name="Rounded Rectangle 12"/>
-          <p:cNvSpPr/>
-          <p:nvPr/>
-        </p:nvSpPr>
-        <p:spPr>
-          <a:xfrm>
-            <a:off x="457200" y="5440680"/>
-            <a:ext cx="11247120" cy="868680"/>
-          </a:xfrm>
-          <a:prstGeom prst="roundRect">
-            <a:avLst/>
-          </a:prstGeom>
-          <a:solidFill>
-            <a:srgbClr val="13294B"/>
-          </a:solidFill>
-          <a:ln w="19050">
-            <a:solidFill>
-              <a:srgbClr val="00E5FF"/>
-            </a:solidFill>
-          </a:ln>
-        </p:spPr>
-        <p:style>
-          <a:lnRef idx="1">
-            <a:schemeClr val="accent1"/>
-          </a:lnRef>
-          <a:fillRef idx="3">
-            <a:schemeClr val="accent1"/>
-          </a:fillRef>
-          <a:effectRef idx="2">
-            <a:schemeClr val="accent1"/>
-          </a:effectRef>
-          <a:fontRef idx="minor">
-            <a:schemeClr val="lt1"/>
-          </a:fontRef>
-        </p:style>
-        <p:txBody>
-          <a:bodyPr rtlCol="0" anchor="ctr" wrap="square" lIns="182880" tIns="109728"/>
-          <a:lstStyle/>
-          <a:p>
-            <a:pPr algn="ctr">
-              <a:defRPr sz="1100" b="1">
-                <a:solidFill>
-                  <a:srgbClr val="38BDF8"/>
-                </a:solidFill>
-                <a:latin typeface="Calibri"/>
-              </a:defRPr>
-            </a:pPr>
-            <a:r>
-              <a:t>FINAL SYSTEM PREDICTION OUTPUT (STAGE 3)</a:t>
-            </a:r>
-          </a:p>
-          <a:p>
-            <a:pPr>
-              <a:defRPr sz="1000">
-                <a:solidFill>
-                  <a:srgbClr val="FFFFFF"/>
-                </a:solidFill>
-                <a:latin typeface="Calibri"/>
-              </a:defRPr>
-            </a:pPr>
-            <a:r>
-              <a:t>• Primary Prediction: Assigned Medical Specialty Class (e.g., 'Cardiovascular / Pulmonary')</a:t>
-            </a:r>
-            <a:br/>
-            <a:r>
-              <a:t>• Confidence Estimate: Aggregated ensemble probability score (%) verifying clinical prediction certainty</a:t>
+              </a:rPr>
+              <a:t>Compensates for individual estimator weaknesses, smoothing noise and stabilizing prediction on rare specialty classes.</a:t>
             </a:r>
           </a:p>
         </p:txBody>
@@ -10856,108 +8982,126 @@
       </p:sp>
       <p:sp>
         <p:nvSpPr>
-          <p:cNvPr id="8" name="Shape 6"/>
+          <p:cNvPr id="8" name="Rounded Rectangle 7"/>
           <p:cNvSpPr/>
           <p:nvPr/>
         </p:nvSpPr>
         <p:spPr>
           <a:xfrm>
-            <a:off x="457200" y="1481328"/>
-            <a:ext cx="11274552" cy="4937760"/>
+            <a:off x="457200" y="1325880"/>
+            <a:ext cx="11247120" cy="5074920"/>
           </a:xfrm>
           <a:prstGeom prst="roundRect">
-            <a:avLst>
-              <a:gd name="adj" fmla="val 1667"/>
-            </a:avLst>
+            <a:avLst/>
           </a:prstGeom>
           <a:solidFill>
             <a:srgbClr val="FFFFFF"/>
           </a:solidFill>
-          <a:ln w="12700">
+          <a:ln w="19050">
             <a:solidFill>
-              <a:srgbClr val="E3E8F0"/>
+              <a:srgbClr val="0E7C86"/>
             </a:solidFill>
-            <a:prstDash val="solid"/>
           </a:ln>
-          <a:effectLst>
-            <a:outerShdw sx="100000" sy="100000" kx="0" ky="0" algn="bl" rotWithShape="0" blurRad="101600" dist="25400" dir="5400000">
-              <a:srgbClr val="1B2A4A">
-                <a:alpha val="16000"/>
-              </a:srgbClr>
-            </a:outerShdw>
-          </a:effectLst>
-        </p:spPr>
-        <p:txBody>
-          <a:bodyPr/>
-          <a:p/>
+        </p:spPr>
+        <p:style>
+          <a:lnRef idx="1">
+            <a:schemeClr val="accent1"/>
+          </a:lnRef>
+          <a:fillRef idx="3">
+            <a:schemeClr val="accent1"/>
+          </a:fillRef>
+          <a:effectRef idx="2">
+            <a:schemeClr val="accent1"/>
+          </a:effectRef>
+          <a:fontRef idx="minor">
+            <a:schemeClr val="lt1"/>
+          </a:fontRef>
+        </p:style>
+        <p:txBody>
+          <a:bodyPr rtlCol="0" anchor="ctr"/>
+          <a:lstStyle/>
+          <a:p>
+            <a:pPr algn="ctr"/>
+          </a:p>
+        </p:txBody>
+      </p:sp>
+      <p:sp>
+        <p:nvSpPr>
+          <p:cNvPr id="9" name="Rounded Rectangle 8"/>
+          <p:cNvSpPr/>
+          <p:nvPr/>
+        </p:nvSpPr>
+        <p:spPr>
+          <a:xfrm>
+            <a:off x="594360" y="1417320"/>
+            <a:ext cx="10972800" cy="384048"/>
+          </a:xfrm>
+          <a:prstGeom prst="roundRect">
+            <a:avLst/>
+          </a:prstGeom>
+          <a:solidFill>
+            <a:srgbClr val="0E7C86"/>
+          </a:solidFill>
+          <a:ln>
+            <a:noFill/>
+          </a:ln>
+        </p:spPr>
+        <p:style>
+          <a:lnRef idx="1">
+            <a:schemeClr val="accent1"/>
+          </a:lnRef>
+          <a:fillRef idx="3">
+            <a:schemeClr val="accent1"/>
+          </a:fillRef>
+          <a:effectRef idx="2">
+            <a:schemeClr val="accent1"/>
+          </a:effectRef>
+          <a:fontRef idx="minor">
+            <a:schemeClr val="lt1"/>
+          </a:fontRef>
+        </p:style>
+        <p:txBody>
+          <a:bodyPr rtlCol="0" anchor="ctr"/>
+          <a:lstStyle/>
+          <a:p>
+            <a:pPr algn="ctr">
+              <a:defRPr sz="1100" b="1">
+                <a:solidFill>
+                  <a:srgbClr val="FFFFFF"/>
+                </a:solidFill>
+                <a:latin typeface="Calibri"/>
+              </a:defRPr>
+            </a:pPr>
+            <a:r>
+              <a:t>END-TO-END PROJECT PIPELINE DIAGRAM (FIGURE 13 FROM REPORT)</a:t>
+            </a:r>
+          </a:p>
         </p:txBody>
       </p:sp>
       <p:pic>
         <p:nvPicPr>
-          <p:cNvPr id="9" name="Image 0" descr="/home/claude/imgs/img-012.png">    </p:cNvPr>
+          <p:cNvPr id="10" name="Picture 9" descr="diagram_page_35_img_1.png"/>
           <p:cNvPicPr>
             <a:picLocks noChangeAspect="1"/>
           </p:cNvPicPr>
           <p:nvPr/>
         </p:nvPicPr>
         <p:blipFill>
-          <a:blip r:embed="rId1"/>
+          <a:blip r:embed="rId4"/>
           <a:stretch>
             <a:fillRect/>
           </a:stretch>
         </p:blipFill>
         <p:spPr>
           <a:xfrm>
-            <a:off x="3511753" y="1627632"/>
-            <a:ext cx="5168189" cy="4114800"/>
+            <a:off x="832104" y="1874519"/>
+            <a:ext cx="10515600" cy="8372293"/>
           </a:xfrm>
           <a:prstGeom prst="rect">
             <a:avLst/>
           </a:prstGeom>
         </p:spPr>
       </p:pic>
-      <p:sp>
-        <p:nvSpPr>
-          <p:cNvPr id="10" name="Text 7"/>
-          <p:cNvSpPr txBox="1"/>
-          <p:nvPr/>
-        </p:nvSpPr>
-        <p:spPr>
-          <a:xfrm>
-            <a:off x="777240" y="5797296"/>
-            <a:ext cx="10607040" cy="457200"/>
-          </a:xfrm>
-          <a:prstGeom prst="rect">
-            <a:avLst/>
-          </a:prstGeom>
-          <a:noFill/>
-          <a:ln/>
-        </p:spPr>
-        <p:txBody>
-          <a:bodyPr wrap="square" lIns="0" tIns="0" rIns="0" bIns="0" rtlCol="0" anchor="t"/>
-          <a:lstStyle/>
-          <a:p>
-            <a:pPr algn="ctr" indent="0" marL="0">
-              <a:lnSpc>
-                <a:spcPct val="110000"/>
-              </a:lnSpc>
-              <a:buNone/>
-            </a:pPr>
-            <a:r>
-              <a:rPr lang="en-US" sz="950" i="1" dirty="0">
-                <a:solidFill>
-                  <a:srgbClr val="5B6472"/>
-                </a:solidFill>
-                <a:latin typeface="Calibri" pitchFamily="34" charset="0"/>
-                <a:ea typeface="Calibri" pitchFamily="34" charset="-122"/>
-                <a:cs typeface="Calibri" pitchFamily="34" charset="-120"/>
-              </a:rPr>
-              <a:t>Three-stage pipeline: Data Preparation &amp; Partitioning → Model Building &amp; Ensemble → Deployment. TF-IDF is fit strictly on training data; the Flask deployment stage reuses the saved preprocessing + TF-IDF + ensemble pipeline.</a:t>
-            </a:r>
-            <a:endParaRPr lang="en-US" sz="950" dirty="0"/>
-          </a:p>
-        </p:txBody>
-      </p:sp>
     </p:spTree>
   </p:cSld>
   <p:clrMapOvr>

</xml_diff>

<commit_message>
feat: automate resizing and positioning of slide 16 image in presentation using python-pptx
</commit_message>
<xml_diff>
--- a/Medical_Specialty_Classification_Presentation.pptx
+++ b/Medical_Specialty_Classification_Presentation.pptx
@@ -9094,8 +9094,8 @@
         </p:blipFill>
         <p:spPr>
           <a:xfrm>
-            <a:off x="832104" y="1874519"/>
-            <a:ext cx="10515600" cy="8372293"/>
+            <a:off x="3368192" y="1874519"/>
+            <a:ext cx="5455310" cy="4343400"/>
           </a:xfrm>
           <a:prstGeom prst="rect">
             <a:avLst/>

</xml_diff>

<commit_message>
Please provide the changes or the file diffs you would like me to summarize.
</commit_message>
<xml_diff>
--- a/Medical_Specialty_Classification_Presentation.pptx
+++ b/Medical_Specialty_Classification_Presentation.pptx
@@ -11283,18 +11283,57 @@
       </p:sp>
       <p:sp>
         <p:nvSpPr>
-          <p:cNvPr id="8" name="Shape 6"/>
+          <p:cNvPr id="18" name="Text 16"/>
+          <p:cNvSpPr txBox="1"/>
+          <p:nvPr/>
+        </p:nvSpPr>
+        <p:spPr>
+          <a:xfrm>
+            <a:off x="457200" y="3794760"/>
+            <a:ext cx="5486400" cy="320040"/>
+          </a:xfrm>
+          <a:prstGeom prst="rect">
+            <a:avLst/>
+          </a:prstGeom>
+          <a:noFill/>
+          <a:ln/>
+        </p:spPr>
+        <p:txBody>
+          <a:bodyPr wrap="square" lIns="0" tIns="0" rIns="0" bIns="0" rtlCol="0" anchor="ctr"/>
+          <a:lstStyle/>
+          <a:p>
+            <a:pPr indent="0" marL="0">
+              <a:buNone/>
+            </a:pPr>
+            <a:r>
+              <a:rPr lang="en-US" sz="1500" b="1" dirty="0">
+                <a:solidFill>
+                  <a:srgbClr val="0B1F3A"/>
+                </a:solidFill>
+                <a:latin typeface="Cambria" pitchFamily="34" charset="0"/>
+                <a:ea typeface="Cambria" pitchFamily="34" charset="-122"/>
+                <a:cs typeface="Cambria" pitchFamily="34" charset="-120"/>
+              </a:rPr>
+              <a:t>Key Project Objectives</a:t>
+            </a:r>
+            <a:endParaRPr lang="en-US" sz="1500" dirty="0"/>
+          </a:p>
+        </p:txBody>
+      </p:sp>
+      <p:sp>
+        <p:nvSpPr>
+          <p:cNvPr id="19" name="Shape 17"/>
           <p:cNvSpPr/>
           <p:nvPr/>
         </p:nvSpPr>
         <p:spPr>
           <a:xfrm>
-            <a:off x="457200" y="1554480"/>
-            <a:ext cx="5394960" cy="1965960"/>
+            <a:off x="457200" y="4224528"/>
+            <a:ext cx="2743200" cy="1965960"/>
           </a:xfrm>
           <a:prstGeom prst="roundRect">
             <a:avLst>
-              <a:gd name="adj" fmla="val 4651"/>
+              <a:gd name="adj" fmla="val 4186"/>
             </a:avLst>
           </a:prstGeom>
           <a:solidFill>
@@ -11321,14 +11360,14 @@
       </p:sp>
       <p:sp>
         <p:nvSpPr>
-          <p:cNvPr id="9" name="Shape 7"/>
+          <p:cNvPr id="20" name="Shape 18"/>
           <p:cNvSpPr/>
           <p:nvPr/>
         </p:nvSpPr>
         <p:spPr>
           <a:xfrm>
-            <a:off x="768096" y="1837944"/>
-            <a:ext cx="566928" cy="566928"/>
+            <a:off x="1577340" y="4430268"/>
+            <a:ext cx="502920" cy="502920"/>
           </a:xfrm>
           <a:prstGeom prst="ellipse">
             <a:avLst/>
@@ -11345,14 +11384,14 @@
       </p:sp>
       <p:sp>
         <p:nvSpPr>
-          <p:cNvPr id="10" name="Text 8"/>
-          <p:cNvSpPr txBox="1"/>
-          <p:nvPr/>
-        </p:nvSpPr>
-        <p:spPr>
-          <a:xfrm>
-            <a:off x="768096" y="1837944"/>
-            <a:ext cx="566928" cy="566928"/>
+          <p:cNvPr id="21" name="Text 19"/>
+          <p:cNvSpPr txBox="1"/>
+          <p:nvPr/>
+        </p:nvSpPr>
+        <p:spPr>
+          <a:xfrm>
+            <a:off x="1577340" y="4430268"/>
+            <a:ext cx="502920" cy="502920"/>
           </a:xfrm>
           <a:prstGeom prst="rect">
             <a:avLst/>
@@ -11368,7 +11407,7 @@
               <a:buNone/>
             </a:pPr>
             <a:r>
-              <a:rPr lang="en-US" sz="2200" b="1" dirty="0">
+              <a:rPr lang="en-US" sz="1200" b="1" dirty="0">
                 <a:solidFill>
                   <a:srgbClr val="FFFFFF"/>
                 </a:solidFill>
@@ -11376,22 +11415,22 @@
                 <a:ea typeface="Calibri" pitchFamily="34" charset="-122"/>
                 <a:cs typeface="Calibri" pitchFamily="34" charset="-120"/>
               </a:rPr>
-              <a:t>!</a:t>
-            </a:r>
-            <a:endParaRPr lang="en-US" sz="2200" dirty="0"/>
-          </a:p>
-        </p:txBody>
-      </p:sp>
-      <p:sp>
-        <p:nvSpPr>
-          <p:cNvPr id="11" name="Text 9"/>
-          <p:cNvSpPr txBox="1"/>
-          <p:nvPr/>
-        </p:nvSpPr>
-        <p:spPr>
-          <a:xfrm>
-            <a:off x="1417320" y="1828800"/>
-            <a:ext cx="4206240" cy="365760"/>
+              <a:t>EDA</a:t>
+            </a:r>
+            <a:endParaRPr lang="en-US" sz="1200" dirty="0"/>
+          </a:p>
+        </p:txBody>
+      </p:sp>
+      <p:sp>
+        <p:nvSpPr>
+          <p:cNvPr id="22" name="Text 20"/>
+          <p:cNvSpPr txBox="1"/>
+          <p:nvPr/>
+        </p:nvSpPr>
+        <p:spPr>
+          <a:xfrm>
+            <a:off x="566928" y="5065776"/>
+            <a:ext cx="2523744" cy="320040"/>
           </a:xfrm>
           <a:prstGeom prst="rect">
             <a:avLst/>
@@ -11403,11 +11442,11 @@
           <a:bodyPr wrap="square" lIns="0" tIns="0" rIns="0" bIns="0" rtlCol="0" anchor="ctr"/>
           <a:lstStyle/>
           <a:p>
-            <a:pPr indent="0" marL="0">
-              <a:buNone/>
-            </a:pPr>
-            <a:r>
-              <a:rPr lang="en-US" sz="1600" b="1" dirty="0">
+            <a:pPr algn="ctr" indent="0" marL="0">
+              <a:buNone/>
+            </a:pPr>
+            <a:r>
+              <a:rPr lang="en-US" sz="1250" b="1" dirty="0">
                 <a:solidFill>
                   <a:srgbClr val="0B1F3A"/>
                 </a:solidFill>
@@ -11415,22 +11454,22 @@
                 <a:ea typeface="Cambria" pitchFamily="34" charset="-122"/>
                 <a:cs typeface="Cambria" pitchFamily="34" charset="-120"/>
               </a:rPr>
-              <a:t>Problem</a:t>
-            </a:r>
-            <a:endParaRPr lang="en-US" sz="1600" dirty="0"/>
-          </a:p>
-        </p:txBody>
-      </p:sp>
-      <p:sp>
-        <p:nvSpPr>
-          <p:cNvPr id="12" name="Text 10"/>
-          <p:cNvSpPr txBox="1"/>
-          <p:nvPr/>
-        </p:nvSpPr>
-        <p:spPr>
-          <a:xfrm>
-            <a:off x="777240" y="2331720"/>
-            <a:ext cx="4800600" cy="1097280"/>
+              <a:t>Explore &amp; Analyze</a:t>
+            </a:r>
+            <a:endParaRPr lang="en-US" sz="1250" dirty="0"/>
+          </a:p>
+        </p:txBody>
+      </p:sp>
+      <p:sp>
+        <p:nvSpPr>
+          <p:cNvPr id="23" name="Text 21"/>
+          <p:cNvSpPr txBox="1"/>
+          <p:nvPr/>
+        </p:nvSpPr>
+        <p:spPr>
+          <a:xfrm>
+            <a:off x="585216" y="5394960"/>
+            <a:ext cx="2487168" cy="713232"/>
           </a:xfrm>
           <a:prstGeom prst="rect">
             <a:avLst/>
@@ -11442,41 +11481,41 @@
           <a:bodyPr wrap="square" lIns="0" tIns="0" rIns="0" bIns="0" rtlCol="0" anchor="t"/>
           <a:lstStyle/>
           <a:p>
-            <a:pPr algn="l" indent="0" marL="0">
+            <a:pPr algn="ctr" indent="0" marL="0">
               <a:lnSpc>
-                <a:spcPct val="115000"/>
+                <a:spcPct val="110000"/>
               </a:lnSpc>
               <a:buNone/>
             </a:pPr>
             <a:r>
-              <a:rPr lang="en-US" sz="1250" dirty="0">
-                <a:solidFill>
-                  <a:srgbClr val="16213E"/>
+              <a:rPr lang="en-US" sz="1000" dirty="0">
+                <a:solidFill>
+                  <a:srgbClr val="5B6472"/>
                 </a:solidFill>
                 <a:latin typeface="Calibri" pitchFamily="34" charset="0"/>
                 <a:ea typeface="Calibri" pitchFamily="34" charset="-122"/>
                 <a:cs typeface="Calibri" pitchFamily="34" charset="-120"/>
               </a:rPr>
-              <a:t>Clinical transcription data is unstructured and can belong to any of several medical specialties, making manual categorization by medical coders slow, inconsistent, and prone to human error as patient volumes grow.</a:t>
-            </a:r>
-            <a:endParaRPr lang="en-US" sz="1250" dirty="0"/>
-          </a:p>
-        </p:txBody>
-      </p:sp>
-      <p:sp>
-        <p:nvSpPr>
-          <p:cNvPr id="13" name="Shape 11"/>
+              <a:t>Conduct EDA on the Kaggle MTSamples clinical transcription dataset.</a:t>
+            </a:r>
+            <a:endParaRPr lang="en-US" sz="1000" dirty="0"/>
+          </a:p>
+        </p:txBody>
+      </p:sp>
+      <p:sp>
+        <p:nvSpPr>
+          <p:cNvPr id="24" name="Shape 22"/>
           <p:cNvSpPr/>
           <p:nvPr/>
         </p:nvSpPr>
         <p:spPr>
           <a:xfrm>
-            <a:off x="6035040" y="1554480"/>
-            <a:ext cx="5696712" cy="1965960"/>
+            <a:off x="3337560" y="4224528"/>
+            <a:ext cx="2743200" cy="1965960"/>
           </a:xfrm>
           <a:prstGeom prst="roundRect">
             <a:avLst>
-              <a:gd name="adj" fmla="val 4651"/>
+              <a:gd name="adj" fmla="val 4186"/>
             </a:avLst>
           </a:prstGeom>
           <a:solidFill>
@@ -11503,14 +11542,14 @@
       </p:sp>
       <p:sp>
         <p:nvSpPr>
-          <p:cNvPr id="14" name="Shape 12"/>
+          <p:cNvPr id="25" name="Shape 23"/>
           <p:cNvSpPr/>
           <p:nvPr/>
         </p:nvSpPr>
         <p:spPr>
           <a:xfrm>
-            <a:off x="6345936" y="1837944"/>
-            <a:ext cx="566928" cy="566928"/>
+            <a:off x="4457700" y="4430268"/>
+            <a:ext cx="502920" cy="502920"/>
           </a:xfrm>
           <a:prstGeom prst="ellipse">
             <a:avLst/>
@@ -11527,14 +11566,14 @@
       </p:sp>
       <p:sp>
         <p:nvSpPr>
-          <p:cNvPr id="15" name="Text 13"/>
-          <p:cNvSpPr txBox="1"/>
-          <p:nvPr/>
-        </p:nvSpPr>
-        <p:spPr>
-          <a:xfrm>
-            <a:off x="6345936" y="1837944"/>
-            <a:ext cx="566928" cy="566928"/>
+          <p:cNvPr id="26" name="Text 24"/>
+          <p:cNvSpPr txBox="1"/>
+          <p:nvPr/>
+        </p:nvSpPr>
+        <p:spPr>
+          <a:xfrm>
+            <a:off x="4457700" y="4430268"/>
+            <a:ext cx="502920" cy="502920"/>
           </a:xfrm>
           <a:prstGeom prst="rect">
             <a:avLst/>
@@ -11550,7 +11589,7 @@
               <a:buNone/>
             </a:pPr>
             <a:r>
-              <a:rPr lang="en-US" sz="2200" b="1" dirty="0">
+              <a:rPr lang="en-US" sz="1200" b="1" dirty="0">
                 <a:solidFill>
                   <a:srgbClr val="FFFFFF"/>
                 </a:solidFill>
@@ -11558,22 +11597,22 @@
                 <a:ea typeface="Calibri" pitchFamily="34" charset="-122"/>
                 <a:cs typeface="Calibri" pitchFamily="34" charset="-120"/>
               </a:rPr>
-              <a:t>→</a:t>
-            </a:r>
-            <a:endParaRPr lang="en-US" sz="2200" dirty="0"/>
-          </a:p>
-        </p:txBody>
-      </p:sp>
-      <p:sp>
-        <p:nvSpPr>
-          <p:cNvPr id="16" name="Text 14"/>
-          <p:cNvSpPr txBox="1"/>
-          <p:nvPr/>
-        </p:nvSpPr>
-        <p:spPr>
-          <a:xfrm>
-            <a:off x="6995160" y="1828800"/>
-            <a:ext cx="4572000" cy="365760"/>
+              <a:t>NLP</a:t>
+            </a:r>
+            <a:endParaRPr lang="en-US" sz="1200" dirty="0"/>
+          </a:p>
+        </p:txBody>
+      </p:sp>
+      <p:sp>
+        <p:nvSpPr>
+          <p:cNvPr id="27" name="Text 25"/>
+          <p:cNvSpPr txBox="1"/>
+          <p:nvPr/>
+        </p:nvSpPr>
+        <p:spPr>
+          <a:xfrm>
+            <a:off x="3447288" y="5065776"/>
+            <a:ext cx="2523744" cy="320040"/>
           </a:xfrm>
           <a:prstGeom prst="rect">
             <a:avLst/>
@@ -11585,11 +11624,11 @@
           <a:bodyPr wrap="square" lIns="0" tIns="0" rIns="0" bIns="0" rtlCol="0" anchor="ctr"/>
           <a:lstStyle/>
           <a:p>
-            <a:pPr indent="0" marL="0">
-              <a:buNone/>
-            </a:pPr>
-            <a:r>
-              <a:rPr lang="en-US" sz="1600" b="1" dirty="0">
+            <a:pPr algn="ctr" indent="0" marL="0">
+              <a:buNone/>
+            </a:pPr>
+            <a:r>
+              <a:rPr lang="en-US" sz="1250" b="1" dirty="0">
                 <a:solidFill>
                   <a:srgbClr val="0B1F3A"/>
                 </a:solidFill>
@@ -11597,22 +11636,22 @@
                 <a:ea typeface="Cambria" pitchFamily="34" charset="-122"/>
                 <a:cs typeface="Cambria" pitchFamily="34" charset="-120"/>
               </a:rPr>
-              <a:t>Objective</a:t>
-            </a:r>
-            <a:endParaRPr lang="en-US" sz="1600" dirty="0"/>
-          </a:p>
-        </p:txBody>
-      </p:sp>
-      <p:sp>
-        <p:nvSpPr>
-          <p:cNvPr id="17" name="Text 15"/>
-          <p:cNvSpPr txBox="1"/>
-          <p:nvPr/>
-        </p:nvSpPr>
-        <p:spPr>
-          <a:xfrm>
-            <a:off x="6355080" y="2331720"/>
-            <a:ext cx="5120640" cy="1097280"/>
+              <a:t>Preprocess Text</a:t>
+            </a:r>
+            <a:endParaRPr lang="en-US" sz="1250" dirty="0"/>
+          </a:p>
+        </p:txBody>
+      </p:sp>
+      <p:sp>
+        <p:nvSpPr>
+          <p:cNvPr id="28" name="Text 26"/>
+          <p:cNvSpPr txBox="1"/>
+          <p:nvPr/>
+        </p:nvSpPr>
+        <p:spPr>
+          <a:xfrm>
+            <a:off x="3465576" y="5394960"/>
+            <a:ext cx="2487168" cy="713232"/>
           </a:xfrm>
           <a:prstGeom prst="rect">
             <a:avLst/>
@@ -11624,75 +11663,36 @@
           <a:bodyPr wrap="square" lIns="0" tIns="0" rIns="0" bIns="0" rtlCol="0" anchor="t"/>
           <a:lstStyle/>
           <a:p>
-            <a:pPr algn="l" indent="0" marL="0">
+            <a:pPr algn="ctr" indent="0" marL="0">
               <a:lnSpc>
-                <a:spcPct val="115000"/>
+                <a:spcPct val="110000"/>
               </a:lnSpc>
               <a:buNone/>
             </a:pPr>
             <a:r>
-              <a:rPr lang="en-US" sz="1250" dirty="0">
-                <a:solidFill>
-                  <a:srgbClr val="16213E"/>
+              <a:rPr lang="en-US" sz="1000" dirty="0">
+                <a:solidFill>
+                  <a:srgbClr val="5B6472"/>
                 </a:solidFill>
                 <a:latin typeface="Calibri" pitchFamily="34" charset="0"/>
                 <a:ea typeface="Calibri" pitchFamily="34" charset="-122"/>
                 <a:cs typeface="Calibri" pitchFamily="34" charset="-120"/>
               </a:rPr>
-              <a:t>Develop an automated NLP and Ensemble Machine Learning system that predicts the correct medical specialty from a clinical transcription, reducing administrative overhead and speeding up document routing.</a:t>
-            </a:r>
-            <a:endParaRPr lang="en-US" sz="1250" dirty="0"/>
-          </a:p>
-        </p:txBody>
-      </p:sp>
-      <p:sp>
-        <p:nvSpPr>
-          <p:cNvPr id="18" name="Text 16"/>
-          <p:cNvSpPr txBox="1"/>
-          <p:nvPr/>
-        </p:nvSpPr>
-        <p:spPr>
-          <a:xfrm>
-            <a:off x="457200" y="3794760"/>
-            <a:ext cx="5486400" cy="320040"/>
-          </a:xfrm>
-          <a:prstGeom prst="rect">
-            <a:avLst/>
-          </a:prstGeom>
-          <a:noFill/>
-          <a:ln/>
-        </p:spPr>
-        <p:txBody>
-          <a:bodyPr wrap="square" lIns="0" tIns="0" rIns="0" bIns="0" rtlCol="0" anchor="ctr"/>
-          <a:lstStyle/>
-          <a:p>
-            <a:pPr indent="0" marL="0">
-              <a:buNone/>
-            </a:pPr>
-            <a:r>
-              <a:rPr lang="en-US" sz="1500" b="1" dirty="0">
-                <a:solidFill>
-                  <a:srgbClr val="0B1F3A"/>
-                </a:solidFill>
-                <a:latin typeface="Cambria" pitchFamily="34" charset="0"/>
-                <a:ea typeface="Cambria" pitchFamily="34" charset="-122"/>
-                <a:cs typeface="Cambria" pitchFamily="34" charset="-120"/>
-              </a:rPr>
-              <a:t>Key Project Objectives</a:t>
-            </a:r>
-            <a:endParaRPr lang="en-US" sz="1500" dirty="0"/>
-          </a:p>
-        </p:txBody>
-      </p:sp>
-      <p:sp>
-        <p:nvSpPr>
-          <p:cNvPr id="19" name="Shape 17"/>
+              <a:t>Clean, tokenize, remove stop-words and lemmatize clinical narratives.</a:t>
+            </a:r>
+            <a:endParaRPr lang="en-US" sz="1000" dirty="0"/>
+          </a:p>
+        </p:txBody>
+      </p:sp>
+      <p:sp>
+        <p:nvSpPr>
+          <p:cNvPr id="29" name="Shape 27"/>
           <p:cNvSpPr/>
           <p:nvPr/>
         </p:nvSpPr>
         <p:spPr>
           <a:xfrm>
-            <a:off x="457200" y="4224528"/>
+            <a:off x="6217920" y="4224528"/>
             <a:ext cx="2743200" cy="1965960"/>
           </a:xfrm>
           <a:prstGeom prst="roundRect">
@@ -11724,20 +11724,20 @@
       </p:sp>
       <p:sp>
         <p:nvSpPr>
-          <p:cNvPr id="20" name="Shape 18"/>
+          <p:cNvPr id="30" name="Shape 28"/>
           <p:cNvSpPr/>
           <p:nvPr/>
         </p:nvSpPr>
         <p:spPr>
           <a:xfrm>
-            <a:off x="1577340" y="4430268"/>
+            <a:off x="7338060" y="4430268"/>
             <a:ext cx="502920" cy="502920"/>
           </a:xfrm>
           <a:prstGeom prst="ellipse">
             <a:avLst/>
           </a:prstGeom>
           <a:solidFill>
-            <a:srgbClr val="6C4AB6"/>
+            <a:srgbClr val="13294B"/>
           </a:solidFill>
           <a:ln/>
         </p:spPr>
@@ -11748,13 +11748,13 @@
       </p:sp>
       <p:sp>
         <p:nvSpPr>
-          <p:cNvPr id="21" name="Text 19"/>
-          <p:cNvSpPr txBox="1"/>
-          <p:nvPr/>
-        </p:nvSpPr>
-        <p:spPr>
-          <a:xfrm>
-            <a:off x="1577340" y="4430268"/>
+          <p:cNvPr id="31" name="Text 29"/>
+          <p:cNvSpPr txBox="1"/>
+          <p:nvPr/>
+        </p:nvSpPr>
+        <p:spPr>
+          <a:xfrm>
+            <a:off x="7338060" y="4430268"/>
             <a:ext cx="502920" cy="502920"/>
           </a:xfrm>
           <a:prstGeom prst="rect">
@@ -11779,7 +11779,7 @@
                 <a:ea typeface="Calibri" pitchFamily="34" charset="-122"/>
                 <a:cs typeface="Calibri" pitchFamily="34" charset="-120"/>
               </a:rPr>
-              <a:t>EDA</a:t>
+              <a:t>TF</a:t>
             </a:r>
             <a:endParaRPr lang="en-US" sz="1200" dirty="0"/>
           </a:p>
@@ -11787,13 +11787,13 @@
       </p:sp>
       <p:sp>
         <p:nvSpPr>
-          <p:cNvPr id="22" name="Text 20"/>
-          <p:cNvSpPr txBox="1"/>
-          <p:nvPr/>
-        </p:nvSpPr>
-        <p:spPr>
-          <a:xfrm>
-            <a:off x="566928" y="5065776"/>
+          <p:cNvPr id="32" name="Text 30"/>
+          <p:cNvSpPr txBox="1"/>
+          <p:nvPr/>
+        </p:nvSpPr>
+        <p:spPr>
+          <a:xfrm>
+            <a:off x="6327648" y="5065776"/>
             <a:ext cx="2523744" cy="320040"/>
           </a:xfrm>
           <a:prstGeom prst="rect">
@@ -11818,7 +11818,7 @@
                 <a:ea typeface="Cambria" pitchFamily="34" charset="-122"/>
                 <a:cs typeface="Cambria" pitchFamily="34" charset="-120"/>
               </a:rPr>
-              <a:t>Explore &amp; Analyze</a:t>
+              <a:t>Extract Features</a:t>
             </a:r>
             <a:endParaRPr lang="en-US" sz="1250" dirty="0"/>
           </a:p>
@@ -11826,13 +11826,13 @@
       </p:sp>
       <p:sp>
         <p:nvSpPr>
-          <p:cNvPr id="23" name="Text 21"/>
-          <p:cNvSpPr txBox="1"/>
-          <p:nvPr/>
-        </p:nvSpPr>
-        <p:spPr>
-          <a:xfrm>
-            <a:off x="585216" y="5394960"/>
+          <p:cNvPr id="33" name="Text 31"/>
+          <p:cNvSpPr txBox="1"/>
+          <p:nvPr/>
+        </p:nvSpPr>
+        <p:spPr>
+          <a:xfrm>
+            <a:off x="6345936" y="5394960"/>
             <a:ext cx="2487168" cy="713232"/>
           </a:xfrm>
           <a:prstGeom prst="rect">
@@ -11860,7 +11860,7 @@
                 <a:ea typeface="Calibri" pitchFamily="34" charset="-122"/>
                 <a:cs typeface="Calibri" pitchFamily="34" charset="-120"/>
               </a:rPr>
-              <a:t>Conduct EDA on the Kaggle MTSamples clinical transcription dataset.</a:t>
+              <a:t>Vectorize clinical text into numeric form using TF-IDF.</a:t>
             </a:r>
             <a:endParaRPr lang="en-US" sz="1000" dirty="0"/>
           </a:p>
@@ -11868,13 +11868,13 @@
       </p:sp>
       <p:sp>
         <p:nvSpPr>
-          <p:cNvPr id="24" name="Shape 22"/>
+          <p:cNvPr id="34" name="Shape 32"/>
           <p:cNvSpPr/>
           <p:nvPr/>
         </p:nvSpPr>
         <p:spPr>
           <a:xfrm>
-            <a:off x="3337560" y="4224528"/>
+            <a:off x="9098280" y="4224528"/>
             <a:ext cx="2743200" cy="1965960"/>
           </a:xfrm>
           <a:prstGeom prst="roundRect">
@@ -11906,20 +11906,20 @@
       </p:sp>
       <p:sp>
         <p:nvSpPr>
-          <p:cNvPr id="25" name="Shape 23"/>
+          <p:cNvPr id="35" name="Shape 33"/>
           <p:cNvSpPr/>
           <p:nvPr/>
         </p:nvSpPr>
         <p:spPr>
           <a:xfrm>
-            <a:off x="4457700" y="4430268"/>
+            <a:off x="10218420" y="4430268"/>
             <a:ext cx="502920" cy="502920"/>
           </a:xfrm>
           <a:prstGeom prst="ellipse">
             <a:avLst/>
           </a:prstGeom>
           <a:solidFill>
-            <a:srgbClr val="0E7C86"/>
+            <a:srgbClr val="6C4AB6"/>
           </a:solidFill>
           <a:ln/>
         </p:spPr>
@@ -11930,13 +11930,13 @@
       </p:sp>
       <p:sp>
         <p:nvSpPr>
-          <p:cNvPr id="26" name="Text 24"/>
-          <p:cNvSpPr txBox="1"/>
-          <p:nvPr/>
-        </p:nvSpPr>
-        <p:spPr>
-          <a:xfrm>
-            <a:off x="4457700" y="4430268"/>
+          <p:cNvPr id="36" name="Text 34"/>
+          <p:cNvSpPr txBox="1"/>
+          <p:nvPr/>
+        </p:nvSpPr>
+        <p:spPr>
+          <a:xfrm>
+            <a:off x="10218420" y="4430268"/>
             <a:ext cx="502920" cy="502920"/>
           </a:xfrm>
           <a:prstGeom prst="rect">
@@ -11961,7 +11961,7 @@
                 <a:ea typeface="Calibri" pitchFamily="34" charset="-122"/>
                 <a:cs typeface="Calibri" pitchFamily="34" charset="-120"/>
               </a:rPr>
-              <a:t>NLP</a:t>
+              <a:t>⊕</a:t>
             </a:r>
             <a:endParaRPr lang="en-US" sz="1200" dirty="0"/>
           </a:p>
@@ -11969,13 +11969,13 @@
       </p:sp>
       <p:sp>
         <p:nvSpPr>
-          <p:cNvPr id="27" name="Text 25"/>
-          <p:cNvSpPr txBox="1"/>
-          <p:nvPr/>
-        </p:nvSpPr>
-        <p:spPr>
-          <a:xfrm>
-            <a:off x="3447288" y="5065776"/>
+          <p:cNvPr id="37" name="Text 35"/>
+          <p:cNvSpPr txBox="1"/>
+          <p:nvPr/>
+        </p:nvSpPr>
+        <p:spPr>
+          <a:xfrm>
+            <a:off x="9208008" y="5065776"/>
             <a:ext cx="2523744" cy="320040"/>
           </a:xfrm>
           <a:prstGeom prst="rect">
@@ -12000,7 +12000,7 @@
                 <a:ea typeface="Cambria" pitchFamily="34" charset="-122"/>
                 <a:cs typeface="Cambria" pitchFamily="34" charset="-120"/>
               </a:rPr>
-              <a:t>Preprocess Text</a:t>
+              <a:t>Ensemble &amp; Deploy</a:t>
             </a:r>
             <a:endParaRPr lang="en-US" sz="1250" dirty="0"/>
           </a:p>
@@ -12008,13 +12008,13 @@
       </p:sp>
       <p:sp>
         <p:nvSpPr>
-          <p:cNvPr id="28" name="Text 26"/>
-          <p:cNvSpPr txBox="1"/>
-          <p:nvPr/>
-        </p:nvSpPr>
-        <p:spPr>
-          <a:xfrm>
-            <a:off x="3465576" y="5394960"/>
+          <p:cNvPr id="38" name="Text 36"/>
+          <p:cNvSpPr txBox="1"/>
+          <p:nvPr/>
+        </p:nvSpPr>
+        <p:spPr>
+          <a:xfrm>
+            <a:off x="9226296" y="5394960"/>
             <a:ext cx="2487168" cy="713232"/>
           </a:xfrm>
           <a:prstGeom prst="rect">
@@ -12042,7 +12042,7 @@
                 <a:ea typeface="Calibri" pitchFamily="34" charset="-122"/>
                 <a:cs typeface="Calibri" pitchFamily="34" charset="-120"/>
               </a:rPr>
-              <a:t>Clean, tokenize, remove stop-words and lemmatize clinical narratives.</a:t>
+              <a:t>Combine SVM, RF, LR, MNB via Voting; deploy on a Flask web app.</a:t>
             </a:r>
             <a:endParaRPr lang="en-US" sz="1000" dirty="0"/>
           </a:p>
@@ -12050,365 +12050,341 @@
       </p:sp>
       <p:sp>
         <p:nvSpPr>
-          <p:cNvPr id="29" name="Shape 27"/>
+          <p:cNvPr id="39" name="Rounded Rectangle 38"/>
           <p:cNvSpPr/>
           <p:nvPr/>
         </p:nvSpPr>
         <p:spPr>
           <a:xfrm>
-            <a:off x="6217920" y="4224528"/>
-            <a:ext cx="2743200" cy="1965960"/>
+            <a:off x="457200" y="1554480"/>
+            <a:ext cx="5394960" cy="2011680"/>
           </a:xfrm>
           <a:prstGeom prst="roundRect">
-            <a:avLst>
-              <a:gd name="adj" fmla="val 4186"/>
-            </a:avLst>
+            <a:avLst/>
           </a:prstGeom>
           <a:solidFill>
             <a:srgbClr val="FFFFFF"/>
           </a:solidFill>
-          <a:ln w="12700">
+          <a:ln w="19050">
             <a:solidFill>
-              <a:srgbClr val="E3E8F0"/>
+              <a:srgbClr val="E2E8F0"/>
             </a:solidFill>
-            <a:prstDash val="solid"/>
           </a:ln>
-          <a:effectLst>
-            <a:outerShdw sx="100000" sy="100000" kx="0" ky="0" algn="bl" rotWithShape="0" blurRad="101600" dist="25400" dir="5400000">
-              <a:srgbClr val="1B2A4A">
-                <a:alpha val="16000"/>
-              </a:srgbClr>
-            </a:outerShdw>
-          </a:effectLst>
-        </p:spPr>
-        <p:txBody>
-          <a:bodyPr/>
-          <a:p/>
-        </p:txBody>
-      </p:sp>
-      <p:sp>
-        <p:nvSpPr>
-          <p:cNvPr id="30" name="Shape 28"/>
+        </p:spPr>
+        <p:style>
+          <a:lnRef idx="1">
+            <a:schemeClr val="accent1"/>
+          </a:lnRef>
+          <a:fillRef idx="3">
+            <a:schemeClr val="accent1"/>
+          </a:fillRef>
+          <a:effectRef idx="2">
+            <a:schemeClr val="accent1"/>
+          </a:effectRef>
+          <a:fontRef idx="minor">
+            <a:schemeClr val="lt1"/>
+          </a:fontRef>
+        </p:style>
+        <p:txBody>
+          <a:bodyPr rtlCol="0" anchor="ctr"/>
+          <a:lstStyle/>
+          <a:p>
+            <a:pPr algn="ctr"/>
+          </a:p>
+        </p:txBody>
+      </p:sp>
+      <p:sp>
+        <p:nvSpPr>
+          <p:cNvPr id="40" name="Oval 39"/>
           <p:cNvSpPr/>
           <p:nvPr/>
         </p:nvSpPr>
         <p:spPr>
           <a:xfrm>
-            <a:off x="7338060" y="4430268"/>
-            <a:ext cx="502920" cy="502920"/>
+            <a:off x="777240" y="1755648"/>
+            <a:ext cx="438912" cy="438912"/>
           </a:xfrm>
           <a:prstGeom prst="ellipse">
             <a:avLst/>
           </a:prstGeom>
           <a:solidFill>
-            <a:srgbClr val="13294B"/>
+            <a:srgbClr val="6C4AB6"/>
           </a:solidFill>
-          <a:ln/>
-        </p:spPr>
-        <p:txBody>
-          <a:bodyPr/>
-          <a:p/>
-        </p:txBody>
-      </p:sp>
-      <p:sp>
-        <p:nvSpPr>
-          <p:cNvPr id="31" name="Text 29"/>
-          <p:cNvSpPr txBox="1"/>
-          <p:nvPr/>
-        </p:nvSpPr>
-        <p:spPr>
-          <a:xfrm>
-            <a:off x="7338060" y="4430268"/>
-            <a:ext cx="502920" cy="502920"/>
-          </a:xfrm>
-          <a:prstGeom prst="rect">
-            <a:avLst/>
-          </a:prstGeom>
-          <a:noFill/>
-          <a:ln/>
-        </p:spPr>
-        <p:txBody>
-          <a:bodyPr wrap="square" lIns="0" tIns="0" rIns="0" bIns="0" rtlCol="0" anchor="ctr"/>
-          <a:lstStyle/>
-          <a:p>
-            <a:pPr algn="ctr" indent="0" marL="0">
-              <a:buNone/>
-            </a:pPr>
-            <a:r>
-              <a:rPr lang="en-US" sz="1200" b="1" dirty="0">
+          <a:ln>
+            <a:noFill/>
+          </a:ln>
+        </p:spPr>
+        <p:style>
+          <a:lnRef idx="1">
+            <a:schemeClr val="accent1"/>
+          </a:lnRef>
+          <a:fillRef idx="3">
+            <a:schemeClr val="accent1"/>
+          </a:fillRef>
+          <a:effectRef idx="2">
+            <a:schemeClr val="accent1"/>
+          </a:effectRef>
+          <a:fontRef idx="minor">
+            <a:schemeClr val="lt1"/>
+          </a:fontRef>
+        </p:style>
+        <p:txBody>
+          <a:bodyPr rtlCol="0" anchor="ctr"/>
+          <a:lstStyle/>
+          <a:p>
+            <a:pPr algn="ctr">
+              <a:defRPr sz="1800" b="1">
                 <a:solidFill>
                   <a:srgbClr val="FFFFFF"/>
                 </a:solidFill>
-                <a:latin typeface="Calibri" pitchFamily="34" charset="0"/>
-                <a:ea typeface="Calibri" pitchFamily="34" charset="-122"/>
-                <a:cs typeface="Calibri" pitchFamily="34" charset="-120"/>
-              </a:rPr>
-              <a:t>TF</a:t>
-            </a:r>
-            <a:endParaRPr lang="en-US" sz="1200" dirty="0"/>
-          </a:p>
-        </p:txBody>
-      </p:sp>
-      <p:sp>
-        <p:nvSpPr>
-          <p:cNvPr id="32" name="Text 30"/>
-          <p:cNvSpPr txBox="1"/>
-          <p:nvPr/>
-        </p:nvSpPr>
-        <p:spPr>
-          <a:xfrm>
-            <a:off x="6327648" y="5065776"/>
-            <a:ext cx="2523744" cy="320040"/>
-          </a:xfrm>
-          <a:prstGeom prst="rect">
-            <a:avLst/>
-          </a:prstGeom>
-          <a:noFill/>
-          <a:ln/>
-        </p:spPr>
-        <p:txBody>
-          <a:bodyPr wrap="square" lIns="0" tIns="0" rIns="0" bIns="0" rtlCol="0" anchor="ctr"/>
-          <a:lstStyle/>
-          <a:p>
-            <a:pPr algn="ctr" indent="0" marL="0">
-              <a:buNone/>
-            </a:pPr>
-            <a:r>
-              <a:rPr lang="en-US" sz="1250" b="1" dirty="0">
+                <a:latin typeface="Calibri"/>
+              </a:defRPr>
+            </a:pPr>
+            <a:r>
+              <a:t>!</a:t>
+            </a:r>
+          </a:p>
+        </p:txBody>
+      </p:sp>
+      <p:sp>
+        <p:nvSpPr>
+          <p:cNvPr id="41" name="TextBox 40"/>
+          <p:cNvSpPr txBox="1"/>
+          <p:nvPr/>
+        </p:nvSpPr>
+        <p:spPr>
+          <a:xfrm>
+            <a:off x="1353312" y="1755648"/>
+            <a:ext cx="4297680" cy="438912"/>
+          </a:xfrm>
+          <a:prstGeom prst="rect">
+            <a:avLst/>
+          </a:prstGeom>
+          <a:noFill/>
+        </p:spPr>
+        <p:txBody>
+          <a:bodyPr wrap="none" anchor="ctr" lIns="45720">
+            <a:spAutoFit/>
+          </a:bodyPr>
+          <a:lstStyle/>
+          <a:p>
+            <a:pPr>
+              <a:defRPr sz="2000" b="1">
                 <a:solidFill>
                   <a:srgbClr val="0B1F3A"/>
                 </a:solidFill>
-                <a:latin typeface="Cambria" pitchFamily="34" charset="0"/>
-                <a:ea typeface="Cambria" pitchFamily="34" charset="-122"/>
-                <a:cs typeface="Cambria" pitchFamily="34" charset="-120"/>
-              </a:rPr>
-              <a:t>Extract Features</a:t>
-            </a:r>
-            <a:endParaRPr lang="en-US" sz="1250" dirty="0"/>
-          </a:p>
-        </p:txBody>
-      </p:sp>
-      <p:sp>
-        <p:nvSpPr>
-          <p:cNvPr id="33" name="Text 31"/>
-          <p:cNvSpPr txBox="1"/>
-          <p:nvPr/>
-        </p:nvSpPr>
-        <p:spPr>
-          <a:xfrm>
-            <a:off x="6345936" y="5394960"/>
-            <a:ext cx="2487168" cy="713232"/>
-          </a:xfrm>
-          <a:prstGeom prst="rect">
-            <a:avLst/>
-          </a:prstGeom>
-          <a:noFill/>
-          <a:ln/>
-        </p:spPr>
-        <p:txBody>
-          <a:bodyPr wrap="square" lIns="0" tIns="0" rIns="0" bIns="0" rtlCol="0" anchor="t"/>
-          <a:lstStyle/>
-          <a:p>
-            <a:pPr algn="ctr" indent="0" marL="0">
-              <a:lnSpc>
-                <a:spcPct val="110000"/>
-              </a:lnSpc>
-              <a:buNone/>
-            </a:pPr>
-            <a:r>
-              <a:rPr lang="en-US" sz="1000" dirty="0">
-                <a:solidFill>
-                  <a:srgbClr val="5B6472"/>
-                </a:solidFill>
-                <a:latin typeface="Calibri" pitchFamily="34" charset="0"/>
-                <a:ea typeface="Calibri" pitchFamily="34" charset="-122"/>
-                <a:cs typeface="Calibri" pitchFamily="34" charset="-120"/>
-              </a:rPr>
-              <a:t>Vectorize clinical text into numeric form using TF-IDF.</a:t>
-            </a:r>
-            <a:endParaRPr lang="en-US" sz="1000" dirty="0"/>
-          </a:p>
-        </p:txBody>
-      </p:sp>
-      <p:sp>
-        <p:nvSpPr>
-          <p:cNvPr id="34" name="Shape 32"/>
+                <a:latin typeface="Cambria"/>
+              </a:defRPr>
+            </a:pPr>
+            <a:r>
+              <a:t>Problem</a:t>
+            </a:r>
+          </a:p>
+        </p:txBody>
+      </p:sp>
+      <p:sp>
+        <p:nvSpPr>
+          <p:cNvPr id="42" name="TextBox 41"/>
+          <p:cNvSpPr txBox="1"/>
+          <p:nvPr/>
+        </p:nvSpPr>
+        <p:spPr>
+          <a:xfrm>
+            <a:off x="777240" y="2331720"/>
+            <a:ext cx="4800600" cy="1097280"/>
+          </a:xfrm>
+          <a:prstGeom prst="rect">
+            <a:avLst/>
+          </a:prstGeom>
+          <a:noFill/>
+        </p:spPr>
+        <p:txBody>
+          <a:bodyPr wrap="square" lIns="0" rIns="0" tIns="0">
+            <a:spAutoFit/>
+          </a:bodyPr>
+          <a:lstStyle/>
+          <a:p>
+            <a:pPr>
+              <a:defRPr sz="1150">
+                <a:solidFill>
+                  <a:srgbClr val="334155"/>
+                </a:solidFill>
+                <a:latin typeface="Calibri"/>
+              </a:defRPr>
+            </a:pPr>
+            <a:r>
+              <a:t>Clinical transcription data is unstructured and can belong to any of several medical specialties, making manual categorization by medical coders slow, inconsistent, and prone to human error as patient volumes grow.</a:t>
+            </a:r>
+          </a:p>
+        </p:txBody>
+      </p:sp>
+      <p:sp>
+        <p:nvSpPr>
+          <p:cNvPr id="43" name="Rounded Rectangle 42"/>
           <p:cNvSpPr/>
           <p:nvPr/>
         </p:nvSpPr>
         <p:spPr>
           <a:xfrm>
-            <a:off x="9098280" y="4224528"/>
-            <a:ext cx="2743200" cy="1965960"/>
+            <a:off x="6035040" y="1554480"/>
+            <a:ext cx="5696712" cy="2011680"/>
           </a:xfrm>
           <a:prstGeom prst="roundRect">
-            <a:avLst>
-              <a:gd name="adj" fmla="val 4186"/>
-            </a:avLst>
+            <a:avLst/>
           </a:prstGeom>
           <a:solidFill>
             <a:srgbClr val="FFFFFF"/>
           </a:solidFill>
-          <a:ln w="12700">
+          <a:ln w="19050">
             <a:solidFill>
-              <a:srgbClr val="E3E8F0"/>
+              <a:srgbClr val="E2E8F0"/>
             </a:solidFill>
-            <a:prstDash val="solid"/>
           </a:ln>
-          <a:effectLst>
-            <a:outerShdw sx="100000" sy="100000" kx="0" ky="0" algn="bl" rotWithShape="0" blurRad="101600" dist="25400" dir="5400000">
-              <a:srgbClr val="1B2A4A">
-                <a:alpha val="16000"/>
-              </a:srgbClr>
-            </a:outerShdw>
-          </a:effectLst>
-        </p:spPr>
-        <p:txBody>
-          <a:bodyPr/>
-          <a:p/>
-        </p:txBody>
-      </p:sp>
-      <p:sp>
-        <p:nvSpPr>
-          <p:cNvPr id="35" name="Shape 33"/>
+        </p:spPr>
+        <p:style>
+          <a:lnRef idx="1">
+            <a:schemeClr val="accent1"/>
+          </a:lnRef>
+          <a:fillRef idx="3">
+            <a:schemeClr val="accent1"/>
+          </a:fillRef>
+          <a:effectRef idx="2">
+            <a:schemeClr val="accent1"/>
+          </a:effectRef>
+          <a:fontRef idx="minor">
+            <a:schemeClr val="lt1"/>
+          </a:fontRef>
+        </p:style>
+        <p:txBody>
+          <a:bodyPr rtlCol="0" anchor="ctr"/>
+          <a:lstStyle/>
+          <a:p>
+            <a:pPr algn="ctr"/>
+          </a:p>
+        </p:txBody>
+      </p:sp>
+      <p:sp>
+        <p:nvSpPr>
+          <p:cNvPr id="44" name="Oval 43"/>
           <p:cNvSpPr/>
           <p:nvPr/>
         </p:nvSpPr>
         <p:spPr>
           <a:xfrm>
-            <a:off x="10218420" y="4430268"/>
-            <a:ext cx="502920" cy="502920"/>
+            <a:off x="6355080" y="1755648"/>
+            <a:ext cx="438912" cy="438912"/>
           </a:xfrm>
           <a:prstGeom prst="ellipse">
             <a:avLst/>
           </a:prstGeom>
           <a:solidFill>
-            <a:srgbClr val="6C4AB6"/>
+            <a:srgbClr val="0E7C86"/>
           </a:solidFill>
-          <a:ln/>
-        </p:spPr>
-        <p:txBody>
-          <a:bodyPr/>
-          <a:p/>
-        </p:txBody>
-      </p:sp>
-      <p:sp>
-        <p:nvSpPr>
-          <p:cNvPr id="36" name="Text 34"/>
-          <p:cNvSpPr txBox="1"/>
-          <p:nvPr/>
-        </p:nvSpPr>
-        <p:spPr>
-          <a:xfrm>
-            <a:off x="10218420" y="4430268"/>
-            <a:ext cx="502920" cy="502920"/>
-          </a:xfrm>
-          <a:prstGeom prst="rect">
-            <a:avLst/>
-          </a:prstGeom>
-          <a:noFill/>
-          <a:ln/>
-        </p:spPr>
-        <p:txBody>
-          <a:bodyPr wrap="square" lIns="0" tIns="0" rIns="0" bIns="0" rtlCol="0" anchor="ctr"/>
-          <a:lstStyle/>
-          <a:p>
-            <a:pPr algn="ctr" indent="0" marL="0">
-              <a:buNone/>
-            </a:pPr>
-            <a:r>
-              <a:rPr lang="en-US" sz="1200" b="1" dirty="0">
+          <a:ln>
+            <a:noFill/>
+          </a:ln>
+        </p:spPr>
+        <p:style>
+          <a:lnRef idx="1">
+            <a:schemeClr val="accent1"/>
+          </a:lnRef>
+          <a:fillRef idx="3">
+            <a:schemeClr val="accent1"/>
+          </a:fillRef>
+          <a:effectRef idx="2">
+            <a:schemeClr val="accent1"/>
+          </a:effectRef>
+          <a:fontRef idx="minor">
+            <a:schemeClr val="lt1"/>
+          </a:fontRef>
+        </p:style>
+        <p:txBody>
+          <a:bodyPr rtlCol="0" anchor="ctr"/>
+          <a:lstStyle/>
+          <a:p>
+            <a:pPr algn="ctr">
+              <a:defRPr sz="1800" b="1">
                 <a:solidFill>
                   <a:srgbClr val="FFFFFF"/>
                 </a:solidFill>
-                <a:latin typeface="Calibri" pitchFamily="34" charset="0"/>
-                <a:ea typeface="Calibri" pitchFamily="34" charset="-122"/>
-                <a:cs typeface="Calibri" pitchFamily="34" charset="-120"/>
-              </a:rPr>
-              <a:t>⊕</a:t>
-            </a:r>
-            <a:endParaRPr lang="en-US" sz="1200" dirty="0"/>
-          </a:p>
-        </p:txBody>
-      </p:sp>
-      <p:sp>
-        <p:nvSpPr>
-          <p:cNvPr id="37" name="Text 35"/>
-          <p:cNvSpPr txBox="1"/>
-          <p:nvPr/>
-        </p:nvSpPr>
-        <p:spPr>
-          <a:xfrm>
-            <a:off x="9208008" y="5065776"/>
-            <a:ext cx="2523744" cy="320040"/>
-          </a:xfrm>
-          <a:prstGeom prst="rect">
-            <a:avLst/>
-          </a:prstGeom>
-          <a:noFill/>
-          <a:ln/>
-        </p:spPr>
-        <p:txBody>
-          <a:bodyPr wrap="square" lIns="0" tIns="0" rIns="0" bIns="0" rtlCol="0" anchor="ctr"/>
-          <a:lstStyle/>
-          <a:p>
-            <a:pPr algn="ctr" indent="0" marL="0">
-              <a:buNone/>
-            </a:pPr>
-            <a:r>
-              <a:rPr lang="en-US" sz="1250" b="1" dirty="0">
+                <a:latin typeface="Calibri"/>
+              </a:defRPr>
+            </a:pPr>
+            <a:r>
+              <a:t>→</a:t>
+            </a:r>
+          </a:p>
+        </p:txBody>
+      </p:sp>
+      <p:sp>
+        <p:nvSpPr>
+          <p:cNvPr id="45" name="TextBox 44"/>
+          <p:cNvSpPr txBox="1"/>
+          <p:nvPr/>
+        </p:nvSpPr>
+        <p:spPr>
+          <a:xfrm>
+            <a:off x="6931152" y="1755648"/>
+            <a:ext cx="4572000" cy="438912"/>
+          </a:xfrm>
+          <a:prstGeom prst="rect">
+            <a:avLst/>
+          </a:prstGeom>
+          <a:noFill/>
+        </p:spPr>
+        <p:txBody>
+          <a:bodyPr wrap="none" anchor="ctr" lIns="45720">
+            <a:spAutoFit/>
+          </a:bodyPr>
+          <a:lstStyle/>
+          <a:p>
+            <a:pPr>
+              <a:defRPr sz="2000" b="1">
                 <a:solidFill>
                   <a:srgbClr val="0B1F3A"/>
                 </a:solidFill>
-                <a:latin typeface="Cambria" pitchFamily="34" charset="0"/>
-                <a:ea typeface="Cambria" pitchFamily="34" charset="-122"/>
-                <a:cs typeface="Cambria" pitchFamily="34" charset="-120"/>
-              </a:rPr>
-              <a:t>Ensemble &amp; Deploy</a:t>
-            </a:r>
-            <a:endParaRPr lang="en-US" sz="1250" dirty="0"/>
-          </a:p>
-        </p:txBody>
-      </p:sp>
-      <p:sp>
-        <p:nvSpPr>
-          <p:cNvPr id="38" name="Text 36"/>
-          <p:cNvSpPr txBox="1"/>
-          <p:nvPr/>
-        </p:nvSpPr>
-        <p:spPr>
-          <a:xfrm>
-            <a:off x="9226296" y="5394960"/>
-            <a:ext cx="2487168" cy="713232"/>
-          </a:xfrm>
-          <a:prstGeom prst="rect">
-            <a:avLst/>
-          </a:prstGeom>
-          <a:noFill/>
-          <a:ln/>
-        </p:spPr>
-        <p:txBody>
-          <a:bodyPr wrap="square" lIns="0" tIns="0" rIns="0" bIns="0" rtlCol="0" anchor="t"/>
-          <a:lstStyle/>
-          <a:p>
-            <a:pPr algn="ctr" indent="0" marL="0">
-              <a:lnSpc>
-                <a:spcPct val="110000"/>
-              </a:lnSpc>
-              <a:buNone/>
-            </a:pPr>
-            <a:r>
-              <a:rPr lang="en-US" sz="1000" dirty="0">
-                <a:solidFill>
-                  <a:srgbClr val="5B6472"/>
-                </a:solidFill>
-                <a:latin typeface="Calibri" pitchFamily="34" charset="0"/>
-                <a:ea typeface="Calibri" pitchFamily="34" charset="-122"/>
-                <a:cs typeface="Calibri" pitchFamily="34" charset="-120"/>
-              </a:rPr>
-              <a:t>Combine SVM, RF, LR, MNB via Voting; deploy on a Flask web app.</a:t>
-            </a:r>
-            <a:endParaRPr lang="en-US" sz="1000" dirty="0"/>
+                <a:latin typeface="Cambria"/>
+              </a:defRPr>
+            </a:pPr>
+            <a:r>
+              <a:t>Objective</a:t>
+            </a:r>
+          </a:p>
+        </p:txBody>
+      </p:sp>
+      <p:sp>
+        <p:nvSpPr>
+          <p:cNvPr id="46" name="TextBox 45"/>
+          <p:cNvSpPr txBox="1"/>
+          <p:nvPr/>
+        </p:nvSpPr>
+        <p:spPr>
+          <a:xfrm>
+            <a:off x="6355080" y="2331720"/>
+            <a:ext cx="5120640" cy="1097280"/>
+          </a:xfrm>
+          <a:prstGeom prst="rect">
+            <a:avLst/>
+          </a:prstGeom>
+          <a:noFill/>
+        </p:spPr>
+        <p:txBody>
+          <a:bodyPr wrap="square" lIns="0" rIns="0" tIns="0">
+            <a:spAutoFit/>
+          </a:bodyPr>
+          <a:lstStyle/>
+          <a:p>
+            <a:pPr>
+              <a:defRPr sz="1150">
+                <a:solidFill>
+                  <a:srgbClr val="334155"/>
+                </a:solidFill>
+                <a:latin typeface="Calibri"/>
+              </a:defRPr>
+            </a:pPr>
+            <a:r>
+              <a:t>Develop an automated NLP and Ensemble Machine Learning system that predicts the correct medical specialty from a clinical transcription, reducing administrative overhead and speeding up document routing.</a:t>
+            </a:r>
           </a:p>
         </p:txBody>
       </p:sp>

</xml_diff>

<commit_message>
docs: update slide preview and presentation file with latest content
</commit_message>
<xml_diff>
--- a/Medical_Specialty_Classification_Presentation.pptx
+++ b/Medical_Specialty_Classification_Presentation.pptx
@@ -13388,7 +13388,7 @@
           </a:fontRef>
         </p:style>
         <p:txBody>
-          <a:bodyPr rtlCol="0" anchor="ctr" wrap="square" lIns="109728" tIns="73152"/>
+          <a:bodyPr rtlCol="0" anchor="ctr" wrap="square" lIns="36576" tIns="73152" rIns="36576"/>
           <a:lstStyle/>
           <a:p>
             <a:pPr algn="ctr">
@@ -13413,7 +13413,7 @@
           </a:p>
           <a:p>
             <a:pPr>
-              <a:defRPr sz="1100" b="1">
+              <a:defRPr sz="980" b="1">
                 <a:solidFill>
                   <a:srgbClr val="000000"/>
                 </a:solidFill>
@@ -13421,7 +13421,7 @@
               </a:defRPr>
             </a:pPr>
             <a:r>
-              <a:rPr sz="1100" b="1">
+              <a:rPr sz="980" b="1">
                 <a:solidFill>
                   <a:srgbClr val="000000"/>
                 </a:solidFill>
@@ -13469,7 +13469,7 @@
           </a:fontRef>
         </p:style>
         <p:txBody>
-          <a:bodyPr rtlCol="0" anchor="ctr" wrap="square" lIns="109728" tIns="73152"/>
+          <a:bodyPr rtlCol="0" anchor="ctr" wrap="square" lIns="36576" tIns="73152" rIns="36576"/>
           <a:lstStyle/>
           <a:p>
             <a:pPr algn="ctr">
@@ -13494,7 +13494,7 @@
           </a:p>
           <a:p>
             <a:pPr>
-              <a:defRPr sz="1100" b="1">
+              <a:defRPr sz="980" b="1">
                 <a:solidFill>
                   <a:srgbClr val="000000"/>
                 </a:solidFill>
@@ -13502,7 +13502,7 @@
               </a:defRPr>
             </a:pPr>
             <a:r>
-              <a:rPr sz="1100" b="1">
+              <a:rPr sz="980" b="1">
                 <a:solidFill>
                   <a:srgbClr val="000000"/>
                 </a:solidFill>
@@ -13550,7 +13550,7 @@
           </a:fontRef>
         </p:style>
         <p:txBody>
-          <a:bodyPr rtlCol="0" anchor="ctr" wrap="square" lIns="109728" tIns="73152"/>
+          <a:bodyPr rtlCol="0" anchor="ctr" wrap="square" lIns="36576" tIns="73152" rIns="36576"/>
           <a:lstStyle/>
           <a:p>
             <a:pPr algn="ctr">
@@ -13575,7 +13575,7 @@
           </a:p>
           <a:p>
             <a:pPr>
-              <a:defRPr sz="1100" b="1">
+              <a:defRPr sz="980" b="1">
                 <a:solidFill>
                   <a:srgbClr val="000000"/>
                 </a:solidFill>
@@ -13583,7 +13583,7 @@
               </a:defRPr>
             </a:pPr>
             <a:r>
-              <a:rPr sz="1100" b="1">
+              <a:rPr sz="980" b="1">
                 <a:solidFill>
                   <a:srgbClr val="000000"/>
                 </a:solidFill>
@@ -13631,7 +13631,7 @@
           </a:fontRef>
         </p:style>
         <p:txBody>
-          <a:bodyPr rtlCol="0" anchor="ctr" wrap="square" lIns="109728" tIns="73152"/>
+          <a:bodyPr rtlCol="0" anchor="ctr" wrap="square" lIns="36576" tIns="73152" rIns="36576"/>
           <a:lstStyle/>
           <a:p>
             <a:pPr algn="ctr">
@@ -13656,7 +13656,7 @@
           </a:p>
           <a:p>
             <a:pPr>
-              <a:defRPr sz="1100" b="1">
+              <a:defRPr sz="980" b="1">
                 <a:solidFill>
                   <a:srgbClr val="000000"/>
                 </a:solidFill>
@@ -13664,7 +13664,7 @@
               </a:defRPr>
             </a:pPr>
             <a:r>
-              <a:rPr sz="1100" b="1">
+              <a:rPr sz="980" b="1">
                 <a:solidFill>
                   <a:srgbClr val="000000"/>
                 </a:solidFill>

</xml_diff>

<commit_message>
style: make text white in Slide 12 bottom cards for maximum contrast
</commit_message>
<xml_diff>
--- a/Medical_Specialty_Classification_Presentation.pptx
+++ b/Medical_Specialty_Classification_Presentation.pptx
@@ -7445,14 +7445,16 @@
               </a:spcAft>
               <a:defRPr sz="1000" b="1">
                 <a:solidFill>
-                  <a:srgbClr val="38BDF8"/>
+                  <a:srgbClr val="FFFFFF"/>
                 </a:solidFill>
                 <a:latin typeface="Calibri"/>
               </a:defRPr>
             </a:pPr>
             <a:r>
               <a:rPr>
-                <a:solidFill/>
+                <a:solidFill>
+                  <a:srgbClr val="FFFFFF"/>
+                </a:solidFill>
               </a:rPr>
               <a:t>FEATURE EXTRACTION</a:t>
             </a:r>
@@ -7471,23 +7473,27 @@
             </a:pPr>
             <a:r>
               <a:rPr>
-                <a:solidFill/>
+                <a:solidFill>
+                  <a:srgbClr val="FFFFFF"/>
+                </a:solidFill>
               </a:rPr>
               <a:t>TF-IDF Vectorizer</a:t>
             </a:r>
           </a:p>
           <a:p>
             <a:pPr>
-              <a:defRPr sz="950">
-                <a:solidFill>
-                  <a:srgbClr val="CBD5E1"/>
+              <a:defRPr sz="1100">
+                <a:solidFill>
+                  <a:srgbClr val="FFFFFF"/>
                 </a:solidFill>
                 <a:latin typeface="Calibri"/>
               </a:defRPr>
             </a:pPr>
             <a:r>
-              <a:rPr>
-                <a:solidFill/>
+              <a:rPr sz="1100">
+                <a:solidFill>
+                  <a:srgbClr val="FFFFFF"/>
+                </a:solidFill>
               </a:rPr>
               <a:t>Unigrams &amp; bigrams with sublinear TF scaling and L2 normalization.</a:t>
             </a:r>
@@ -7541,14 +7547,16 @@
               </a:spcAft>
               <a:defRPr sz="1000" b="1">
                 <a:solidFill>
-                  <a:srgbClr val="A7F3D0"/>
+                  <a:srgbClr val="FFFFFF"/>
                 </a:solidFill>
                 <a:latin typeface="Calibri"/>
               </a:defRPr>
             </a:pPr>
             <a:r>
               <a:rPr>
-                <a:solidFill/>
+                <a:solidFill>
+                  <a:srgbClr val="FFFFFF"/>
+                </a:solidFill>
               </a:rPr>
               <a:t>CLASSIFICATION (4 DIVERSE BASE ESTIMATORS)</a:t>
             </a:r>
@@ -7567,23 +7575,27 @@
             </a:pPr>
             <a:r>
               <a:rPr>
-                <a:solidFill/>
+                <a:solidFill>
+                  <a:srgbClr val="FFFFFF"/>
+                </a:solidFill>
               </a:rPr>
               <a:t>SVM + Random Forest + Logistic Regression + Multinomial NB</a:t>
             </a:r>
           </a:p>
           <a:p>
             <a:pPr>
-              <a:defRPr sz="950">
-                <a:solidFill>
-                  <a:srgbClr val="F0FDFA"/>
+              <a:defRPr sz="1100">
+                <a:solidFill>
+                  <a:srgbClr val="FFFFFF"/>
                 </a:solidFill>
                 <a:latin typeface="Calibri"/>
               </a:defRPr>
             </a:pPr>
             <a:r>
-              <a:rPr>
-                <a:solidFill/>
+              <a:rPr sz="1100">
+                <a:solidFill>
+                  <a:srgbClr val="FFFFFF"/>
+                </a:solidFill>
               </a:rPr>
               <a:t>Each model independently evaluates high-dimensional sparse vectors and outputs class probabilities.</a:t>
             </a:r>
@@ -7637,14 +7649,16 @@
               </a:spcAft>
               <a:defRPr sz="1000" b="1">
                 <a:solidFill>
-                  <a:srgbClr val="E9D5FF"/>
+                  <a:srgbClr val="FFFFFF"/>
                 </a:solidFill>
                 <a:latin typeface="Calibri"/>
               </a:defRPr>
             </a:pPr>
             <a:r>
               <a:rPr>
-                <a:solidFill/>
+                <a:solidFill>
+                  <a:srgbClr val="FFFFFF"/>
+                </a:solidFill>
               </a:rPr>
               <a:t>ENSEMBLE AGGREGATION</a:t>
             </a:r>
@@ -7663,23 +7677,27 @@
             </a:pPr>
             <a:r>
               <a:rPr>
-                <a:solidFill/>
+                <a:solidFill>
+                  <a:srgbClr val="FFFFFF"/>
+                </a:solidFill>
               </a:rPr>
               <a:t>Voting Classifier (Soft)</a:t>
             </a:r>
           </a:p>
           <a:p>
             <a:pPr>
-              <a:defRPr sz="950">
-                <a:solidFill>
-                  <a:srgbClr val="F5F3FF"/>
+              <a:defRPr sz="1100">
+                <a:solidFill>
+                  <a:srgbClr val="FFFFFF"/>
                 </a:solidFill>
                 <a:latin typeface="Calibri"/>
               </a:defRPr>
             </a:pPr>
             <a:r>
-              <a:rPr>
-                <a:solidFill/>
+              <a:rPr sz="1100">
+                <a:solidFill>
+                  <a:srgbClr val="FFFFFF"/>
+                </a:solidFill>
               </a:rPr>
               <a:t>Aggregates consensus probabilities to output final specialty prediction.</a:t>
             </a:r>

</xml_diff>

<commit_message>
fix: remove temporary lock file and update presentation slides
</commit_message>
<xml_diff>
--- a/Medical_Specialty_Classification_Presentation.pptx
+++ b/Medical_Specialty_Classification_Presentation.pptx
@@ -2391,49 +2391,6 @@
       </p:grpSpPr>
       <p:sp>
         <p:nvSpPr>
-          <p:cNvPr id="2" name="Rectangle 1"/>
-          <p:cNvSpPr/>
-          <p:nvPr/>
-        </p:nvSpPr>
-        <p:spPr>
-          <a:xfrm>
-            <a:off x="0" y="0"/>
-            <a:ext cx="12191695" cy="109728"/>
-          </a:xfrm>
-          <a:prstGeom prst="rect">
-            <a:avLst/>
-          </a:prstGeom>
-          <a:solidFill>
-            <a:srgbClr val="00E5FF"/>
-          </a:solidFill>
-          <a:ln>
-            <a:noFill/>
-          </a:ln>
-        </p:spPr>
-        <p:style>
-          <a:lnRef idx="1">
-            <a:schemeClr val="accent1"/>
-          </a:lnRef>
-          <a:fillRef idx="3">
-            <a:schemeClr val="accent1"/>
-          </a:fillRef>
-          <a:effectRef idx="2">
-            <a:schemeClr val="accent1"/>
-          </a:effectRef>
-          <a:fontRef idx="minor">
-            <a:schemeClr val="lt1"/>
-          </a:fontRef>
-        </p:style>
-        <p:txBody>
-          <a:bodyPr rtlCol="0" anchor="ctr"/>
-          <a:lstStyle/>
-          <a:p>
-            <a:pPr algn="ctr"/>
-          </a:p>
-        </p:txBody>
-      </p:sp>
-      <p:sp>
-        <p:nvSpPr>
           <p:cNvPr id="3" name="TextBox 2"/>
           <p:cNvSpPr txBox="1"/>
           <p:nvPr/>
@@ -11463,49 +11420,6 @@
           <a:chExt cx="0" cy="0"/>
         </a:xfrm>
       </p:grpSpPr>
-      <p:sp>
-        <p:nvSpPr>
-          <p:cNvPr id="2" name="Rectangle 1"/>
-          <p:cNvSpPr/>
-          <p:nvPr/>
-        </p:nvSpPr>
-        <p:spPr>
-          <a:xfrm>
-            <a:off x="0" y="0"/>
-            <a:ext cx="12191695" cy="109728"/>
-          </a:xfrm>
-          <a:prstGeom prst="rect">
-            <a:avLst/>
-          </a:prstGeom>
-          <a:solidFill>
-            <a:srgbClr val="00E5FF"/>
-          </a:solidFill>
-          <a:ln>
-            <a:noFill/>
-          </a:ln>
-        </p:spPr>
-        <p:style>
-          <a:lnRef idx="1">
-            <a:schemeClr val="accent1"/>
-          </a:lnRef>
-          <a:fillRef idx="3">
-            <a:schemeClr val="accent1"/>
-          </a:fillRef>
-          <a:effectRef idx="2">
-            <a:schemeClr val="accent1"/>
-          </a:effectRef>
-          <a:fontRef idx="minor">
-            <a:schemeClr val="lt1"/>
-          </a:fontRef>
-        </p:style>
-        <p:txBody>
-          <a:bodyPr rtlCol="0" anchor="ctr"/>
-          <a:lstStyle/>
-          <a:p>
-            <a:pPr algn="ctr"/>
-          </a:p>
-        </p:txBody>
-      </p:sp>
       <p:sp>
         <p:nvSpPr>
           <p:cNvPr id="3" name="Rounded Rectangle 2"/>

</xml_diff>

<commit_message>
feat: automate PPTX presentation notes injection with comprehensive script content
</commit_message>
<xml_diff>
--- a/Medical_Specialty_Classification_Presentation.pptx
+++ b/Medical_Specialty_Classification_Presentation.pptx
@@ -519,10 +519,71 @@
           <a:lstStyle/>
           <a:p>
             <a:r>
-              <a:rPr lang="en-US" dirty="0"/>
-              <a:t>Good morning / afternoon. My project is titled Medical Specialty Classification Using TF-IDF and Ensemble Machine Learning, presented as my MCA Mini Project's first review from the Department of Computer Applications, Mar Athanasius College of Engineering, Kothamangalam. In this presentation I will walk through the literature I reviewed, the exploratory analysis I performed on the clinical transcription dataset, my proposed preprocessing and TF-IDF feature extraction approach, the ensemble machine learning algorithms I plan to use, the overall project pipeline, and a proposed GUI for deployment. Let's begin with the problem this project addresses.</a:t>
-            </a:r>
-            <a:endParaRPr lang="en-US" dirty="0"/>
+              <a:t>[FORMAL PRESENTATION SCRIPT]</a:t>
+            </a:r>
+          </a:p>
+          <a:p>
+            <a:r>
+              <a:t>Respected Guide Prof. Biju Skaria, Chairperson, and esteemed members of the evaluation committee, good morning. </a:t>
+            </a:r>
+          </a:p>
+          <a:p/>
+          <a:p>
+            <a:r>
+              <a:t>I am Jiphin George, Register Number MAC25MCA-2033, pursuing my Master of Computer Applications at Mar Athanasius College of Engineering, Kothamangalam. Today, I am privileged to present the first review of my MCA Mini Project titled: 'Medical Specialty Classification Using TF-IDF and Ensemble Machine Learning'.</a:t>
+            </a:r>
+          </a:p>
+          <a:p/>
+          <a:p>
+            <a:r>
+              <a:t>[KEY TECHNICAL HIGHLIGHTS]</a:t>
+            </a:r>
+          </a:p>
+          <a:p>
+            <a:r>
+              <a:t>• Domain Problem: Healthcare systems generate thousands of unstructured clinical dictations daily. Manually reading and routing these to medical departments causes clinical delays, high administrative costs, and coding inconsistencies.</a:t>
+            </a:r>
+          </a:p>
+          <a:p>
+            <a:r>
+              <a:t>• Proposed Solution: An automated, lightweight, and explainable NLP and Machine Learning classification system capable of classifying medical transcripts into 40 medical specialties.</a:t>
+            </a:r>
+          </a:p>
+          <a:p>
+            <a:r>
+              <a:t>• Architectural Pillars:</a:t>
+            </a:r>
+          </a:p>
+          <a:p>
+            <a:r>
+              <a:t>  1. Clinical NLP Normalization (cleaning, tokenization, stopword removal, WordNet lemmatization).</a:t>
+            </a:r>
+          </a:p>
+          <a:p>
+            <a:r>
+              <a:t>  2. Sublinear TF-IDF Feature Vectorization (unigrams + bigrams with L2 normalization).</a:t>
+            </a:r>
+          </a:p>
+          <a:p>
+            <a:r>
+              <a:t>  3. Soft Voting Ensemble combining 4 diverse classifiers: Linear SVM, Random Forest, Multinomial Logistic Regression, and Multinomial Naive Bayes.</a:t>
+            </a:r>
+          </a:p>
+          <a:p>
+            <a:r>
+              <a:t>  4. Lightweight Flask Web Deployment running in real-time on standard commodity CPU hardware without requiring expensive GPUs.</a:t>
+            </a:r>
+          </a:p>
+          <a:p/>
+          <a:p>
+            <a:r>
+              <a:t>[TRANSITION TO NEXT SLIDE]</a:t>
+            </a:r>
+          </a:p>
+          <a:p>
+            <a:r>
+              <a:t>Let us begin by examining the underlying problem statement and the core objectives guiding this project.</a:t>
+            </a:r>
           </a:p>
         </p:txBody>
       </p:sp>
@@ -555,6 +616,144 @@
         <p14:creationId xmlns:p14="http://schemas.microsoft.com/office/powerpoint/2010/main" val="1024086991"/>
       </p:ext>
     </p:extLst>
+  </p:cSld>
+  <p:clrMapOvr>
+    <a:masterClrMapping/>
+  </p:clrMapOvr>
+</p:notes>
+</file>
+
+<file path=ppt/notesSlides/notesSlide11.xml><?xml version="1.0" encoding="utf-8"?>
+<p:notes xmlns:a="http://schemas.openxmlformats.org/drawingml/2006/main" xmlns:p="http://schemas.openxmlformats.org/presentationml/2006/main" xmlns:r="http://schemas.openxmlformats.org/officeDocument/2006/relationships">
+  <p:cSld>
+    <p:spTree>
+      <p:nvGrpSpPr>
+        <p:cNvPr id="1" name=""/>
+        <p:cNvGrpSpPr/>
+        <p:nvPr/>
+      </p:nvGrpSpPr>
+      <p:grpSpPr>
+        <a:xfrm>
+          <a:off x="0" y="0"/>
+          <a:ext cx="0" cy="0"/>
+          <a:chOff x="0" y="0"/>
+          <a:chExt cx="0" cy="0"/>
+        </a:xfrm>
+      </p:grpSpPr>
+      <p:sp>
+        <p:nvSpPr>
+          <p:cNvPr id="2" name="Slide Image Placeholder 1"/>
+          <p:cNvSpPr>
+            <a:spLocks noGrp="1"/>
+          </p:cNvSpPr>
+          <p:nvPr>
+            <p:ph type="sldImg" idx="2"/>
+          </p:nvPr>
+        </p:nvSpPr>
+        <p:spPr/>
+      </p:sp>
+      <p:sp>
+        <p:nvSpPr>
+          <p:cNvPr id="3" name="Notes Placeholder 2"/>
+          <p:cNvSpPr>
+            <a:spLocks noGrp="1"/>
+          </p:cNvSpPr>
+          <p:nvPr>
+            <p:ph type="body" idx="3" sz="quarter"/>
+          </p:nvPr>
+        </p:nvSpPr>
+        <p:spPr/>
+        <p:txBody>
+          <a:bodyPr/>
+          <a:lstStyle/>
+          <a:p>
+            <a:r>
+              <a:t>[FORMAL PRESENTATION SCRIPT]</a:t>
+            </a:r>
+          </a:p>
+          <a:p>
+            <a:r>
+              <a:t>Slide 3 presents the academic context, theoretical foundation, and research landscape of clinical text classification.</a:t>
+            </a:r>
+          </a:p>
+          <a:p/>
+          <a:p>
+            <a:r>
+              <a:t>The top phase bar outlines our research progression:</a:t>
+            </a:r>
+          </a:p>
+          <a:p>
+            <a:r>
+              <a:t>1. Prior Literature: Validated the feasibility of supervised machine learning for clinical text classification.</a:t>
+            </a:r>
+          </a:p>
+          <a:p>
+            <a:r>
+              <a:t>2. Key Methodologies: Established TF-IDF vectorization and linear classifiers as strong, interpretable baselines.</a:t>
+            </a:r>
+          </a:p>
+          <a:p>
+            <a:r>
+              <a:t>3. Identified Gap: Deep learning approaches (such as BERT or ClinicalBERT) achieve high benchmarks but demand massive GPU compute, suffer from long inference latency, and show high variance when trained on severely imbalanced text data.</a:t>
+            </a:r>
+          </a:p>
+          <a:p>
+            <a:r>
+              <a:t>4. Proposed Architecture: A lightweight Soft Voting Ensemble designed to achieve robust multi-class accuracy across all 40 specialties on standard CPU hardware.</a:t>
+            </a:r>
+          </a:p>
+          <a:p/>
+          <a:p>
+            <a:r>
+              <a:t>[FOUR CORE METHODOLOGICAL PILLARS]</a:t>
+            </a:r>
+          </a:p>
+          <a:p>
+            <a:r>
+              <a:t>• Clinical NLP &amp; Preprocessing: Clinical dictations contain non-standard abbreviations and punctuation noise. We implement a systematic 5-stage cleaning sequence (HTML/noise removal, case normalization, regex tokenization, clinical stopword removal, and morphological lemmatization) that normalizes inflected clinical terms to their diagnostic roots.</a:t>
+            </a:r>
+          </a:p>
+          <a:p>
+            <a:r>
+              <a:t>• TF-IDF Feature Representation: Converts unstructured narratives into high-dimensional sparse numerical vectors. Sublinear scaling (1 + log(TF)) dampens repetitive non-informative terms while highlighting discriminative clinical tokens. L2 normalization handles document length variations.</a:t>
+            </a:r>
+          </a:p>
+          <a:p>
+            <a:r>
+              <a:t>• Supervised ML Classifiers: Linear models (SVM, Logistic Regression) excel on high-dimensional sparse text vectors; Random Forest introduces non-linear decision boundaries and bagging variance reduction; Multinomial Naive Bayes provides fast probabilistic likelihood estimation.</a:t>
+            </a:r>
+          </a:p>
+          <a:p>
+            <a:r>
+              <a:t>• Ensemble Learning &amp; Research Gap: Single models often struggle with rare classes under severe imbalance. Combining calibrated base models through soft probability voting balances variance and achieves superior generalization.</a:t>
+            </a:r>
+          </a:p>
+          <a:p/>
+          <a:p>
+            <a:r>
+              <a:t>[TRANSITION TO NEXT SLIDE]</a:t>
+            </a:r>
+          </a:p>
+          <a:p>
+            <a:r>
+              <a:t>Let us now examine three specific peer-reviewed papers that directly informed our methodological design on Slide 4.</a:t>
+            </a:r>
+          </a:p>
+        </p:txBody>
+      </p:sp>
+      <p:sp>
+        <p:nvSpPr>
+          <p:cNvPr id="4" name="Slide Number Placeholder 3"/>
+          <p:cNvSpPr>
+            <a:spLocks noGrp="1"/>
+          </p:cNvSpPr>
+          <p:nvPr>
+            <p:ph type="sldNum" idx="5" sz="quarter"/>
+          </p:nvPr>
+        </p:nvSpPr>
+        <p:spPr/>
+      </p:sp>
+    </p:spTree>
   </p:cSld>
   <p:clrMapOvr>
     <a:masterClrMapping/>
@@ -607,10 +806,65 @@
           <a:lstStyle/>
           <a:p>
             <a:r>
-              <a:rPr lang="en-US" dirty="0"/>
-              <a:t>This slide distinguishes what I have already done from what is proposed. On the left is the currently explored and cleaned dataset: after dropping the 33 missing-transcription records, the shape becomes 4,966 rows by 6 columns, spanning the same 40 target classes, with dtypes as shown. On the right is the proposed fully preprocessed output once the 8-step text-cleaning pipeline I described earlier is executed — lowercase, punctuation-free, lemmatized narrative text ready for TF-IDF. I want to be transparent that this full text-cleaning execution is a planned next step, not a completed result, and I will verify it using head, shape, info and describe once implemented.</a:t>
-            </a:r>
-            <a:endParaRPr lang="en-US" dirty="0"/>
+              <a:t>[FORMAL PRESENTATION SCRIPT]</a:t>
+            </a:r>
+          </a:p>
+          <a:p>
+            <a:r>
+              <a:t>Slide 11 contrasts the raw ingested dataset against the clean, preprocessed data structure established for model training.</a:t>
+            </a:r>
+          </a:p>
+          <a:p/>
+          <a:p>
+            <a:r>
+              <a:t>[CLEANED DATASET STRUCTURE]</a:t>
+            </a:r>
+          </a:p>
+          <a:p>
+            <a:r>
+              <a:t>• Drop Null Records: Removed the 33 records with missing transcriptions, yielding a clean dataset of 4,966 high-quality rows spanning all 40 original medical specialties.</a:t>
+            </a:r>
+          </a:p>
+          <a:p>
+            <a:r>
+              <a:t>• Feature Matrix ($X$): The cleaned `transcription` narrative text.</a:t>
+            </a:r>
+          </a:p>
+          <a:p>
+            <a:r>
+              <a:t>• Target Variable ($y$): The categorical `medical_specialty` label, encoded into numerical format via scikit-learn's `LabelEncoder`.</a:t>
+            </a:r>
+          </a:p>
+          <a:p>
+            <a:r>
+              <a:t>• Stratified Train-Test Split:</a:t>
+            </a:r>
+          </a:p>
+          <a:p>
+            <a:r>
+              <a:t>  - 80% Training Set (3,972 samples) : 20% Test Set (994 samples).</a:t>
+            </a:r>
+          </a:p>
+          <a:p>
+            <a:r>
+              <a:t>  - Stratification ensures that all 40 specialties—including the rarest classes—are proportionally represented in both training and test partitions.</a:t>
+            </a:r>
+          </a:p>
+          <a:p>
+            <a:r>
+              <a:t>• Strict Data Leakage Prevention: The TF-IDF Vectorizer is fitted strictly on the training partition (`fit_transform`). The test set is strictly transformed (`transform`) using frozen vocabulary and IDF weights, ensuring no data snooping or leakage occurs.</a:t>
+            </a:r>
+          </a:p>
+          <a:p/>
+          <a:p>
+            <a:r>
+              <a:t>[TRANSITION TO NEXT SLIDE]</a:t>
+            </a:r>
+          </a:p>
+          <a:p>
+            <a:r>
+              <a:t>Slide 12 introduces our proposed machine learning algorithms and ensemble architecture.</a:t>
+            </a:r>
           </a:p>
         </p:txBody>
       </p:sp>
@@ -695,10 +949,71 @@
           <a:lstStyle/>
           <a:p>
             <a:r>
-              <a:rPr lang="en-US" dirty="0"/>
-              <a:t>I propose four base classifiers on top of the TF-IDF features: Support Vector Machine, which handles sparse high-dimensional text very well; Random Forest, which captures non-linear keyword interactions; Logistic Regression, a highly interpretable probabilistic baseline; and Multinomial Naive Bayes, a fast count-based model. The strip below makes the pipeline explicit: TF-IDF handles feature extraction, these four models handle classification, and a Voting Classifier handles the final ensemble decision. One important technical note: since I plan to use soft voting, every classifier must output probability estimates, and because Linear SVM does not natively provide those, its scores will need probability calibration before joining the ensemble.</a:t>
-            </a:r>
-            <a:endParaRPr lang="en-US" dirty="0"/>
+              <a:t>[FORMAL PRESENTATION SCRIPT]</a:t>
+            </a:r>
+          </a:p>
+          <a:p>
+            <a:r>
+              <a:t>Slide 12 presents our proposed classification architecture, combining four diverse base machine learning models into an overarching Soft Voting Ensemble.</a:t>
+            </a:r>
+          </a:p>
+          <a:p/>
+          <a:p>
+            <a:r>
+              <a:t>[TOP 4 BASE CLASSIFIERS]</a:t>
+            </a:r>
+          </a:p>
+          <a:p>
+            <a:r>
+              <a:t>1. Support Vector Machine (Linear Kernel): Finds the maximum-margin separating hyperplane. Proven mathematically to excel on sparse, high-dimensional text feature spaces where the number of features exceeds the number of samples.</a:t>
+            </a:r>
+          </a:p>
+          <a:p>
+            <a:r>
+              <a:t>2. Random Forest Classifier: An ensemble of decision trees utilizing bootstrap aggregation (bagging). Captures non-linear keyword interactions and provides variance reduction.</a:t>
+            </a:r>
+          </a:p>
+          <a:p>
+            <a:r>
+              <a:t>3. Logistic Regression (Multinomial / Softmax): Provides a well-calibrated probabilistic baseline with L2 regularization, generating interpretable posterior odds ratios for clinical features.</a:t>
+            </a:r>
+          </a:p>
+          <a:p>
+            <a:r>
+              <a:t>4. Multinomial Naive Bayes: A fast, count-based probabilistic classifier using Laplace smoothing. Computationally efficient and highly effective on word frequency distributions.</a:t>
+            </a:r>
+          </a:p>
+          <a:p/>
+          <a:p>
+            <a:r>
+              <a:t>[BOTTOM 3 STAGES: PIPELINE ARCHITECTURE]</a:t>
+            </a:r>
+          </a:p>
+          <a:p>
+            <a:r>
+              <a:t>• Feature Extraction: TF-IDF vectorizer extracts unigrams and bigrams with sublinear TF scaling and L2 normalization, producing a standardized sparse matrix.</a:t>
+            </a:r>
+          </a:p>
+          <a:p>
+            <a:r>
+              <a:t>• Classification: The four base estimators independently evaluate the sparse vector and generate class probability distributions.</a:t>
+            </a:r>
+          </a:p>
+          <a:p>
+            <a:r>
+              <a:t>• Ensemble Aggregation: A Soft Voting Classifier aggregates consensus probabilities across all four base models: P_ensemble(c) = 1/4 * sum(P_m(c)). The predicted specialty corresponds to argmax(P_ensemble).</a:t>
+            </a:r>
+          </a:p>
+          <a:p/>
+          <a:p>
+            <a:r>
+              <a:t>[TRANSITION TO NEXT SLIDE]</a:t>
+            </a:r>
+          </a:p>
+          <a:p>
+            <a:r>
+              <a:t>Let us now examine the formal UML Activity Diagrams for each algorithm, starting with SVM and Naive Bayes on Slide 13.</a:t>
+            </a:r>
           </a:p>
         </p:txBody>
       </p:sp>
@@ -783,10 +1098,102 @@
           <a:lstStyle/>
           <a:p>
             <a:r>
-              <a:rPr lang="en-US" dirty="0"/>
-              <a:t>This is the training workflow, designed carefully to avoid data leakage. Starting from the full 4,999-record dataset, I first do initial cleaning and a null audit, then perform the stratified 80:20 train-test split before any text vectorization happens. Text preprocessing is applied to both partitions, but critically, the TF-IDF vectorizer is fit only on the training data — highlighted here — and then used to transform both the training and test sets. This prevents information from the test set leaking into the vocabulary or IDF weights. After that, the four base classifiers are trained, combined through soft voting, evaluated with standard metrics, and the final pipeline is serialized for deployment.</a:t>
-            </a:r>
-            <a:endParaRPr lang="en-US" dirty="0"/>
+              <a:t>[FORMAL PRESENTATION SCRIPT]</a:t>
+            </a:r>
+          </a:p>
+          <a:p>
+            <a:r>
+              <a:t>Slide 13 displays the formal UML Activity Diagrams for our first two classifiers—Support Vector Machine on the left and Multinomial Naive Bayes on the right—extracted directly from Figures 7 and 8 of our project report.</a:t>
+            </a:r>
+          </a:p>
+          <a:p/>
+          <a:p>
+            <a:r>
+              <a:t>[DETAILED STEP-BY-STEP ACTIVITY DIAGRAM WALKTHROUGH]</a:t>
+            </a:r>
+          </a:p>
+          <a:p/>
+          <a:p>
+            <a:r>
+              <a:t>• LEFT DIAGRAM: SVM Model Training &amp; Classification (Figure 7):</a:t>
+            </a:r>
+          </a:p>
+          <a:p>
+            <a:r>
+              <a:t>  1. Initial Node (Black Circle): Ingestion of preprocessed clinical transcription text.</a:t>
+            </a:r>
+          </a:p>
+          <a:p>
+            <a:r>
+              <a:t>  2. TF-IDF Vectorization Activity: Converts the clinical text into a high-dimensional numerical sparse feature vector.</a:t>
+            </a:r>
+          </a:p>
+          <a:p>
+            <a:r>
+              <a:t>  3. Hyperplane Optimization: Solves the convex quadratic programming dual problem: finding the maximum-margin hyperplane separating specialty classes using a linear kernel K(x_i, x_j) = x_i^T x_j.</a:t>
+            </a:r>
+          </a:p>
+          <a:p>
+            <a:r>
+              <a:t>  4. Decision Node (Platt Scaling / Probability Calibration): Because standard SVM outputs uncalibrated geometric margins, Platt scaling (logistic sigmoid fitting) is applied to convert margins into well-calibrated class probability distributions P(y|x) necessary for soft voting.</a:t>
+            </a:r>
+          </a:p>
+          <a:p>
+            <a:r>
+              <a:t>  5. Multi-Class Decision: One-vs-Rest (OvR) decision strategy constructs 40 binary decision boundaries.</a:t>
+            </a:r>
+          </a:p>
+          <a:p>
+            <a:r>
+              <a:t>  6. Output &amp; Terminal Node: Outputs the calibrated probability vector and predicted specialty class.</a:t>
+            </a:r>
+          </a:p>
+          <a:p/>
+          <a:p>
+            <a:r>
+              <a:t>• RIGHT DIAGRAM: Multinomial Naive Bayes (Figure 8):</a:t>
+            </a:r>
+          </a:p>
+          <a:p>
+            <a:r>
+              <a:t>  1. Initial Node: Ingestion of tokenized transcription feature vector.</a:t>
+            </a:r>
+          </a:p>
+          <a:p>
+            <a:r>
+              <a:t>  2. Prior &amp; Likelihood Computation: Computes class prior log-probabilities log P(c) and feature likelihoods log P(w_i | c).</a:t>
+            </a:r>
+          </a:p>
+          <a:p>
+            <a:r>
+              <a:t>  3. Laplace Smoothing Activity: Applies additive Laplace smoothing (alpha = 1.0) to prevent zero-probability errors on words absent in specific classes: P(w_i|c) = (N_ci + 1) / (N_c + |V|).</a:t>
+            </a:r>
+          </a:p>
+          <a:p>
+            <a:r>
+              <a:t>  4. Posterior Likelihood Aggregation: Sums log-likelihoods over all tokens to prevent floating-point underflow: log P(c) + sum(log P(w_i | c)).</a:t>
+            </a:r>
+          </a:p>
+          <a:p>
+            <a:r>
+              <a:t>  5. Softmax Normalization: Normalizes posterior log-odds into a calibrated probability distribution across all 40 specialties.</a:t>
+            </a:r>
+          </a:p>
+          <a:p>
+            <a:r>
+              <a:t>  6. Terminal Node: Outputs probability distribution to the ensemble aggregator.</a:t>
+            </a:r>
+          </a:p>
+          <a:p/>
+          <a:p>
+            <a:r>
+              <a:t>[TRANSITION TO NEXT SLIDE]</a:t>
+            </a:r>
+          </a:p>
+          <a:p>
+            <a:r>
+              <a:t>Slide 14 presents the activity diagrams for our remaining two base estimators: Random Forest and Logistic Regression.</a:t>
+            </a:r>
           </a:p>
         </p:txBody>
       </p:sp>
@@ -871,10 +1278,107 @@
           <a:lstStyle/>
           <a:p>
             <a:r>
-              <a:rPr lang="en-US" dirty="0"/>
-              <a:t>In plain English, here is how the whole system will work end to end: load the raw dataset, clean it, split it in a stratified way so all specialties are represented in both partitions, preprocess the clinical text, fit TF-IDF only on the training partition, transform both partitions into numeric vectors, train the four base classifiers, combine them with soft voting, evaluate using accuracy, precision, recall and F1, and finally serialize the winning pipeline so it can be used for real-time prediction. This ten-step summary is the backbone of both my model-development phase and the Flask deployment that follows it.</a:t>
-            </a:r>
-            <a:endParaRPr lang="en-US" dirty="0"/>
+              <a:t>[FORMAL PRESENTATION SCRIPT]</a:t>
+            </a:r>
+          </a:p>
+          <a:p>
+            <a:r>
+              <a:t>Slide 14 displays the formal UML Activity Diagrams for Random Forest on the left and Logistic Regression on the right, corresponding to Figures 9 and 10 in our project report.</a:t>
+            </a:r>
+          </a:p>
+          <a:p/>
+          <a:p>
+            <a:r>
+              <a:t>[DETAILED STEP-BY-STEP ACTIVITY DIAGRAM WALKTHROUGH]</a:t>
+            </a:r>
+          </a:p>
+          <a:p/>
+          <a:p>
+            <a:r>
+              <a:t>• LEFT DIAGRAM: Random Forest Classifier (Figure 9):</a:t>
+            </a:r>
+          </a:p>
+          <a:p>
+            <a:r>
+              <a:t>  1. Initial Node: Ingestion of TF-IDF feature matrix.</a:t>
+            </a:r>
+          </a:p>
+          <a:p>
+            <a:r>
+              <a:t>  2. Fork Bar (Parallel Bootstrap Sampling): Splits the training process across an ensemble of B decision trees (n_estimators=100) via Bootstrap Aggregation (Bagging).</a:t>
+            </a:r>
+          </a:p>
+          <a:p>
+            <a:r>
+              <a:t>  3. Random Feature Subspace Split: At each split node of every tree, a random subset of features (sqrt(D)) is evaluated to maximize Gini Impurity reduction: Gini = 1 - sum(p_i^2).</a:t>
+            </a:r>
+          </a:p>
+          <a:p>
+            <a:r>
+              <a:t>  4. Tree Growing: Decision trees grow independently without pruning down to minimum leaf size.</a:t>
+            </a:r>
+          </a:p>
+          <a:p>
+            <a:r>
+              <a:t>  5. Join Bar (Ensemble Synchronization): Gathers predictions across all parallel decision trees.</a:t>
+            </a:r>
+          </a:p>
+          <a:p>
+            <a:r>
+              <a:t>  6. Probability Averaging Activity: Averages leaf node class distributions across all trees: P_RF(c) = 1/B * sum(p_b(c)).</a:t>
+            </a:r>
+          </a:p>
+          <a:p>
+            <a:r>
+              <a:t>  7. Terminal Node: Outputs the aggregated ensemble probability distribution.</a:t>
+            </a:r>
+          </a:p>
+          <a:p/>
+          <a:p>
+            <a:r>
+              <a:t>• RIGHT DIAGRAM: Multinomial Logistic Regression (Figure 10):</a:t>
+            </a:r>
+          </a:p>
+          <a:p>
+            <a:r>
+              <a:t>  1. Initial Node: Ingestion of TF-IDF feature vector.</a:t>
+            </a:r>
+          </a:p>
+          <a:p>
+            <a:r>
+              <a:t>  2. Logit Linear Combination: Evaluates linear log-odds for each specialty class: z_k = w_k^T x + b_k.</a:t>
+            </a:r>
+          </a:p>
+          <a:p>
+            <a:r>
+              <a:t>  3. Multinomial Softmax Activation: Converts raw logit scores into valid probabilities summing to 1: P(y=k|x) = exp(z_k) / sum(exp(z_j)).</a:t>
+            </a:r>
+          </a:p>
+          <a:p>
+            <a:r>
+              <a:t>  4. L2 Regularized Cross-Entropy Optimization: Optimizes the cross-entropy loss function with Ridge penalty (lambda/2 * ||w||^2) using the L-BFGS quasi-Newton optimization solver.</a:t>
+            </a:r>
+          </a:p>
+          <a:p>
+            <a:r>
+              <a:t>  5. Class Weight Balancing Activity: Adjusts gradient weights inversely proportional to class frequencies to counteract class imbalance.</a:t>
+            </a:r>
+          </a:p>
+          <a:p>
+            <a:r>
+              <a:t>  6. Terminal Node: Outputs calibrated multi-class posterior probability vector.</a:t>
+            </a:r>
+          </a:p>
+          <a:p/>
+          <a:p>
+            <a:r>
+              <a:t>[TRANSITION TO NEXT SLIDE]</a:t>
+            </a:r>
+          </a:p>
+          <a:p>
+            <a:r>
+              <a:t>On Slide 15, we see how these four streams converge into our Soft Voting Ensemble architecture.</a:t>
+            </a:r>
           </a:p>
         </p:txBody>
       </p:sp>
@@ -959,10 +1463,101 @@
           <a:lstStyle/>
           <a:p>
             <a:r>
-              <a:rPr lang="en-US" dirty="0"/>
-              <a:t>Here is a consolidated view of how every algorithm participates. A clinical transcription first goes through text preprocessing, then TF-IDF feature extraction turns it into a numeric vector. That same vector is fed in parallel to all four classifiers — SVM, Random Forest, Logistic Regression, and Multinomial Naive Bayes — each producing its own probability estimate for every one of the 40 specialties. The Voting Ensemble then averages these probability estimates and picks the specialty with the highest combined score as the final predicted medical specialty.</a:t>
-            </a:r>
-            <a:endParaRPr lang="en-US" dirty="0"/>
+              <a:t>[FORMAL PRESENTATION SCRIPT]</a:t>
+            </a:r>
+          </a:p>
+          <a:p>
+            <a:r>
+              <a:t>Slide 15 illustrates the architectural synthesis and complete UML Activity Diagram of our Soft Voting Ensemble Model, corresponding directly to Figure 12 in the project report.</a:t>
+            </a:r>
+          </a:p>
+          <a:p/>
+          <a:p>
+            <a:r>
+              <a:t>[DETAILED STEP-BY-STEP ENSEMBLE ACTIVITY FLOW]</a:t>
+            </a:r>
+          </a:p>
+          <a:p>
+            <a:r>
+              <a:t>1. Initial Node (Start): A raw clinical transcription text string is received by the system.</a:t>
+            </a:r>
+          </a:p>
+          <a:p>
+            <a:r>
+              <a:t>2. Clinical NLP Preprocessing: The string is cleaned, lowercased, tokenized, filtered for stopwords, and morphologically lemmatized.</a:t>
+            </a:r>
+          </a:p>
+          <a:p>
+            <a:r>
+              <a:t>3. TF-IDF Feature Extraction: The normalized token stream is transformed into a standardized numerical sparse vector x using the fitted vocabulary.</a:t>
+            </a:r>
+          </a:p>
+          <a:p>
+            <a:r>
+              <a:t>4. Fork Bar (Concurrent Classifier Evaluation): The feature vector x is broadcast simultaneously to all four trained base estimators:</a:t>
+            </a:r>
+          </a:p>
+          <a:p>
+            <a:r>
+              <a:t>   - Branch A: Linear SVM (Platt Calibrated) -&gt; computes P_SVM(c)</a:t>
+            </a:r>
+          </a:p>
+          <a:p>
+            <a:r>
+              <a:t>   - Branch B: Random Forest Classifier -&gt; computes P_RF(c)</a:t>
+            </a:r>
+          </a:p>
+          <a:p>
+            <a:r>
+              <a:t>   - Branch C: Logistic Regression (Softmax) -&gt; computes P_LR(c)</a:t>
+            </a:r>
+          </a:p>
+          <a:p>
+            <a:r>
+              <a:t>   - Branch D: Multinomial Naive Bayes -&gt; computes P_MNB(c)</a:t>
+            </a:r>
+          </a:p>
+          <a:p>
+            <a:r>
+              <a:t>5. Join Bar (Probability Matrix Collection): Synchronizes and collects the four 40-dimensional probability vectors into a unified consensus matrix.</a:t>
+            </a:r>
+          </a:p>
+          <a:p>
+            <a:r>
+              <a:t>6. Soft Voting Aggregation Activity: Evaluates the unweighted/weighted arithmetic mean: P_ensemble(c) = 1/4 * [ P_SVM(c) + P_RF(c) + P_LR(c) + P_MNB(c) ].</a:t>
+            </a:r>
+          </a:p>
+          <a:p>
+            <a:r>
+              <a:t>7. Argmax Decision Node: Evaluates y_hat = argmax_c P_ensemble(c) to select the specialty with the highest consensus confidence.</a:t>
+            </a:r>
+          </a:p>
+          <a:p>
+            <a:r>
+              <a:t>8. Terminal Node (End): Returns the predicted medical specialty along with top-3 candidate confidence scores.</a:t>
+            </a:r>
+          </a:p>
+          <a:p/>
+          <a:p>
+            <a:r>
+              <a:t>[THEORETICAL ADVANTAGE OF SOFT VOTING]</a:t>
+            </a:r>
+          </a:p>
+          <a:p>
+            <a:r>
+              <a:t>Unlike Hard Majority Voting (which counts discrete votes and discards confidence), Soft Voting weights predictions by continuous model certainty. If SVM and Logistic Regression are 90% confident on 'Cardiology', they overpower weak 51% majority ties from other models, significantly reducing error variance.</a:t>
+            </a:r>
+          </a:p>
+          <a:p/>
+          <a:p>
+            <a:r>
+              <a:t>[TRANSITION TO NEXT SLIDE]</a:t>
+            </a:r>
+          </a:p>
+          <a:p>
+            <a:r>
+              <a:t>Slide 16 presents the complete end-to-end macro system pipeline covering training, persistence, and web deployment.</a:t>
+            </a:r>
           </a:p>
         </p:txBody>
       </p:sp>
@@ -1047,10 +1642,107 @@
           <a:lstStyle/>
           <a:p>
             <a:r>
-              <a:rPr lang="en-US" dirty="0"/>
-              <a:t>This diagram brings everything together into the full project pipeline, organized into three stages. Data Preparation &amp; Partitioning covers ingesting the Kaggle MTSamples dataset, cleaning and null auditing, the stratified train-test split, text preprocessing, and fitting the TF-IDF vectorizer only on the training data. Model Building &amp; Ensemble covers training the calibrated SVM, Random Forest, Logistic Regression and Multinomial Naive Bayes, combining them with soft voting, evaluating with macro and weighted F1, precision and recall, and finally serializing the selected pipeline with Joblib. The Deployment stage takes that saved pipeline into a Flask web application where a clinician can input a transcription and receive a predicted specialty.</a:t>
-            </a:r>
-            <a:endParaRPr lang="en-US" dirty="0"/>
+              <a:t>[FORMAL PRESENTATION SCRIPT]</a:t>
+            </a:r>
+          </a:p>
+          <a:p>
+            <a:r>
+              <a:t>Slide 16 presents the macro-level UML Activity Diagram for the complete project lifecycle, corresponding to Figure 13 of the project report.</a:t>
+            </a:r>
+          </a:p>
+          <a:p/>
+          <a:p>
+            <a:r>
+              <a:t>[DETAILED END-TO-END PIPELINE WALKTHROUGH]</a:t>
+            </a:r>
+          </a:p>
+          <a:p/>
+          <a:p>
+            <a:r>
+              <a:t>• STAGE 1: Offline Data Preparation &amp; Model Training:</a:t>
+            </a:r>
+          </a:p>
+          <a:p>
+            <a:r>
+              <a:t>  1. Data Ingestion: Loads the raw Kaggle MTSamples CSV (4,999 records).</a:t>
+            </a:r>
+          </a:p>
+          <a:p>
+            <a:r>
+              <a:t>  2. Data Audit &amp; Cleansing: Drops 33 null transcription records, retaining 4,966 clean rows.</a:t>
+            </a:r>
+          </a:p>
+          <a:p>
+            <a:r>
+              <a:t>  3. Stratified Partitioning: Splits into 80% train (3,972) and 20% test (994) partitions with preserved class ratios.</a:t>
+            </a:r>
+          </a:p>
+          <a:p>
+            <a:r>
+              <a:t>  4. TF-IDF Fitting: Fits vectorizer strictly on training data; transforms test data.</a:t>
+            </a:r>
+          </a:p>
+          <a:p>
+            <a:r>
+              <a:t>  5. Multi-Model Training: Trains SVM, Random Forest, Logistic Regression, and Multinomial Naive Bayes.</a:t>
+            </a:r>
+          </a:p>
+          <a:p>
+            <a:r>
+              <a:t>  6. Soft Voting Ensemble Assembly: Chains models into a scikit-learn VotingClassifier(voting='soft').</a:t>
+            </a:r>
+          </a:p>
+          <a:p>
+            <a:r>
+              <a:t>  7. Evaluation &amp; Validation: Computes Precision, Recall, Macro-F1, and generates confusion matrices.</a:t>
+            </a:r>
+          </a:p>
+          <a:p>
+            <a:r>
+              <a:t>  8. Model Serialization: Persists finalized pipeline objects (`voting_model.pkl` and `tfidf_vectorizer.pkl`) to disk via Python `joblib` / `pickle`.</a:t>
+            </a:r>
+          </a:p>
+          <a:p/>
+          <a:p>
+            <a:r>
+              <a:t>• STAGE 2: Online Real-Time Inference &amp; Flask Web Deployment:</a:t>
+            </a:r>
+          </a:p>
+          <a:p>
+            <a:r>
+              <a:t>  1. User Input: Clinician enters or pastes a clinical narrative into the web GUI.</a:t>
+            </a:r>
+          </a:p>
+          <a:p>
+            <a:r>
+              <a:t>  2. HTTP Request: Browser dispatches POST request with text payload to Flask backend.</a:t>
+            </a:r>
+          </a:p>
+          <a:p>
+            <a:r>
+              <a:t>  3. Deserialization &amp; Pipeline Execution: Flask loads serialized artifacts, executes identical NLP preprocessing and TF-IDF vectorization.</a:t>
+            </a:r>
+          </a:p>
+          <a:p>
+            <a:r>
+              <a:t>  4. Soft Voting Inference: The ensemble predicts the top medical specialty and confidence scores in under 200 milliseconds.</a:t>
+            </a:r>
+          </a:p>
+          <a:p>
+            <a:r>
+              <a:t>  5. Response Rendering: Formatted JSON/HTML results are displayed on the clinician's dashboard.</a:t>
+            </a:r>
+          </a:p>
+          <a:p/>
+          <a:p>
+            <a:r>
+              <a:t>[TRANSITION TO NEXT SLIDE]</a:t>
+            </a:r>
+          </a:p>
+          <a:p>
+            <a:r>
+              <a:t>Slide 17 summarizes our project progress and implementation roadmap.</a:t>
+            </a:r>
           </a:p>
         </p:txBody>
       </p:sp>
@@ -1135,10 +1827,121 @@
           <a:lstStyle/>
           <a:p>
             <a:r>
-              <a:rPr lang="en-US" dirty="0"/>
-              <a:t>This is a proposed wireframe for the Flask-based deployment, not a finished application. The clinician would paste a clinical transcription into the text area, optionally upload a file instead, and click Predict Specialty. The result panel would then show the predicted medical specialty along with a confidence score bar, since the project pipeline I showed earlier explicitly plans a prediction result with a confidence score. The example specialty shown here is only illustrative — no model has actually been trained or deployed yet; this is purely a design mockup for the upcoming GUI development phase.</a:t>
-            </a:r>
-            <a:endParaRPr lang="en-US" dirty="0"/>
+              <a:t>[FORMAL PRESENTATION SCRIPT]</a:t>
+            </a:r>
+          </a:p>
+          <a:p>
+            <a:r>
+              <a:t>Slide 17 presents our current project implementation status and roadmap across all four project phases.</a:t>
+            </a:r>
+          </a:p>
+          <a:p/>
+          <a:p>
+            <a:r>
+              <a:t>[PHASE-BY-PHASE STATUS]</a:t>
+            </a:r>
+          </a:p>
+          <a:p>
+            <a:r>
+              <a:t>• Phase 1: Problem Formulation &amp; Literature Review (100% COMPLETED):</a:t>
+            </a:r>
+          </a:p>
+          <a:p>
+            <a:r>
+              <a:t>  - Conducted extensive literature review of text mining in clinical domains.</a:t>
+            </a:r>
+          </a:p>
+          <a:p>
+            <a:r>
+              <a:t>  - Formulated problem statement, technical objectives, and scope.</a:t>
+            </a:r>
+          </a:p>
+          <a:p>
+            <a:r>
+              <a:t>  - Established project repository and version-controlled codebase.</a:t>
+            </a:r>
+          </a:p>
+          <a:p>
+            <a:r>
+              <a:t>• Phase 2: Dataset Acquisition &amp; Exploratory Data Analysis (100% COMPLETED):</a:t>
+            </a:r>
+          </a:p>
+          <a:p>
+            <a:r>
+              <a:t>  - Ingested and profiled all 4,999 MTSamples records across 40 classes.</a:t>
+            </a:r>
+          </a:p>
+          <a:p>
+            <a:r>
+              <a:t>  - Completed missing value analysis, deduplication, and class distribution audits.</a:t>
+            </a:r>
+          </a:p>
+          <a:p>
+            <a:r>
+              <a:t>  - Implemented 5-step clinical NLP cleaning pipeline and verified zero data leakage.</a:t>
+            </a:r>
+          </a:p>
+          <a:p>
+            <a:r>
+              <a:t>• Phase 3: Model Development &amp; Ensemble Optimization (IN PROGRESS - 40% COMPLETED):</a:t>
+            </a:r>
+          </a:p>
+          <a:p>
+            <a:r>
+              <a:t>  - Implemented baseline classifiers: Linear SVM, Random Forest, Logistic Regression, and MNB.</a:t>
+            </a:r>
+          </a:p>
+          <a:p>
+            <a:r>
+              <a:t>  - Currently tuning hyperparameters using Stratified 5-fold cross-validation with GridSearchCV.</a:t>
+            </a:r>
+          </a:p>
+          <a:p>
+            <a:r>
+              <a:t>  - Calibrating probability estimators for optimal soft voting weights.</a:t>
+            </a:r>
+          </a:p>
+          <a:p>
+            <a:r>
+              <a:t>• Phase 4: Web Application Deployment &amp; Evaluation (UPCOMING - 0% COMPLETED):</a:t>
+            </a:r>
+          </a:p>
+          <a:p>
+            <a:r>
+              <a:t>  - Building lightweight Flask application backend with REST API endpoint.</a:t>
+            </a:r>
+          </a:p>
+          <a:p>
+            <a:r>
+              <a:t>  - Designing clean, responsive web interface for clinical text submission.</a:t>
+            </a:r>
+          </a:p>
+          <a:p>
+            <a:r>
+              <a:t>  - Conducting stress testing, latency benchmarking, and final report compilation.</a:t>
+            </a:r>
+          </a:p>
+          <a:p/>
+          <a:p>
+            <a:r>
+              <a:t>[CORE TECHNOLOGY STACK]</a:t>
+            </a:r>
+          </a:p>
+          <a:p>
+            <a:r>
+              <a:t>Python 3.10+, Scikit-Learn, Pandas, NumPy, NLTK, Matplotlib, Seaborn, Flask, HTML5/CSS3.</a:t>
+            </a:r>
+          </a:p>
+          <a:p/>
+          <a:p>
+            <a:r>
+              <a:t>[TRANSITION TO NEXT SLIDE]</a:t>
+            </a:r>
+          </a:p>
+          <a:p>
+            <a:r>
+              <a:t>On Slide 18, we review the project execution timeline, milestone schedule, and risk management strategies.</a:t>
+            </a:r>
           </a:p>
         </p:txBody>
       </p:sp>
@@ -1223,10 +2026,76 @@
           <a:lstStyle/>
           <a:p>
             <a:r>
-              <a:rPr lang="en-US" dirty="0"/>
-              <a:t>On the left are the planned GUI components: a text input area for pasting clinical narratives, an optional file upload, a predict button that triggers the preprocessing and ensemble pipeline, a result panel showing the predicted specialty, and a confidence display. On the right is my current project progress. Completed so far: the literature review, dataset collection, statistical and exploratory data analysis, data visualization, and the design of the preprocessing and TF-IDF methodology, along with algorithm selection and the overall architecture. Still upcoming: implementing the full preprocessing and TF-IDF pipeline, training and tuning the four classifiers, building the voting ensemble, evaluating it, and finally developing and deploying the Flask GUI.</a:t>
-            </a:r>
-            <a:endParaRPr lang="en-US" dirty="0"/>
+              <a:t>[FORMAL PRESENTATION SCRIPT]</a:t>
+            </a:r>
+          </a:p>
+          <a:p>
+            <a:r>
+              <a:t>Slide 18 details our structured 16-week project execution timeline, key milestones M1 through M6, and risk management strategies.</a:t>
+            </a:r>
+          </a:p>
+          <a:p/>
+          <a:p>
+            <a:r>
+              <a:t>[16-WEEK TIMELINE &amp; MILESTONES]</a:t>
+            </a:r>
+          </a:p>
+          <a:p>
+            <a:r>
+              <a:t>• Weeks 1–4 (Month 1): Problem formulation, literature survey, environment setup. -&gt; Milestone M1: Topic Approval &amp; Feasibility Report.</a:t>
+            </a:r>
+          </a:p>
+          <a:p>
+            <a:r>
+              <a:t>• Weeks 5–8 (Month 2): Dataset acquisition, EDA, data quality audit, baseline NLP pipeline. -&gt; Milestone M2: EDA Completion &amp; Initial Project Review (CURRENT REVIEW).</a:t>
+            </a:r>
+          </a:p>
+          <a:p>
+            <a:r>
+              <a:t>• Weeks 9–12 (Month 3): Advanced feature engineering, ensemble optimization, hyperparameter tuning via GridSearchCV. -&gt; Milestone M3: Model Optimization &amp; Milestone M4: Internal Review.</a:t>
+            </a:r>
+          </a:p>
+          <a:p>
+            <a:r>
+              <a:t>• Weeks 13–16 (Month 4): Flask web app development, UI integration, latency benchmarking, final documentation. -&gt; Milestone M5: Web Deployment &amp; Milestone M6: Final Defense.</a:t>
+            </a:r>
+          </a:p>
+          <a:p/>
+          <a:p>
+            <a:r>
+              <a:t>[RISK MANAGEMENT &amp; MITIGATION STRATEGIES]</a:t>
+            </a:r>
+          </a:p>
+          <a:p>
+            <a:r>
+              <a:t>• Risk 1 (Extreme Class Imbalance): Mitigated via stratified splitting, cost-sensitive class weighting (`class_weight='balanced'`), and soft probability aggregation.</a:t>
+            </a:r>
+          </a:p>
+          <a:p>
+            <a:r>
+              <a:t>• Risk 2 (Inference Latency): Mitigated by choosing sublinear TF-IDF over heavy deep learning models, enabling sub-200ms CPU inference.</a:t>
+            </a:r>
+          </a:p>
+          <a:p>
+            <a:r>
+              <a:t>• Risk 3 (Data Leakage): Mitigated by strictly fitting the vectorizer on training data and applying frozen transforms on test sets.</a:t>
+            </a:r>
+          </a:p>
+          <a:p>
+            <a:r>
+              <a:t>• Risk 4 (High-Dimensional Sparsity): Mitigated by frequency pruning (`min_df=3`, `max_df=0.85`) and L2 regularization in base models.</a:t>
+            </a:r>
+          </a:p>
+          <a:p/>
+          <a:p>
+            <a:r>
+              <a:t>[TRANSITION TO NEXT SLIDE]</a:t>
+            </a:r>
+          </a:p>
+          <a:p>
+            <a:r>
+              <a:t>This brings me to the conclusion of my presentation on Slide 19.</a:t>
+            </a:r>
           </a:p>
         </p:txBody>
       </p:sp>
@@ -1311,10 +2180,62 @@
           <a:lstStyle/>
           <a:p>
             <a:r>
-              <a:rPr lang="en-US" dirty="0"/>
-              <a:t>Manual sorting of clinical transcription reports into specialties like Cardiology or Orthopedic is time-consuming and inconsistent between reviewers. My objective is to automate this using NLP and ensemble machine learning. On the left is the problem, on the right the objective. Below I list four concrete project objectives: exploring the dataset, building a text preprocessing pipeline, extracting TF-IDF features, and finally combining four classifiers using a voting ensemble, which will be deployed through a Flask web application so a clinician could paste in a report and get a predicted specialty.</a:t>
-            </a:r>
-            <a:endParaRPr lang="en-US" dirty="0"/>
+              <a:t>[FORMAL PRESENTATION SCRIPT]</a:t>
+            </a:r>
+          </a:p>
+          <a:p>
+            <a:r>
+              <a:t>Moving to Slide 2, let us look closely at why automated clinical specialty categorization is a vital healthcare informatics challenge.</a:t>
+            </a:r>
+          </a:p>
+          <a:p/>
+          <a:p>
+            <a:r>
+              <a:t>As shown on the left, clinical narratives are inherently unstructured, written in dense physician shorthand with complex jargon, abbreviations, and variable lengths. In hospitals, medical coders manually inspect these narratives to assign departmental specialty tags. This process is time-consuming, prone to human fatigue, expensive, and inconsistent across coders.</a:t>
+            </a:r>
+          </a:p>
+          <a:p/>
+          <a:p>
+            <a:r>
+              <a:t>Our objective, shown on the right, is to design and implement an end-to-end Machine Learning pipeline that automates this categorization, speeding up document routing and eliminating administrative bottlenecks.</a:t>
+            </a:r>
+          </a:p>
+          <a:p/>
+          <a:p>
+            <a:r>
+              <a:t>[KEY OBJECTIVES EXPLAINED]</a:t>
+            </a:r>
+          </a:p>
+          <a:p>
+            <a:r>
+              <a:t>1. Explore &amp; Analyze: Conduct exhaustive statistical and exploratory analysis on the Kaggle MTSamples clinical transcription dataset across all 40 specialties.</a:t>
+            </a:r>
+          </a:p>
+          <a:p>
+            <a:r>
+              <a:t>2. Preprocess Text: Build a robust 5-step clinical NLP cleaning sequence to eliminate noise while preserving clinical root meanings.</a:t>
+            </a:r>
+          </a:p>
+          <a:p>
+            <a:r>
+              <a:t>3. Extract Features: Transform raw text into standardized, high-dimensional numerical feature vectors using sublinear TF-IDF.</a:t>
+            </a:r>
+          </a:p>
+          <a:p>
+            <a:r>
+              <a:t>4. Ensemble &amp; Deploy: Train and ensemble four diverse machine learning models via soft voting to handle severe class imbalance, deploying the finalized model through an interactive Flask web application.</a:t>
+            </a:r>
+          </a:p>
+          <a:p/>
+          <a:p>
+            <a:r>
+              <a:t>[TRANSITION TO NEXT SLIDE]</a:t>
+            </a:r>
+          </a:p>
+          <a:p>
+            <a:r>
+              <a:t>To ground our methodology in established research, I conducted an extensive review of the literature, summarized on Slide 3.</a:t>
+            </a:r>
           </a:p>
         </p:txBody>
       </p:sp>
@@ -1399,10 +2320,50 @@
           <a:lstStyle/>
           <a:p>
             <a:r>
-              <a:rPr lang="en-US" dirty="0"/>
-              <a:t>To conclude: this project addresses automating medical specialty classification from unstructured clinical transcriptions. So far I have completed dataset exploration and statistical analysis of all 4,999 MTSamples records across 40 specialties, identified class imbalance and text-length variation through EDA, and designed an 8-step preprocessing pipeline together with a TF-IDF feature extraction approach and a 4-model voting ensemble. The next phase of work is implementing this pipeline end to end: fitting TF-IDF, training and tuning the four classifiers, calibrating SVM and building the soft-voting ensemble, evaluating with standard multi-class metrics, and finally deploying the Flask web application. Thank you, and I welcome any questions.</a:t>
-            </a:r>
-            <a:endParaRPr lang="en-US" dirty="0"/>
+              <a:t>[FORMAL PRESENTATION SCRIPT]</a:t>
+            </a:r>
+          </a:p>
+          <a:p>
+            <a:r>
+              <a:t>Thank you, respected Guide Prof. Biju Skaria, Chairperson, and distinguished members of the evaluation committee, for your time, patient listening, and constructive guidance.</a:t>
+            </a:r>
+          </a:p>
+          <a:p/>
+          <a:p>
+            <a:r>
+              <a:t>[SUMMARY RECAP]</a:t>
+            </a:r>
+          </a:p>
+          <a:p>
+            <a:r>
+              <a:t>In summary, this first review has demonstrated:</a:t>
+            </a:r>
+          </a:p>
+          <a:p>
+            <a:r>
+              <a:t>1. A rigorous formulation of the automated clinical transcription classification problem.</a:t>
+            </a:r>
+          </a:p>
+          <a:p>
+            <a:r>
+              <a:t>2. Comprehensive exploratory data analysis across all 4,999 records and 40 medical specialties.</a:t>
+            </a:r>
+          </a:p>
+          <a:p>
+            <a:r>
+              <a:t>3. Concrete architectural solutions to mitigate severe class imbalance, high vocabulary dimensionality, and document length variance.</a:t>
+            </a:r>
+          </a:p>
+          <a:p>
+            <a:r>
+              <a:t>4. A clear, scientifically validated UML activity workflow for our four base estimators and Soft Voting Ensemble.</a:t>
+            </a:r>
+          </a:p>
+          <a:p/>
+          <a:p>
+            <a:r>
+              <a:t>I am deeply grateful for your feedback and now warmly open the floor for your questions, suggestions, and technical discussion.</a:t>
+            </a:r>
           </a:p>
         </p:txBody>
       </p:sp>
@@ -1487,10 +2448,87 @@
           <a:lstStyle/>
           <a:p>
             <a:r>
-              <a:rPr lang="en-US" dirty="0"/>
-              <a:t>I reviewed three key papers. Omar and colleagues compared classical and neural text representations and found Word2Vec with k-NN gave the best accuracy at 92 percent, but distance-based k-NN is slow at scale; their 4-phase pipeline of preprocessing, vectorization, feature reduction, and classification inspired my own workflow. Zhang and colleagues used synthetic data augmentation and BERT on a smaller 18-class version of the same MTSamples dataset, gaining 14.9 percent, but needing GPU infrastructure. Blanchard and colleagues showed that keyword-weighted features help rare classes, which supports using TF-IDF n-grams instead of manually curated keyword dictionaries. Together, these gaps motivate my lightweight, CPU-friendly TF-IDF plus ensemble approach.</a:t>
-            </a:r>
-            <a:endParaRPr lang="en-US" dirty="0"/>
+              <a:t>[FORMAL PRESENTATION SCRIPT]</a:t>
+            </a:r>
+          </a:p>
+          <a:p>
+            <a:r>
+              <a:t>On Slide 4, I have synthesized three pivotal research publications that directly influenced our pipeline design.</a:t>
+            </a:r>
+          </a:p>
+          <a:p/>
+          <a:p>
+            <a:r>
+              <a:t>[PAPER 1: Omar et al. (2023, iJOE)]</a:t>
+            </a:r>
+          </a:p>
+          <a:p>
+            <a:r>
+              <a:t>• Methodology: Compared classical feature representations (Bag-of-Words, TF-IDF, Word2Vec) across multiple classifiers including Logistic Regression, SVM, Naive Bayes, and k-NN.</a:t>
+            </a:r>
+          </a:p>
+          <a:p>
+            <a:r>
+              <a:t>• Key Finding: Word2Vec + k-NN achieved the highest accuracy at 92%, but distance-based k-NN scales poorly during inference on large, expanding hospital databases.</a:t>
+            </a:r>
+          </a:p>
+          <a:p>
+            <a:r>
+              <a:t>• Relevance: Validated the standard 4-phase preprocessing pipeline and guided us toward parametric, computationally lightweight linear and ensemble classifiers.</a:t>
+            </a:r>
+          </a:p>
+          <a:p/>
+          <a:p>
+            <a:r>
+              <a:t>[PAPER 2: Zhang et al. (2023, Hindawi CIN)]</a:t>
+            </a:r>
+          </a:p>
+          <a:p>
+            <a:r>
+              <a:t>• Methodology: Explored SemiADA synthetic data augmentation paired with BERT on an 18-class MTSamples subset.</a:t>
+            </a:r>
+          </a:p>
+          <a:p>
+            <a:r>
+              <a:t>• Key Finding: Demonstrated that class imbalance is the primary cause of clinical classification error, achieving a +14.9% gain with augmentation, but at the cost of heavy GPU fine-tuning overhead.</a:t>
+            </a:r>
+          </a:p>
+          <a:p>
+            <a:r>
+              <a:t>• Relevance: Highlighted the extreme class imbalance in MTSamples and motivated our approach: an accessible TF-IDF + soft voting ensemble that mitigates imbalance through probability calibration without requiring expensive GPU clusters.</a:t>
+            </a:r>
+          </a:p>
+          <a:p/>
+          <a:p>
+            <a:r>
+              <a:t>[PAPER 3: Blanchard et al. (2022, IEEE JBHI)]</a:t>
+            </a:r>
+          </a:p>
+          <a:p>
+            <a:r>
+              <a:t>• Methodology: Designed a CNN with keyword-constrained loss for cancer pathology text on the NCI SEER registry.</a:t>
+            </a:r>
+          </a:p>
+          <a:p>
+            <a:r>
+              <a:t>• Key Finding: Proved that clinical keywords carry the bulk of diagnostic signal; keyword weighting significantly improved macro-F1 and recall on rare classes without hurting majority performance.</a:t>
+            </a:r>
+          </a:p>
+          <a:p>
+            <a:r>
+              <a:t>• Relevance: Justified our choice of sublinear TF-IDF with n-gram weighting to preserve and amplify predictive medical terms for rare specialty classes.</a:t>
+            </a:r>
+          </a:p>
+          <a:p/>
+          <a:p>
+            <a:r>
+              <a:t>[TRANSITION TO NEXT SLIDE]</a:t>
+            </a:r>
+          </a:p>
+          <a:p>
+            <a:r>
+              <a:t>With this literature background established, let us inspect the empirical dataset used in this research, shown on Slide 5.</a:t>
+            </a:r>
           </a:p>
         </p:txBody>
       </p:sp>
@@ -1575,10 +2613,96 @@
           <a:lstStyle/>
           <a:p>
             <a:r>
-              <a:rPr lang="en-US" dirty="0"/>
-              <a:t>The dataset is the Kaggle Medical Transcriptions or MTSamples dataset, containing 4,999 real clinical dictation reports spread across 40 medical specialties. It has six columns: an index, a short description, the target medical_specialty label, a sample name, the main transcription narrative, and extracted keywords. The transcription column is my primary input feature since it holds the full clinical narrative, and medical_specialty is the target I am predicting. The dataset is nearly complete for the target label with zero missing values, while the transcription field has only 33 missing records out of 4,999, which is under one percent.</a:t>
-            </a:r>
-            <a:endParaRPr lang="en-US" dirty="0"/>
+              <a:t>[FORMAL PRESENTATION SCRIPT]</a:t>
+            </a:r>
+          </a:p>
+          <a:p>
+            <a:r>
+              <a:t>Slide 5 introduces the dataset: the Kaggle MTSamples Medical Transcriptions dataset, a well-established open-source benchmark in healthcare text analytics.</a:t>
+            </a:r>
+          </a:p>
+          <a:p/>
+          <a:p>
+            <a:r>
+              <a:t>[DATASET SPECIFICATIONS &amp; SCHEMA]</a:t>
+            </a:r>
+          </a:p>
+          <a:p>
+            <a:r>
+              <a:t>• Source: Authentic clinical dictations transcribed from MTSamples.com, covering real-world patient histories, physical exams, diagnostic consultations, and operative notes.</a:t>
+            </a:r>
+          </a:p>
+          <a:p>
+            <a:r>
+              <a:t>• Scale: Exactly 4,999 clinical records categorized into 40 distinct medical specialties.</a:t>
+            </a:r>
+          </a:p>
+          <a:p>
+            <a:r>
+              <a:t>• 6 Attributes:</a:t>
+            </a:r>
+          </a:p>
+          <a:p>
+            <a:r>
+              <a:t>  1. Unnamed: 0: Integer row identifier / index.</a:t>
+            </a:r>
+          </a:p>
+          <a:p>
+            <a:r>
+              <a:t>  2. description: Short 1–2 sentence summary of the clinical encounter.</a:t>
+            </a:r>
+          </a:p>
+          <a:p>
+            <a:r>
+              <a:t>  3. medical_specialty: The ground-truth categorical target label spanning 40 clinical classes.</a:t>
+            </a:r>
+          </a:p>
+          <a:p>
+            <a:r>
+              <a:t>  4. sample_name: Specific clinical dictation or procedure heading.</a:t>
+            </a:r>
+          </a:p>
+          <a:p>
+            <a:r>
+              <a:t>  5. transcription: The primary independent feature containing the unstructured narrative text.</a:t>
+            </a:r>
+          </a:p>
+          <a:p>
+            <a:r>
+              <a:t>  6. keywords: Comma-separated extracted medical keywords.</a:t>
+            </a:r>
+          </a:p>
+          <a:p/>
+          <a:p>
+            <a:r>
+              <a:t>[INITIAL QUALITY AUDIT]</a:t>
+            </a:r>
+          </a:p>
+          <a:p>
+            <a:r>
+              <a:t>• Data Completeness: The target attribute `medical_specialty` has 0 missing values across all 4,999 rows (100% complete).</a:t>
+            </a:r>
+          </a:p>
+          <a:p>
+            <a:r>
+              <a:t>• Feature Completeness: The `transcription` narrative is 99.34% complete, with only 33 null records (0.66%).</a:t>
+            </a:r>
+          </a:p>
+          <a:p>
+            <a:r>
+              <a:t>• High Sparsity in Keywords: `keywords` is missing in 1,068 records (21.36%), confirming that we must extract features directly from raw transcription text rather than relying on keywords.</a:t>
+            </a:r>
+          </a:p>
+          <a:p/>
+          <a:p>
+            <a:r>
+              <a:t>[TRANSITION TO NEXT SLIDE]</a:t>
+            </a:r>
+          </a:p>
+          <a:p>
+            <a:r>
+              <a:t>On Slide 6, we examine the statistical verification and structural profiling performed on this dataset.</a:t>
+            </a:r>
           </a:p>
         </p:txBody>
       </p:sp>
@@ -1663,10 +2787,55 @@
           <a:lstStyle/>
           <a:p>
             <a:r>
-              <a:rPr lang="en-US" dirty="0"/>
-              <a:t>For statistical analysis I used pandas and numpy. I applied dataset exploration functions such as shape, info(), dtypes, describe(), head(), and columns to understand the structure. The table on the right is a representative info()-style summary: it confirms 4,999 rows and 6 columns with no structural corruption. The key findings box on the left summarizes what this told me: the target column medical_specialty has zero missing values, which is great for supervised learning, transcription is 99.3 percent complete, and keywords is missing over a thousand records, so I exclude it from the primary feature set.</a:t>
-            </a:r>
-            <a:endParaRPr lang="en-US" dirty="0"/>
+              <a:t>[FORMAL PRESENTATION SCRIPT]</a:t>
+            </a:r>
+          </a:p>
+          <a:p>
+            <a:r>
+              <a:t>Slide 6 presents the statistical profiling of the dataset conducted using Python's pandas and NumPy libraries.</a:t>
+            </a:r>
+          </a:p>
+          <a:p/>
+          <a:p>
+            <a:r>
+              <a:t>[STATISTICAL VERIFICATION]</a:t>
+            </a:r>
+          </a:p>
+          <a:p>
+            <a:r>
+              <a:t>• Programmatic Inspection: We applied standard DataFrame inspection methods: `df.shape`, `df.info()`, `df.dtypes`, `df.describe()`, `df.head()`, and `df.memory_usage(deep=True)`.</a:t>
+            </a:r>
+          </a:p>
+          <a:p>
+            <a:r>
+              <a:t>• Dimensions: Verified exact dimensions of 4,999 observations and 6 attributes.</a:t>
+            </a:r>
+          </a:p>
+          <a:p>
+            <a:r>
+              <a:t>• Data Types: Confirmed 1 integer index column and 5 object (string) columns. Total memory usage in pandas is approximately 25 megabytes.</a:t>
+            </a:r>
+          </a:p>
+          <a:p>
+            <a:r>
+              <a:t>• Text Description Analysis: Descriptive statistics confirm that `transcription` is free-form natural language text of highly variable length and rich clinical vocabulary.</a:t>
+            </a:r>
+          </a:p>
+          <a:p>
+            <a:r>
+              <a:t>• Deduplication Check: Checked via `df.duplicated(subset=['transcription'])`. Confirmed no duplicate clinical narratives in the corpus, ruling out artificial memorization or data leakage.</a:t>
+            </a:r>
+          </a:p>
+          <a:p/>
+          <a:p>
+            <a:r>
+              <a:t>[TRANSITION TO NEXT SLIDE]</a:t>
+            </a:r>
+          </a:p>
+          <a:p>
+            <a:r>
+              <a:t>Next, on Slide 7, we visualize our missing value audit across all dataset attributes.</a:t>
+            </a:r>
           </a:p>
         </p:txBody>
       </p:sp>
@@ -1751,10 +2920,50 @@
           <a:lstStyle/>
           <a:p>
             <a:r>
-              <a:rPr lang="en-US" dirty="0"/>
-              <a:t>Data quality was checked using pandas' isnull().sum() and duplicated() functions, visualized here with matplotlib and seaborn. The chart shows that transcription, my primary input, is missing only 33 out of 4,999 records — well under one percent. The keywords column is missing 1,068 records, so I am excluding it from primary modeling since it is too sparse to rely on. The target column, medical_specialty, has zero missing values, which is ideal since a supervised classifier needs every training example labeled. I also verified there are no duplicate clinical reports in the corpus.</a:t>
-            </a:r>
-            <a:endParaRPr lang="en-US" dirty="0"/>
+              <a:t>[FORMAL PRESENTATION SCRIPT]</a:t>
+            </a:r>
+          </a:p>
+          <a:p>
+            <a:r>
+              <a:t>Slide 7 visualizes the data quality audit, specifically analyzing missing values across all dataset fields using pandas `isnull().sum()`, rendered with Seaborn and Matplotlib.</a:t>
+            </a:r>
+          </a:p>
+          <a:p/>
+          <a:p>
+            <a:r>
+              <a:t>[DATA QUALITY AUDIT FINDINGS]</a:t>
+            </a:r>
+          </a:p>
+          <a:p>
+            <a:r>
+              <a:t>• `transcription` (Primary Feature): 33 missing values out of 4,999 (0.66%). In text classification, imputing missing free-form narrative text is statistically invalid. Because 0.66% is negligible, dropping these 33 rows leaves 4,966 high-integrity records with zero synthetic distortion.</a:t>
+            </a:r>
+          </a:p>
+          <a:p>
+            <a:r>
+              <a:t>• `keywords`: 1,068 missing records (21.36%). This severe sparsity validates our architectural choice to discard `keywords` and derive our own TF-IDF feature space directly from the full transcription text.</a:t>
+            </a:r>
+          </a:p>
+          <a:p>
+            <a:r>
+              <a:t>• `description`: 6 missing records (0.12%).</a:t>
+            </a:r>
+          </a:p>
+          <a:p>
+            <a:r>
+              <a:t>• `medical_specialty` (Target Label): 0 missing records (0.00%). Every record is deterministically labeled, providing a clean ground truth for supervised multi-class learning.</a:t>
+            </a:r>
+          </a:p>
+          <a:p/>
+          <a:p>
+            <a:r>
+              <a:t>[TRANSITION TO NEXT SLIDE]</a:t>
+            </a:r>
+          </a:p>
+          <a:p>
+            <a:r>
+              <a:t>Let us now turn to Slide 8 to analyze the distribution of our target variable, which reveals our primary modeling challenge: class imbalance.</a:t>
+            </a:r>
           </a:p>
         </p:txBody>
       </p:sp>
@@ -1839,10 +3048,70 @@
           <a:lstStyle/>
           <a:p>
             <a:r>
-              <a:rPr lang="en-US" dirty="0"/>
-              <a:t>This chart, built with matplotlib and seaborn, shows the full class distribution across all 40 medical specialties. Surgery dominates with 1,103 records, while specialties like Autopsy and Executive Evaluation have only 2 records each. This is a textbook case of severe class imbalance. It directly affects my modeling choices: I plan to use stratified 80:20 train-test splitting so every specialty is proportionally represented in both sets, and a soft-voting ensemble so no single classifier's bias toward the majority class dominates the final prediction.</a:t>
-            </a:r>
-            <a:endParaRPr lang="en-US" dirty="0"/>
+              <a:t>[FORMAL PRESENTATION SCRIPT]</a:t>
+            </a:r>
+          </a:p>
+          <a:p>
+            <a:r>
+              <a:t>Slide 8 displays the complete distribution across all 40 medical specialty classes in the MTSamples dataset, generated using Seaborn and Matplotlib.</a:t>
+            </a:r>
+          </a:p>
+          <a:p/>
+          <a:p>
+            <a:r>
+              <a:t>[CLASS IMBALANCE ANALYSIS]</a:t>
+            </a:r>
+          </a:p>
+          <a:p>
+            <a:r>
+              <a:t>• Extreme Imbalance Ratio: The dataset exhibits a severe long-tail Pareto distribution:</a:t>
+            </a:r>
+          </a:p>
+          <a:p>
+            <a:r>
+              <a:t>  - Majority Class: 'Surgery' dominates with 1,103 records (over 22% of the entire dataset).</a:t>
+            </a:r>
+          </a:p>
+          <a:p>
+            <a:r>
+              <a:t>  - Next Largest Classes: 'Consult - History and Phy.' has 516 records, and 'Cardiovascular / Pulmonary' has 371 records.</a:t>
+            </a:r>
+          </a:p>
+          <a:p>
+            <a:r>
+              <a:t>  - Minority Classes: Rare specialties at the tail have very few samples—'Autopsy' and 'Executive Evaluation' have only 2 records each; 'Hospice - Palliative Care' has only 6 records.</a:t>
+            </a:r>
+          </a:p>
+          <a:p>
+            <a:r>
+              <a:t>• Why This Matters for Modeling:</a:t>
+            </a:r>
+          </a:p>
+          <a:p>
+            <a:r>
+              <a:t>  1. Standard train/test splitting would randomly place rare classes entirely in the training set or test set, causing evaluation failure. A strictly stratified train-test split (`stratify=y`) is mandatory.</a:t>
+            </a:r>
+          </a:p>
+          <a:p>
+            <a:r>
+              <a:t>  2. Standard Accuracy is a misleading metric under severe imbalance (a naive model predicting 'Surgery' always would achieve ~22% accuracy). Evaluation must rely on Macro-averaged Precision, Recall, and F1-score.</a:t>
+            </a:r>
+          </a:p>
+          <a:p>
+            <a:r>
+              <a:t>  3. Classifiers must incorporate cost-sensitive weighting (`class_weight='balanced'`) and probability calibration.</a:t>
+            </a:r>
+          </a:p>
+          <a:p/>
+          <a:p>
+            <a:r>
+              <a:t>[TRANSITION TO NEXT SLIDE]</a:t>
+            </a:r>
+          </a:p>
+          <a:p>
+            <a:r>
+              <a:t>Having analyzed the target labels, on Slide 9 we inspect the linguistic characteristics of the clinical narratives.</a:t>
+            </a:r>
           </a:p>
         </p:txBody>
       </p:sp>
@@ -1927,10 +3196,75 @@
           <a:lstStyle/>
           <a:p>
             <a:r>
-              <a:rPr lang="en-US" dirty="0"/>
-              <a:t>Looking at the text itself: the left chart shows transcription length is right-skewed, with most reports between 200 and 600 words but some extending to nearly 3,000 words. The word cloud on the right, generated with the WordCloud library, shows the most frequent terms across the whole corpus — words like placed, noted, used, and removed. These are generic documentation words that appear in almost every specialty, not distinguishing vocabulary. This is exactly why TF-IDF is useful: its inverse-document-frequency term automatically down-weights these common words and up-weights rarer, more specialty-specific medical terms.</a:t>
-            </a:r>
-            <a:endParaRPr lang="en-US" dirty="0"/>
+              <a:t>[FORMAL PRESENTATION SCRIPT]</a:t>
+            </a:r>
+          </a:p>
+          <a:p>
+            <a:r>
+              <a:t>Slide 9 examines the word count distribution and clinical vocabulary extracted from the transcription narratives.</a:t>
+            </a:r>
+          </a:p>
+          <a:p/>
+          <a:p>
+            <a:r>
+              <a:t>[TEXT LENGTH &amp; VOCABULARY INSIGHTS]</a:t>
+            </a:r>
+          </a:p>
+          <a:p>
+            <a:r>
+              <a:t>• Word Count Distribution (Left Chart):</a:t>
+            </a:r>
+          </a:p>
+          <a:p>
+            <a:r>
+              <a:t>  - Highly right-skewed distribution. The median narrative length is approximately 435 words, with the interquartile range between 210 and 680 words.</a:t>
+            </a:r>
+          </a:p>
+          <a:p>
+            <a:r>
+              <a:t>  - However, comprehensive surgical and operative notes extend up to nearly 3,000 words.</a:t>
+            </a:r>
+          </a:p>
+          <a:p>
+            <a:r>
+              <a:t>  - This extreme variability justifies document-level L2 normalization in TF-IDF, ensuring that lengthy documents do not artificially dominate feature magnitudes.</a:t>
+            </a:r>
+          </a:p>
+          <a:p>
+            <a:r>
+              <a:t>• Word Cloud of High-Frequency Terms (Right Chart):</a:t>
+            </a:r>
+          </a:p>
+          <a:p>
+            <a:r>
+              <a:t>  - Generated using the Python `wordcloud` library.</a:t>
+            </a:r>
+          </a:p>
+          <a:p>
+            <a:r>
+              <a:t>  - Prominent terms include 'patient', 'procedure', 'left', 'right', 'placed', 'noted', 'history', 'normal', 'tolerated'.</a:t>
+            </a:r>
+          </a:p>
+          <a:p>
+            <a:r>
+              <a:t>  - These ubiquitous terms represent generic clinical documentation boilerplate common across almost all hospital encounters.</a:t>
+            </a:r>
+          </a:p>
+          <a:p>
+            <a:r>
+              <a:t>  - Without proper Inverse Document Frequency (IDF) down-weighting and clinical stopword filtering, these frequent words act as noise and overpower discriminative specialty terms (e.g., 'myocardial', 'laparoscopic', 'electroencephalogram').</a:t>
+            </a:r>
+          </a:p>
+          <a:p/>
+          <a:p>
+            <a:r>
+              <a:t>[TRANSITION TO NEXT SLIDE]</a:t>
+            </a:r>
+          </a:p>
+          <a:p>
+            <a:r>
+              <a:t>Slide 10 synthesizes these empirical findings into four foundational modeling conclusions.</a:t>
+            </a:r>
           </a:p>
         </p:txBody>
       </p:sp>
@@ -2015,10 +3349,75 @@
           <a:lstStyle/>
           <a:p>
             <a:r>
-              <a:rPr lang="en-US" dirty="0"/>
-              <a:t>To summarize the exploratory analysis: the dataset has severe class imbalance, highly variable transcription length, a very high-dimensional and noisy vocabulary dominated by generic clinical documentation words, a keywords field too sparse to use directly, and it demands multi-metric evaluation rather than relying on plain accuracy. Every one of these findings directly shapes a design decision later in the project — from stratified splitting, to TF-IDF weighting, to choosing an ensemble of diverse classifiers, to the evaluation metrics I will report.</a:t>
-            </a:r>
-            <a:endParaRPr lang="en-US" dirty="0"/>
+              <a:t>[FORMAL PRESENTATION SCRIPT]</a:t>
+            </a:r>
+          </a:p>
+          <a:p>
+            <a:r>
+              <a:t>Slide 10 synthesizes the four key insights derived from our exploratory data analysis that directly dictate our preprocessing, feature engineering, and modeling strategies.</a:t>
+            </a:r>
+          </a:p>
+          <a:p/>
+          <a:p>
+            <a:r>
+              <a:t>[FOUR CORE CONCLUSIONS]</a:t>
+            </a:r>
+          </a:p>
+          <a:p>
+            <a:r>
+              <a:t>1. Severe Class Imbalance (1,103 vs. 2 records):</a:t>
+            </a:r>
+          </a:p>
+          <a:p>
+            <a:r>
+              <a:t>   - Strategy: Mandatory stratified 80:20 data splitting, balanced cost-sensitive sample weighting, and ensemble voting to prevent majority class bias.</a:t>
+            </a:r>
+          </a:p>
+          <a:p>
+            <a:r>
+              <a:t>2. Variable Text Length (200 to 3,000 words):</a:t>
+            </a:r>
+          </a:p>
+          <a:p>
+            <a:r>
+              <a:t>   - Strategy: Sublinear TF scaling (1 + log(TF)) to dampen high-frequency repetition, paired with document-level L2 vector normalization.</a:t>
+            </a:r>
+          </a:p>
+          <a:p>
+            <a:r>
+              <a:t>3. High-Dimensional Text Vocabulary:</a:t>
+            </a:r>
+          </a:p>
+          <a:p>
+            <a:r>
+              <a:t>   - Strategy: Set minimum document frequency (`min_df=3`) to eliminate single-occurrence spelling noise, and maximum document frequency (`max_df=0.85`) to exclude ubiquitous words, capturing unigrams and bigrams.</a:t>
+            </a:r>
+          </a:p>
+          <a:p>
+            <a:r>
+              <a:t>4. Generic Documentation Noise:</a:t>
+            </a:r>
+          </a:p>
+          <a:p>
+            <a:r>
+              <a:t>   - Strategy: Combine NLTK standard English stopwords with clinical-specific boilerplate tokens, followed by WordNet morphological lemmatization.</a:t>
+            </a:r>
+          </a:p>
+          <a:p>
+            <a:r>
+              <a:t>5. Evaluation Metric: Overall accuracy alone is deceptive under severe imbalance; model success will be evaluated using Macro-averaged Precision, Recall, and F1-Score.</a:t>
+            </a:r>
+          </a:p>
+          <a:p/>
+          <a:p>
+            <a:r>
+              <a:t>[TRANSITION TO NEXT SLIDE]</a:t>
+            </a:r>
+          </a:p>
+          <a:p>
+            <a:r>
+              <a:t>On Slide 11, we examine the pre-processed dataset structure ready for machine learning.</a:t>
+            </a:r>
           </a:p>
         </p:txBody>
       </p:sp>

</xml_diff>